<commit_message>
Prepare v0.1 technical preview launch
</commit_message>
<xml_diff>
--- a/docs/PurposeMesh-Executive-Architecture-Briefing.pptx
+++ b/docs/PurposeMesh-Executive-Architecture-Briefing.pptx
@@ -2,26 +2,27 @@
 <file path=ppt/presentation.xml><?xml version="1.0" encoding="utf-8"?>
 <p:presentation xmlns:p="http://schemas.openxmlformats.org/presentationml/2006/main">
   <p:sldMasterIdLst>
-    <p:sldMasterId xmlns:r="http://schemas.openxmlformats.org/officeDocument/2006/relationships" id="2147483648" r:id="R8bfa5b3defd04f9f"/>
+    <p:sldMasterId xmlns:r="http://schemas.openxmlformats.org/officeDocument/2006/relationships" id="2147483648" r:id="Rd812c8a17f874f7e"/>
   </p:sldMasterIdLst>
   <p:notesMasterIdLst>
-    <p:notesMasterId xmlns:r="http://schemas.openxmlformats.org/officeDocument/2006/relationships" r:id="Rd2e0ae57f2ae4a40"/>
+    <p:notesMasterId xmlns:r="http://schemas.openxmlformats.org/officeDocument/2006/relationships" r:id="Ra8efcc42d47d4d66"/>
   </p:notesMasterIdLst>
   <p:sldIdLst>
-    <p:sldId xmlns:r="http://schemas.openxmlformats.org/officeDocument/2006/relationships" id="256" r:id="Rc04614bb3e7648b3"/>
-    <p:sldId xmlns:r="http://schemas.openxmlformats.org/officeDocument/2006/relationships" id="257" r:id="R7247a06aa22d4364"/>
-    <p:sldId xmlns:r="http://schemas.openxmlformats.org/officeDocument/2006/relationships" id="258" r:id="R4514b02258f04ec7"/>
-    <p:sldId xmlns:r="http://schemas.openxmlformats.org/officeDocument/2006/relationships" id="259" r:id="R76ffd7c16b3f4c6b"/>
-    <p:sldId xmlns:r="http://schemas.openxmlformats.org/officeDocument/2006/relationships" id="260" r:id="Ra31b30669880468b"/>
-    <p:sldId xmlns:r="http://schemas.openxmlformats.org/officeDocument/2006/relationships" id="261" r:id="Re329eb6f4c0b42d3"/>
-    <p:sldId xmlns:r="http://schemas.openxmlformats.org/officeDocument/2006/relationships" id="262" r:id="R426c01a2281a40be"/>
-    <p:sldId xmlns:r="http://schemas.openxmlformats.org/officeDocument/2006/relationships" id="263" r:id="R7be70ffc3ff9499d"/>
-    <p:sldId xmlns:r="http://schemas.openxmlformats.org/officeDocument/2006/relationships" id="264" r:id="R1e27cb89b1a345b1"/>
-    <p:sldId xmlns:r="http://schemas.openxmlformats.org/officeDocument/2006/relationships" id="265" r:id="R49b8067c803e49df"/>
-    <p:sldId xmlns:r="http://schemas.openxmlformats.org/officeDocument/2006/relationships" id="266" r:id="R5075fb8a9a2642b3"/>
-    <p:sldId xmlns:r="http://schemas.openxmlformats.org/officeDocument/2006/relationships" id="267" r:id="Rb20494efcc18403c"/>
-    <p:sldId xmlns:r="http://schemas.openxmlformats.org/officeDocument/2006/relationships" id="268" r:id="R2c34c830812b4532"/>
-    <p:sldId xmlns:r="http://schemas.openxmlformats.org/officeDocument/2006/relationships" id="269" r:id="R53e039efa75c4069"/>
+    <p:sldId xmlns:r="http://schemas.openxmlformats.org/officeDocument/2006/relationships" id="256" r:id="R59f99f9b9d74458c"/>
+    <p:sldId xmlns:r="http://schemas.openxmlformats.org/officeDocument/2006/relationships" id="257" r:id="R85b198de23c44b9d"/>
+    <p:sldId xmlns:r="http://schemas.openxmlformats.org/officeDocument/2006/relationships" id="258" r:id="Rc1ff14263ac246ba"/>
+    <p:sldId xmlns:r="http://schemas.openxmlformats.org/officeDocument/2006/relationships" id="259" r:id="R6c2fd270de104a56"/>
+    <p:sldId xmlns:r="http://schemas.openxmlformats.org/officeDocument/2006/relationships" id="260" r:id="R4c326b048f784915"/>
+    <p:sldId xmlns:r="http://schemas.openxmlformats.org/officeDocument/2006/relationships" id="261" r:id="Ra26eca051f324db7"/>
+    <p:sldId xmlns:r="http://schemas.openxmlformats.org/officeDocument/2006/relationships" id="262" r:id="Rdf18d1ae66ed4eb7"/>
+    <p:sldId xmlns:r="http://schemas.openxmlformats.org/officeDocument/2006/relationships" id="263" r:id="Rcb4b1b9e2e224f3d"/>
+    <p:sldId xmlns:r="http://schemas.openxmlformats.org/officeDocument/2006/relationships" id="264" r:id="Ra692555593f241e8"/>
+    <p:sldId xmlns:r="http://schemas.openxmlformats.org/officeDocument/2006/relationships" id="265" r:id="R659d0fb7cd564ec5"/>
+    <p:sldId xmlns:r="http://schemas.openxmlformats.org/officeDocument/2006/relationships" id="266" r:id="R3529bd9c7b1f4fd8"/>
+    <p:sldId xmlns:r="http://schemas.openxmlformats.org/officeDocument/2006/relationships" id="267" r:id="R4058226cd6c54b76"/>
+    <p:sldId xmlns:r="http://schemas.openxmlformats.org/officeDocument/2006/relationships" id="268" r:id="R01718c7d87bc4368"/>
+    <p:sldId xmlns:r="http://schemas.openxmlformats.org/officeDocument/2006/relationships" id="269" r:id="R2dd46d7186cb4ab9"/>
+    <p:sldId xmlns:r="http://schemas.openxmlformats.org/officeDocument/2006/relationships" id="270" r:id="R5eb1822fd8a0425a"/>
   </p:sldIdLst>
   <p:sldSz cx="12192000" cy="6858000"/>
   <p:notesSz cx="6858000" cy="9144000"/>
@@ -1030,6 +1031,86 @@
 </p:notes>
 </file>
 
+<file path=ppt/notesSlides/notesSlide15.xml><?xml version="1.0" encoding="utf-8"?>
+<p:notes xmlns:p="http://schemas.openxmlformats.org/presentationml/2006/main">
+  <p:cSld>
+    <p:spTree>
+      <p:nvGrpSpPr>
+        <p:cNvPr id="1" name=""/>
+        <p:cNvGrpSpPr/>
+        <p:nvPr/>
+      </p:nvGrpSpPr>
+      <p:grpSpPr>
+        <a:xfrm xmlns:a="http://schemas.openxmlformats.org/drawingml/2006/main"/>
+      </p:grpSpPr>
+      <p:sp>
+        <p:nvSpPr>
+          <p:cNvPr id="2" name="Slide Image Placeholder 1"/>
+          <p:cNvSpPr>
+            <a:spLocks xmlns:a="http://schemas.openxmlformats.org/drawingml/2006/main" noGrp="1"/>
+          </p:cNvSpPr>
+          <p:nvPr>
+            <p:ph type="sldImg" idx="0"/>
+          </p:nvPr>
+        </p:nvSpPr>
+        <p:spPr/>
+      </p:sp>
+      <p:sp>
+        <p:nvSpPr>
+          <p:cNvPr id="3" name="Notes Placeholder 2"/>
+          <p:cNvSpPr>
+            <a:spLocks xmlns:a="http://schemas.openxmlformats.org/drawingml/2006/main" noGrp="1"/>
+          </p:cNvSpPr>
+          <p:nvPr>
+            <p:ph type="body" idx="1"/>
+          </p:nvPr>
+        </p:nvSpPr>
+        <p:spPr/>
+        <p:txBody>
+          <a:bodyPr xmlns:a="http://schemas.openxmlformats.org/drawingml/2006/main"/>
+          <a:lstStyle xmlns:a="http://schemas.openxmlformats.org/drawingml/2006/main"/>
+          <a:p xmlns:a="http://schemas.openxmlformats.org/drawingml/2006/main">
+            <a:r>
+              <a:t>[Sources]</a:t>
+            </a:r>
+          </a:p>
+          <a:p xmlns:a="http://schemas.openxmlformats.org/drawingml/2006/main">
+            <a:r>
+              <a:t>- https://openid.net/specs/authorization-api-1_0-final.html — AuthZEN Authorization API 1.0 final specification (accessed 16 August 2026).</a:t>
+            </a:r>
+          </a:p>
+          <a:p xmlns:a="http://schemas.openxmlformats.org/drawingml/2006/main">
+            <a:r>
+              <a:t>[/Sources]</a:t>
+            </a:r>
+          </a:p>
+        </p:txBody>
+      </p:sp>
+      <p:sp>
+        <p:nvSpPr>
+          <p:cNvPr id="4" name="Slide Number Placeholder 3"/>
+          <p:cNvSpPr>
+            <a:spLocks xmlns:a="http://schemas.openxmlformats.org/drawingml/2006/main" noGrp="1"/>
+          </p:cNvSpPr>
+          <p:nvPr>
+            <p:ph type="sldNum" idx="5"/>
+          </p:nvPr>
+        </p:nvSpPr>
+        <p:spPr/>
+        <p:txBody>
+          <a:bodyPr xmlns:a="http://schemas.openxmlformats.org/drawingml/2006/main"/>
+          <a:lstStyle xmlns:a="http://schemas.openxmlformats.org/drawingml/2006/main"/>
+          <a:p xmlns:a="http://schemas.openxmlformats.org/drawingml/2006/main"/>
+        </p:txBody>
+      </p:sp>
+    </p:spTree>
+  </p:cSld>
+  <p:clrMapOvr>
+    <a:masterClrMapping xmlns:a="http://schemas.openxmlformats.org/drawingml/2006/main"/>
+  </p:clrMapOvr>
+</p:notes>
+</file>
+
 <file path=ppt/notesSlides/notesSlide2.xml><?xml version="1.0" encoding="utf-8"?>
 <p:notes xmlns:p="http://schemas.openxmlformats.org/presentationml/2006/main">
   <p:cSld>
@@ -1858,7 +1939,7 @@
   </p:cSld>
   <p:clrMap bg1="lt1" tx1="dk1" bg2="lt2" tx2="dk2" accent1="accent1" accent2="accent2" accent3="accent3" accent4="accent4" accent5="accent5" accent6="accent6" hlink="hlink" folHlink="folHlink"/>
   <p:sldLayoutIdLst>
-    <p:sldLayoutId xmlns:r="http://schemas.openxmlformats.org/officeDocument/2006/relationships" id="2147483649" r:id="R015d4eed44b445fc"/>
+    <p:sldLayoutId xmlns:r="http://schemas.openxmlformats.org/officeDocument/2006/relationships" id="2147483649" r:id="Rdaf115554f1f43e8"/>
   </p:sldLayoutIdLst>
   <p:txStyles>
     <p:titleStyle>
@@ -10088,7 +10169,1784 @@
                 <a:ea typeface="Aptos"/>
                 <a:cs typeface="Aptos"/>
               </a:rPr>
-              <a:t>One dataset + purpose, two personas, one connector. Scale only after allow/deny, read-back, drift, identity, and recovery pass.</a:t>
+              <a:t>Pilot one dataset and connector; scale after read-back, drift, and recovery pass.</a:t>
+            </a:r>
+          </a:p>
+        </p:txBody>
+      </p:sp>
+      <p:sp>
+        <p:nvSpPr>
+          <p:cNvPr id="35" name="brand-9">
+            <a:extLst xmlns:a="http://schemas.openxmlformats.org/drawingml/2006/main">
+              <a:ext uri="{FF2B5EF4-FFF2-40B4-BE49-F238E27FC236}">
+                <a16:creationId xmlns:a16="http://schemas.microsoft.com/office/drawing/2014/main" id="{B112E3BB-DFB7-4F02-91C9-347E1094D734}"/>
+              </a:ext>
+            </a:extLst>
+          </p:cNvPr>
+          <p:cNvSpPr>
+            <a:spLocks xmlns:a="http://schemas.openxmlformats.org/drawingml/2006/main" noGrp="1"/>
+          </p:cNvSpPr>
+          <p:nvPr/>
+        </p:nvSpPr>
+        <p:spPr>
+          <a:xfrm xmlns:a="http://schemas.openxmlformats.org/drawingml/2006/main">
+            <a:off x="609600" y="266700"/>
+            <a:ext cx="1257300" cy="247650"/>
+          </a:xfrm>
+          <a:prstGeom xmlns:a="http://schemas.openxmlformats.org/drawingml/2006/main" prst="rect">
+            <a:avLst/>
+          </a:prstGeom>
+          <a:noFill xmlns:a="http://schemas.openxmlformats.org/drawingml/2006/main"/>
+          <a:ln xmlns:a="http://schemas.openxmlformats.org/drawingml/2006/main" w="0">
+            <a:noFill/>
+            <a:prstDash val="solid"/>
+          </a:ln>
+        </p:spPr>
+        <p:txBody>
+          <a:bodyPr xmlns:a="http://schemas.openxmlformats.org/drawingml/2006/main" wrap="square" lIns="0" tIns="0" rIns="0" bIns="0" anchor="t">
+            <a:normAutofit fontScale="100000"/>
+          </a:bodyPr>
+          <a:lstStyle xmlns:a="http://schemas.openxmlformats.org/drawingml/2006/main"/>
+          <a:p xmlns:a="http://schemas.openxmlformats.org/drawingml/2006/main">
+            <a:pPr algn="l">
+              <a:lnSpc>
+                <a:spcPct val="108000"/>
+              </a:lnSpc>
+              <a:buNone/>
+              <a:defRPr sz="1350" b="1">
+                <a:solidFill>
+                  <a:srgbClr val="2DD4BF"/>
+                </a:solidFill>
+                <a:latin typeface="Aptos"/>
+                <a:ea typeface="Aptos"/>
+                <a:cs typeface="Aptos"/>
+              </a:defRPr>
+            </a:pPr>
+            <a:r>
+              <a:rPr sz="1050" b="1">
+                <a:solidFill>
+                  <a:srgbClr val="2DD4BF"/>
+                </a:solidFill>
+                <a:latin typeface="Aptos"/>
+                <a:ea typeface="Aptos"/>
+                <a:cs typeface="Aptos"/>
+              </a:rPr>
+              <a:t>PurposeMesh</a:t>
+            </a:r>
+          </a:p>
+        </p:txBody>
+      </p:sp>
+    </p:spTree>
+    <p:extLst>
+      <p:ext uri="{BB962C8B-B14F-4D97-AF65-F5344CB8AC3E}">
+        <p14:creationId xmlns:p14="http://schemas.microsoft.com/office/powerpoint/2010/main" val="1391688617"/>
+      </p:ext>
+    </p:extLst>
+  </p:cSld>
+</p:sld>
+</file>
+
+<file path=ppt/slides/slide15.xml><?xml version="1.0" encoding="utf-8"?>
+<p:sld xmlns:p="http://schemas.openxmlformats.org/presentationml/2006/main">
+  <p:cSld>
+    <p:bg>
+      <p:bgPr>
+        <a:solidFill xmlns:a="http://schemas.openxmlformats.org/drawingml/2006/main">
+          <a:srgbClr val="071014"/>
+        </a:solidFill>
+      </p:bgPr>
+    </p:bg>
+    <p:spTree>
+      <p:nvGrpSpPr>
+        <p:cNvPr id="1" name=""/>
+        <p:cNvGrpSpPr/>
+        <p:nvPr/>
+      </p:nvGrpSpPr>
+      <p:grpSpPr>
+        <a:xfrm xmlns:a="http://schemas.openxmlformats.org/drawingml/2006/main"/>
+      </p:grpSpPr>
+      <p:sp>
+        <p:nvSpPr>
+          <p:cNvPr id="36" name="title-9">
+            <a:extLst xmlns:a="http://schemas.openxmlformats.org/drawingml/2006/main">
+              <a:ext uri="{FF2B5EF4-FFF2-40B4-BE49-F238E27FC236}">
+                <a16:creationId xmlns:a16="http://schemas.microsoft.com/office/drawing/2014/main" id="{4C73BD00-A2DE-49B5-BAFA-99C4ADF5BE23}"/>
+              </a:ext>
+            </a:extLst>
+          </p:cNvPr>
+          <p:cNvSpPr>
+            <a:spLocks xmlns:a="http://schemas.openxmlformats.org/drawingml/2006/main" noGrp="1"/>
+          </p:cNvSpPr>
+          <p:nvPr/>
+        </p:nvSpPr>
+        <p:spPr>
+          <a:xfrm xmlns:a="http://schemas.openxmlformats.org/drawingml/2006/main">
+            <a:off x="609600" y="723900"/>
+            <a:ext cx="10972800" cy="647700"/>
+          </a:xfrm>
+          <a:prstGeom xmlns:a="http://schemas.openxmlformats.org/drawingml/2006/main" prst="rect">
+            <a:avLst/>
+          </a:prstGeom>
+          <a:noFill xmlns:a="http://schemas.openxmlformats.org/drawingml/2006/main"/>
+          <a:ln xmlns:a="http://schemas.openxmlformats.org/drawingml/2006/main" w="0">
+            <a:noFill/>
+            <a:prstDash val="solid"/>
+          </a:ln>
+        </p:spPr>
+        <p:txBody>
+          <a:bodyPr xmlns:a="http://schemas.openxmlformats.org/drawingml/2006/main" wrap="square" lIns="0" tIns="0" rIns="0" bIns="0" anchor="t">
+            <a:noAutofit/>
+          </a:bodyPr>
+          <a:lstStyle xmlns:a="http://schemas.openxmlformats.org/drawingml/2006/main"/>
+          <a:p xmlns:a="http://schemas.openxmlformats.org/drawingml/2006/main">
+            <a:pPr algn="l">
+              <a:lnSpc>
+                <a:spcPct val="96000"/>
+              </a:lnSpc>
+              <a:buNone/>
+              <a:defRPr sz="3750" b="1">
+                <a:solidFill>
+                  <a:srgbClr val="EDF6F7"/>
+                </a:solidFill>
+                <a:latin typeface="Aptos"/>
+                <a:ea typeface="Aptos"/>
+                <a:cs typeface="Aptos"/>
+              </a:defRPr>
+            </a:pPr>
+            <a:r>
+              <a:rPr sz="3750" b="1">
+                <a:solidFill>
+                  <a:srgbClr val="EDF6F7"/>
+                </a:solidFill>
+                <a:latin typeface="Aptos"/>
+                <a:ea typeface="Aptos"/>
+                <a:cs typeface="Aptos"/>
+              </a:rPr>
+              <a:t>Roadmap: prove enforcement, then expand</a:t>
+            </a:r>
+          </a:p>
+        </p:txBody>
+      </p:sp>
+      <p:sp>
+        <p:nvSpPr>
+          <p:cNvPr id="2" name="subtitle-9">
+            <a:extLst xmlns:a="http://schemas.openxmlformats.org/drawingml/2006/main">
+              <a:ext uri="{FF2B5EF4-FFF2-40B4-BE49-F238E27FC236}">
+                <a16:creationId xmlns:a16="http://schemas.microsoft.com/office/drawing/2014/main" id="{416668E3-A93D-4622-A2D8-11C1608AF9D2}"/>
+              </a:ext>
+            </a:extLst>
+          </p:cNvPr>
+          <p:cNvSpPr>
+            <a:spLocks xmlns:a="http://schemas.openxmlformats.org/drawingml/2006/main" noGrp="1"/>
+          </p:cNvSpPr>
+          <p:nvPr/>
+        </p:nvSpPr>
+        <p:spPr>
+          <a:xfrm xmlns:a="http://schemas.openxmlformats.org/drawingml/2006/main">
+            <a:off x="609600" y="1466850"/>
+            <a:ext cx="10001250" cy="552450"/>
+          </a:xfrm>
+          <a:prstGeom xmlns:a="http://schemas.openxmlformats.org/drawingml/2006/main" prst="rect">
+            <a:avLst/>
+          </a:prstGeom>
+          <a:noFill xmlns:a="http://schemas.openxmlformats.org/drawingml/2006/main"/>
+          <a:ln xmlns:a="http://schemas.openxmlformats.org/drawingml/2006/main" w="0">
+            <a:noFill/>
+            <a:prstDash val="solid"/>
+          </a:ln>
+        </p:spPr>
+        <p:txBody>
+          <a:bodyPr xmlns:a="http://schemas.openxmlformats.org/drawingml/2006/main" wrap="square" lIns="0" tIns="0" rIns="0" bIns="0" anchor="t">
+            <a:noAutofit/>
+          </a:bodyPr>
+          <a:lstStyle xmlns:a="http://schemas.openxmlformats.org/drawingml/2006/main"/>
+          <a:p xmlns:a="http://schemas.openxmlformats.org/drawingml/2006/main">
+            <a:pPr algn="l">
+              <a:lnSpc>
+                <a:spcPct val="115000"/>
+              </a:lnSpc>
+              <a:buNone/>
+              <a:defRPr sz="1650" b="0">
+                <a:solidFill>
+                  <a:srgbClr val="9CB0B5"/>
+                </a:solidFill>
+                <a:latin typeface="Aptos"/>
+                <a:ea typeface="Aptos"/>
+                <a:cs typeface="Aptos"/>
+              </a:defRPr>
+            </a:pPr>
+            <a:r>
+              <a:rPr sz="1650" b="0">
+                <a:solidFill>
+                  <a:srgbClr val="9CB0B5"/>
+                </a:solidFill>
+                <a:latin typeface="Aptos"/>
+                <a:ea typeface="Aptos"/>
+                <a:cs typeface="Aptos"/>
+              </a:rPr>
+              <a:t>Trust grows in stages: reproducible local proof, one certified target, then scale.</a:t>
+            </a:r>
+          </a:p>
+        </p:txBody>
+      </p:sp>
+      <p:sp>
+        <p:nvSpPr>
+          <p:cNvPr id="3" name="top-accent-9">
+            <a:extLst xmlns:a="http://schemas.openxmlformats.org/drawingml/2006/main">
+              <a:ext uri="{FF2B5EF4-FFF2-40B4-BE49-F238E27FC236}">
+                <a16:creationId xmlns:a16="http://schemas.microsoft.com/office/drawing/2014/main" id="{FB18E914-8A72-4C23-83DC-83667C1A3D05}"/>
+              </a:ext>
+            </a:extLst>
+          </p:cNvPr>
+          <p:cNvSpPr>
+            <a:spLocks xmlns:a="http://schemas.openxmlformats.org/drawingml/2006/main" noGrp="1"/>
+          </p:cNvSpPr>
+          <p:nvPr/>
+        </p:nvSpPr>
+        <p:spPr>
+          <a:xfrm xmlns:a="http://schemas.openxmlformats.org/drawingml/2006/main">
+            <a:off x="0" y="0"/>
+            <a:ext cx="12192000" cy="38100"/>
+          </a:xfrm>
+          <a:prstGeom xmlns:a="http://schemas.openxmlformats.org/drawingml/2006/main" prst="roundRect">
+            <a:avLst>
+              <a:gd name="adj" fmla="val 50000"/>
+            </a:avLst>
+          </a:prstGeom>
+          <a:solidFill xmlns:a="http://schemas.openxmlformats.org/drawingml/2006/main">
+            <a:srgbClr val="2DD4BF"/>
+          </a:solidFill>
+          <a:ln xmlns:a="http://schemas.openxmlformats.org/drawingml/2006/main" w="0">
+            <a:noFill/>
+            <a:prstDash val="solid"/>
+          </a:ln>
+        </p:spPr>
+      </p:sp>
+      <p:sp>
+        <p:nvSpPr>
+          <p:cNvPr id="4" name="section-9">
+            <a:extLst xmlns:a="http://schemas.openxmlformats.org/drawingml/2006/main">
+              <a:ext uri="{FF2B5EF4-FFF2-40B4-BE49-F238E27FC236}">
+                <a16:creationId xmlns:a16="http://schemas.microsoft.com/office/drawing/2014/main" id="{F4C91E87-BD8A-44C4-9A25-AC3C3AC68431}"/>
+              </a:ext>
+            </a:extLst>
+          </p:cNvPr>
+          <p:cNvSpPr>
+            <a:spLocks xmlns:a="http://schemas.openxmlformats.org/drawingml/2006/main" noGrp="1"/>
+          </p:cNvSpPr>
+          <p:nvPr/>
+        </p:nvSpPr>
+        <p:spPr>
+          <a:xfrm xmlns:a="http://schemas.openxmlformats.org/drawingml/2006/main">
+            <a:off x="1619250" y="285750"/>
+            <a:ext cx="6858000" cy="209550"/>
+          </a:xfrm>
+          <a:prstGeom xmlns:a="http://schemas.openxmlformats.org/drawingml/2006/main" prst="rect">
+            <a:avLst/>
+          </a:prstGeom>
+          <a:noFill xmlns:a="http://schemas.openxmlformats.org/drawingml/2006/main"/>
+          <a:ln xmlns:a="http://schemas.openxmlformats.org/drawingml/2006/main" w="0">
+            <a:noFill/>
+            <a:prstDash val="solid"/>
+          </a:ln>
+        </p:spPr>
+        <p:txBody>
+          <a:bodyPr xmlns:a="http://schemas.openxmlformats.org/drawingml/2006/main" wrap="square" lIns="0" tIns="0" rIns="0" bIns="0" anchor="t">
+            <a:noAutofit/>
+          </a:bodyPr>
+          <a:lstStyle xmlns:a="http://schemas.openxmlformats.org/drawingml/2006/main"/>
+          <a:p xmlns:a="http://schemas.openxmlformats.org/drawingml/2006/main">
+            <a:pPr algn="l">
+              <a:lnSpc>
+                <a:spcPct val="108000"/>
+              </a:lnSpc>
+              <a:buNone/>
+              <a:defRPr sz="1050" b="1">
+                <a:solidFill>
+                  <a:srgbClr val="6F858B"/>
+                </a:solidFill>
+                <a:latin typeface="Aptos"/>
+                <a:ea typeface="Aptos"/>
+                <a:cs typeface="Aptos"/>
+              </a:defRPr>
+            </a:pPr>
+            <a:r>
+              <a:rPr sz="1050" b="1">
+                <a:solidFill>
+                  <a:srgbClr val="6F858B"/>
+                </a:solidFill>
+                <a:latin typeface="Aptos"/>
+                <a:ea typeface="Aptos"/>
+                <a:cs typeface="Aptos"/>
+              </a:rPr>
+              <a:t>PUBLIC ROADMAP</a:t>
+            </a:r>
+          </a:p>
+        </p:txBody>
+      </p:sp>
+      <p:sp>
+        <p:nvSpPr>
+          <p:cNvPr id="5" name="page-9">
+            <a:extLst xmlns:a="http://schemas.openxmlformats.org/drawingml/2006/main">
+              <a:ext uri="{FF2B5EF4-FFF2-40B4-BE49-F238E27FC236}">
+                <a16:creationId xmlns:a16="http://schemas.microsoft.com/office/drawing/2014/main" id="{BF242CCA-07DF-4B74-9D95-10AD31EA3FA7}"/>
+              </a:ext>
+            </a:extLst>
+          </p:cNvPr>
+          <p:cNvSpPr>
+            <a:spLocks xmlns:a="http://schemas.openxmlformats.org/drawingml/2006/main" noGrp="1"/>
+          </p:cNvSpPr>
+          <p:nvPr/>
+        </p:nvSpPr>
+        <p:spPr>
+          <a:xfrm xmlns:a="http://schemas.openxmlformats.org/drawingml/2006/main">
+            <a:off x="11049000" y="285750"/>
+            <a:ext cx="533400" cy="209550"/>
+          </a:xfrm>
+          <a:prstGeom xmlns:a="http://schemas.openxmlformats.org/drawingml/2006/main" prst="rect">
+            <a:avLst/>
+          </a:prstGeom>
+          <a:noFill xmlns:a="http://schemas.openxmlformats.org/drawingml/2006/main"/>
+          <a:ln xmlns:a="http://schemas.openxmlformats.org/drawingml/2006/main" w="0">
+            <a:noFill/>
+            <a:prstDash val="solid"/>
+          </a:ln>
+        </p:spPr>
+        <p:txBody>
+          <a:bodyPr xmlns:a="http://schemas.openxmlformats.org/drawingml/2006/main" wrap="square" lIns="0" tIns="0" rIns="0" bIns="0" anchor="t">
+            <a:noAutofit/>
+          </a:bodyPr>
+          <a:lstStyle xmlns:a="http://schemas.openxmlformats.org/drawingml/2006/main"/>
+          <a:p xmlns:a="http://schemas.openxmlformats.org/drawingml/2006/main">
+            <a:pPr algn="r">
+              <a:lnSpc>
+                <a:spcPct val="108000"/>
+              </a:lnSpc>
+              <a:buNone/>
+              <a:defRPr sz="1050" b="1">
+                <a:solidFill>
+                  <a:srgbClr val="6F858B"/>
+                </a:solidFill>
+                <a:latin typeface="Aptos"/>
+                <a:ea typeface="Aptos"/>
+                <a:cs typeface="Aptos"/>
+              </a:defRPr>
+            </a:pPr>
+            <a:r>
+              <a:rPr sz="1050" b="1">
+                <a:solidFill>
+                  <a:srgbClr val="6F858B"/>
+                </a:solidFill>
+                <a:latin typeface="Aptos"/>
+                <a:ea typeface="Aptos"/>
+                <a:cs typeface="Aptos"/>
+              </a:rPr>
+              <a:t>15</a:t>
+            </a:r>
+          </a:p>
+        </p:txBody>
+      </p:sp>
+      <p:sp>
+        <p:nvSpPr>
+          <p:cNvPr id="6" name="decision-accent-0">
+            <a:extLst xmlns:a="http://schemas.openxmlformats.org/drawingml/2006/main">
+              <a:ext uri="{FF2B5EF4-FFF2-40B4-BE49-F238E27FC236}">
+                <a16:creationId xmlns:a16="http://schemas.microsoft.com/office/drawing/2014/main" id="{57800E63-16B5-445A-A654-FD9DFBC7E3FA}"/>
+              </a:ext>
+            </a:extLst>
+          </p:cNvPr>
+          <p:cNvSpPr>
+            <a:spLocks xmlns:a="http://schemas.openxmlformats.org/drawingml/2006/main" noGrp="1"/>
+          </p:cNvSpPr>
+          <p:nvPr/>
+        </p:nvSpPr>
+        <p:spPr>
+          <a:xfrm xmlns:a="http://schemas.openxmlformats.org/drawingml/2006/main">
+            <a:off x="609600" y="2343150"/>
+            <a:ext cx="3143250" cy="38100"/>
+          </a:xfrm>
+          <a:prstGeom xmlns:a="http://schemas.openxmlformats.org/drawingml/2006/main" prst="roundRect">
+            <a:avLst>
+              <a:gd name="adj" fmla="val 50000"/>
+            </a:avLst>
+          </a:prstGeom>
+          <a:solidFill xmlns:a="http://schemas.openxmlformats.org/drawingml/2006/main">
+            <a:srgbClr val="38BDF8"/>
+          </a:solidFill>
+          <a:ln xmlns:a="http://schemas.openxmlformats.org/drawingml/2006/main" w="0">
+            <a:noFill/>
+            <a:prstDash val="solid"/>
+          </a:ln>
+        </p:spPr>
+      </p:sp>
+      <p:sp>
+        <p:nvSpPr>
+          <p:cNvPr id="7" name="decision-label-0">
+            <a:extLst xmlns:a="http://schemas.openxmlformats.org/drawingml/2006/main">
+              <a:ext uri="{FF2B5EF4-FFF2-40B4-BE49-F238E27FC236}">
+                <a16:creationId xmlns:a16="http://schemas.microsoft.com/office/drawing/2014/main" id="{22491B48-158F-4650-ADB1-D9724C10B79F}"/>
+              </a:ext>
+            </a:extLst>
+          </p:cNvPr>
+          <p:cNvSpPr>
+            <a:spLocks xmlns:a="http://schemas.openxmlformats.org/drawingml/2006/main" noGrp="1"/>
+          </p:cNvSpPr>
+          <p:nvPr/>
+        </p:nvSpPr>
+        <p:spPr>
+          <a:xfrm xmlns:a="http://schemas.openxmlformats.org/drawingml/2006/main">
+            <a:off x="609600" y="2647950"/>
+            <a:ext cx="2381250" cy="209550"/>
+          </a:xfrm>
+          <a:prstGeom xmlns:a="http://schemas.openxmlformats.org/drawingml/2006/main" prst="rect">
+            <a:avLst/>
+          </a:prstGeom>
+          <a:noFill xmlns:a="http://schemas.openxmlformats.org/drawingml/2006/main"/>
+          <a:ln xmlns:a="http://schemas.openxmlformats.org/drawingml/2006/main" w="0">
+            <a:noFill/>
+            <a:prstDash val="solid"/>
+          </a:ln>
+        </p:spPr>
+        <p:txBody>
+          <a:bodyPr xmlns:a="http://schemas.openxmlformats.org/drawingml/2006/main" wrap="square" lIns="0" tIns="0" rIns="0" bIns="0" anchor="t">
+            <a:noAutofit/>
+          </a:bodyPr>
+          <a:lstStyle xmlns:a="http://schemas.openxmlformats.org/drawingml/2006/main"/>
+          <a:p xmlns:a="http://schemas.openxmlformats.org/drawingml/2006/main">
+            <a:pPr algn="l">
+              <a:lnSpc>
+                <a:spcPct val="108000"/>
+              </a:lnSpc>
+              <a:buNone/>
+              <a:defRPr sz="1050" b="1">
+                <a:solidFill>
+                  <a:srgbClr val="38BDF8"/>
+                </a:solidFill>
+                <a:latin typeface="Aptos"/>
+                <a:ea typeface="Aptos"/>
+                <a:cs typeface="Aptos"/>
+              </a:defRPr>
+            </a:pPr>
+            <a:r>
+              <a:rPr sz="1050" b="1">
+                <a:solidFill>
+                  <a:srgbClr val="38BDF8"/>
+                </a:solidFill>
+                <a:latin typeface="Aptos"/>
+                <a:ea typeface="Aptos"/>
+                <a:cs typeface="Aptos"/>
+              </a:rPr>
+              <a:t>NOW · v0.1</a:t>
+            </a:r>
+          </a:p>
+        </p:txBody>
+      </p:sp>
+      <p:sp>
+        <p:nvSpPr>
+          <p:cNvPr id="8" name="decision-title-0">
+            <a:extLst xmlns:a="http://schemas.openxmlformats.org/drawingml/2006/main">
+              <a:ext uri="{FF2B5EF4-FFF2-40B4-BE49-F238E27FC236}">
+                <a16:creationId xmlns:a16="http://schemas.microsoft.com/office/drawing/2014/main" id="{D13498F6-3376-4090-A387-60CA829307DF}"/>
+              </a:ext>
+            </a:extLst>
+          </p:cNvPr>
+          <p:cNvSpPr>
+            <a:spLocks xmlns:a="http://schemas.openxmlformats.org/drawingml/2006/main" noGrp="1"/>
+          </p:cNvSpPr>
+          <p:nvPr/>
+        </p:nvSpPr>
+        <p:spPr>
+          <a:xfrm xmlns:a="http://schemas.openxmlformats.org/drawingml/2006/main">
+            <a:off x="609600" y="3048000"/>
+            <a:ext cx="3143250" cy="400050"/>
+          </a:xfrm>
+          <a:prstGeom xmlns:a="http://schemas.openxmlformats.org/drawingml/2006/main" prst="rect">
+            <a:avLst/>
+          </a:prstGeom>
+          <a:noFill xmlns:a="http://schemas.openxmlformats.org/drawingml/2006/main"/>
+          <a:ln xmlns:a="http://schemas.openxmlformats.org/drawingml/2006/main" w="0">
+            <a:noFill/>
+            <a:prstDash val="solid"/>
+          </a:ln>
+        </p:spPr>
+        <p:txBody>
+          <a:bodyPr xmlns:a="http://schemas.openxmlformats.org/drawingml/2006/main" wrap="square" lIns="0" tIns="0" rIns="0" bIns="0" anchor="t">
+            <a:noAutofit/>
+          </a:bodyPr>
+          <a:lstStyle xmlns:a="http://schemas.openxmlformats.org/drawingml/2006/main"/>
+          <a:p xmlns:a="http://schemas.openxmlformats.org/drawingml/2006/main">
+            <a:pPr algn="l">
+              <a:lnSpc>
+                <a:spcPct val="108000"/>
+              </a:lnSpc>
+              <a:buNone/>
+              <a:defRPr sz="2250" b="1">
+                <a:solidFill>
+                  <a:srgbClr val="EDF6F7"/>
+                </a:solidFill>
+                <a:latin typeface="Aptos"/>
+                <a:ea typeface="Aptos"/>
+                <a:cs typeface="Aptos"/>
+              </a:defRPr>
+            </a:pPr>
+            <a:r>
+              <a:rPr sz="2250" b="1">
+                <a:solidFill>
+                  <a:srgbClr val="EDF6F7"/>
+                </a:solidFill>
+                <a:latin typeface="Aptos"/>
+                <a:ea typeface="Aptos"/>
+                <a:cs typeface="Aptos"/>
+              </a:rPr>
+              <a:t>Technical Preview</a:t>
+            </a:r>
+          </a:p>
+        </p:txBody>
+      </p:sp>
+      <p:sp>
+        <p:nvSpPr>
+          <p:cNvPr id="9" name="decision-0-0-dot">
+            <a:extLst xmlns:a="http://schemas.openxmlformats.org/drawingml/2006/main">
+              <a:ext uri="{FF2B5EF4-FFF2-40B4-BE49-F238E27FC236}">
+                <a16:creationId xmlns:a16="http://schemas.microsoft.com/office/drawing/2014/main" id="{2972C95D-7FF7-4F84-B204-BD9595FBE40A}"/>
+              </a:ext>
+            </a:extLst>
+          </p:cNvPr>
+          <p:cNvSpPr>
+            <a:spLocks xmlns:a="http://schemas.openxmlformats.org/drawingml/2006/main" noGrp="1"/>
+          </p:cNvSpPr>
+          <p:nvPr/>
+        </p:nvSpPr>
+        <p:spPr>
+          <a:xfrm xmlns:a="http://schemas.openxmlformats.org/drawingml/2006/main">
+            <a:off x="609600" y="3819525"/>
+            <a:ext cx="66675" cy="66675"/>
+          </a:xfrm>
+          <a:prstGeom xmlns:a="http://schemas.openxmlformats.org/drawingml/2006/main" prst="ellipse">
+            <a:avLst/>
+          </a:prstGeom>
+          <a:solidFill xmlns:a="http://schemas.openxmlformats.org/drawingml/2006/main">
+            <a:srgbClr val="2DD4BF"/>
+          </a:solidFill>
+          <a:ln xmlns:a="http://schemas.openxmlformats.org/drawingml/2006/main" w="0">
+            <a:noFill/>
+            <a:prstDash val="solid"/>
+          </a:ln>
+        </p:spPr>
+      </p:sp>
+      <p:sp>
+        <p:nvSpPr>
+          <p:cNvPr id="10" name="decision-0-0">
+            <a:extLst xmlns:a="http://schemas.openxmlformats.org/drawingml/2006/main">
+              <a:ext uri="{FF2B5EF4-FFF2-40B4-BE49-F238E27FC236}">
+                <a16:creationId xmlns:a16="http://schemas.microsoft.com/office/drawing/2014/main" id="{1FC5A3BC-472D-492A-A790-109CFC75582E}"/>
+              </a:ext>
+            </a:extLst>
+          </p:cNvPr>
+          <p:cNvSpPr>
+            <a:spLocks xmlns:a="http://schemas.openxmlformats.org/drawingml/2006/main" noGrp="1"/>
+          </p:cNvSpPr>
+          <p:nvPr/>
+        </p:nvSpPr>
+        <p:spPr>
+          <a:xfrm xmlns:a="http://schemas.openxmlformats.org/drawingml/2006/main">
+            <a:off x="800100" y="3733800"/>
+            <a:ext cx="2952750" cy="533400"/>
+          </a:xfrm>
+          <a:prstGeom xmlns:a="http://schemas.openxmlformats.org/drawingml/2006/main" prst="rect">
+            <a:avLst/>
+          </a:prstGeom>
+          <a:noFill xmlns:a="http://schemas.openxmlformats.org/drawingml/2006/main"/>
+          <a:ln xmlns:a="http://schemas.openxmlformats.org/drawingml/2006/main" w="0">
+            <a:noFill/>
+            <a:prstDash val="solid"/>
+          </a:ln>
+        </p:spPr>
+        <p:txBody>
+          <a:bodyPr xmlns:a="http://schemas.openxmlformats.org/drawingml/2006/main" wrap="square" lIns="0" tIns="0" rIns="0" bIns="0" anchor="t">
+            <a:noAutofit/>
+          </a:bodyPr>
+          <a:lstStyle xmlns:a="http://schemas.openxmlformats.org/drawingml/2006/main"/>
+          <a:p xmlns:a="http://schemas.openxmlformats.org/drawingml/2006/main">
+            <a:pPr algn="l">
+              <a:lnSpc>
+                <a:spcPct val="112000"/>
+              </a:lnSpc>
+              <a:buNone/>
+              <a:defRPr sz="1650" b="0">
+                <a:solidFill>
+                  <a:srgbClr val="EDF6F7"/>
+                </a:solidFill>
+                <a:latin typeface="Aptos"/>
+                <a:ea typeface="Aptos"/>
+                <a:cs typeface="Aptos"/>
+              </a:defRPr>
+            </a:pPr>
+            <a:r>
+              <a:rPr sz="1650" b="0">
+                <a:solidFill>
+                  <a:srgbClr val="EDF6F7"/>
+                </a:solidFill>
+                <a:latin typeface="Aptos"/>
+                <a:ea typeface="Aptos"/>
+                <a:cs typeface="Aptos"/>
+              </a:rPr>
+              <a:t>One-command local demo</a:t>
+            </a:r>
+          </a:p>
+        </p:txBody>
+      </p:sp>
+      <p:sp>
+        <p:nvSpPr>
+          <p:cNvPr id="11" name="decision-0-1-dot">
+            <a:extLst xmlns:a="http://schemas.openxmlformats.org/drawingml/2006/main">
+              <a:ext uri="{FF2B5EF4-FFF2-40B4-BE49-F238E27FC236}">
+                <a16:creationId xmlns:a16="http://schemas.microsoft.com/office/drawing/2014/main" id="{208BED63-CEA2-4C36-956F-EBD2A1EE79C5}"/>
+              </a:ext>
+            </a:extLst>
+          </p:cNvPr>
+          <p:cNvSpPr>
+            <a:spLocks xmlns:a="http://schemas.openxmlformats.org/drawingml/2006/main" noGrp="1"/>
+          </p:cNvSpPr>
+          <p:nvPr/>
+        </p:nvSpPr>
+        <p:spPr>
+          <a:xfrm xmlns:a="http://schemas.openxmlformats.org/drawingml/2006/main">
+            <a:off x="609600" y="4391025"/>
+            <a:ext cx="66675" cy="66675"/>
+          </a:xfrm>
+          <a:prstGeom xmlns:a="http://schemas.openxmlformats.org/drawingml/2006/main" prst="ellipse">
+            <a:avLst/>
+          </a:prstGeom>
+          <a:solidFill xmlns:a="http://schemas.openxmlformats.org/drawingml/2006/main">
+            <a:srgbClr val="2DD4BF"/>
+          </a:solidFill>
+          <a:ln xmlns:a="http://schemas.openxmlformats.org/drawingml/2006/main" w="0">
+            <a:noFill/>
+            <a:prstDash val="solid"/>
+          </a:ln>
+        </p:spPr>
+      </p:sp>
+      <p:sp>
+        <p:nvSpPr>
+          <p:cNvPr id="12" name="decision-0-1">
+            <a:extLst xmlns:a="http://schemas.openxmlformats.org/drawingml/2006/main">
+              <a:ext uri="{FF2B5EF4-FFF2-40B4-BE49-F238E27FC236}">
+                <a16:creationId xmlns:a16="http://schemas.microsoft.com/office/drawing/2014/main" id="{A8C4C40F-14AE-432B-B8A6-B4A6D241496E}"/>
+              </a:ext>
+            </a:extLst>
+          </p:cNvPr>
+          <p:cNvSpPr>
+            <a:spLocks xmlns:a="http://schemas.openxmlformats.org/drawingml/2006/main" noGrp="1"/>
+          </p:cNvSpPr>
+          <p:nvPr/>
+        </p:nvSpPr>
+        <p:spPr>
+          <a:xfrm xmlns:a="http://schemas.openxmlformats.org/drawingml/2006/main">
+            <a:off x="800100" y="4305300"/>
+            <a:ext cx="2952750" cy="533400"/>
+          </a:xfrm>
+          <a:prstGeom xmlns:a="http://schemas.openxmlformats.org/drawingml/2006/main" prst="rect">
+            <a:avLst/>
+          </a:prstGeom>
+          <a:noFill xmlns:a="http://schemas.openxmlformats.org/drawingml/2006/main"/>
+          <a:ln xmlns:a="http://schemas.openxmlformats.org/drawingml/2006/main" w="0">
+            <a:noFill/>
+            <a:prstDash val="solid"/>
+          </a:ln>
+        </p:spPr>
+        <p:txBody>
+          <a:bodyPr xmlns:a="http://schemas.openxmlformats.org/drawingml/2006/main" wrap="square" lIns="0" tIns="0" rIns="0" bIns="0" anchor="t">
+            <a:noAutofit/>
+          </a:bodyPr>
+          <a:lstStyle xmlns:a="http://schemas.openxmlformats.org/drawingml/2006/main"/>
+          <a:p xmlns:a="http://schemas.openxmlformats.org/drawingml/2006/main">
+            <a:pPr algn="l">
+              <a:lnSpc>
+                <a:spcPct val="112000"/>
+              </a:lnSpc>
+              <a:buNone/>
+              <a:defRPr sz="1650" b="0">
+                <a:solidFill>
+                  <a:srgbClr val="EDF6F7"/>
+                </a:solidFill>
+                <a:latin typeface="Aptos"/>
+                <a:ea typeface="Aptos"/>
+                <a:cs typeface="Aptos"/>
+              </a:defRPr>
+            </a:pPr>
+            <a:r>
+              <a:rPr sz="1650" b="0">
+                <a:solidFill>
+                  <a:srgbClr val="EDF6F7"/>
+                </a:solidFill>
+                <a:latin typeface="Aptos"/>
+                <a:ea typeface="Aptos"/>
+                <a:cs typeface="Aptos"/>
+              </a:rPr>
+              <a:t>196 automated checks</a:t>
+            </a:r>
+          </a:p>
+        </p:txBody>
+      </p:sp>
+      <p:sp>
+        <p:nvSpPr>
+          <p:cNvPr id="13" name="decision-0-2-dot">
+            <a:extLst xmlns:a="http://schemas.openxmlformats.org/drawingml/2006/main">
+              <a:ext uri="{FF2B5EF4-FFF2-40B4-BE49-F238E27FC236}">
+                <a16:creationId xmlns:a16="http://schemas.microsoft.com/office/drawing/2014/main" id="{2E4395D6-9C5B-4AA6-A567-82E07E697A65}"/>
+              </a:ext>
+            </a:extLst>
+          </p:cNvPr>
+          <p:cNvSpPr>
+            <a:spLocks xmlns:a="http://schemas.openxmlformats.org/drawingml/2006/main" noGrp="1"/>
+          </p:cNvSpPr>
+          <p:nvPr/>
+        </p:nvSpPr>
+        <p:spPr>
+          <a:xfrm xmlns:a="http://schemas.openxmlformats.org/drawingml/2006/main">
+            <a:off x="609600" y="4962525"/>
+            <a:ext cx="66675" cy="66675"/>
+          </a:xfrm>
+          <a:prstGeom xmlns:a="http://schemas.openxmlformats.org/drawingml/2006/main" prst="ellipse">
+            <a:avLst/>
+          </a:prstGeom>
+          <a:solidFill xmlns:a="http://schemas.openxmlformats.org/drawingml/2006/main">
+            <a:srgbClr val="2DD4BF"/>
+          </a:solidFill>
+          <a:ln xmlns:a="http://schemas.openxmlformats.org/drawingml/2006/main" w="0">
+            <a:noFill/>
+            <a:prstDash val="solid"/>
+          </a:ln>
+        </p:spPr>
+      </p:sp>
+      <p:sp>
+        <p:nvSpPr>
+          <p:cNvPr id="14" name="decision-0-2">
+            <a:extLst xmlns:a="http://schemas.openxmlformats.org/drawingml/2006/main">
+              <a:ext uri="{FF2B5EF4-FFF2-40B4-BE49-F238E27FC236}">
+                <a16:creationId xmlns:a16="http://schemas.microsoft.com/office/drawing/2014/main" id="{499EE4D9-5FC5-4CC4-B842-316DD5F1D374}"/>
+              </a:ext>
+            </a:extLst>
+          </p:cNvPr>
+          <p:cNvSpPr>
+            <a:spLocks xmlns:a="http://schemas.openxmlformats.org/drawingml/2006/main" noGrp="1"/>
+          </p:cNvSpPr>
+          <p:nvPr/>
+        </p:nvSpPr>
+        <p:spPr>
+          <a:xfrm xmlns:a="http://schemas.openxmlformats.org/drawingml/2006/main">
+            <a:off x="800100" y="4876800"/>
+            <a:ext cx="2952750" cy="533400"/>
+          </a:xfrm>
+          <a:prstGeom xmlns:a="http://schemas.openxmlformats.org/drawingml/2006/main" prst="rect">
+            <a:avLst/>
+          </a:prstGeom>
+          <a:noFill xmlns:a="http://schemas.openxmlformats.org/drawingml/2006/main"/>
+          <a:ln xmlns:a="http://schemas.openxmlformats.org/drawingml/2006/main" w="0">
+            <a:noFill/>
+            <a:prstDash val="solid"/>
+          </a:ln>
+        </p:spPr>
+        <p:txBody>
+          <a:bodyPr xmlns:a="http://schemas.openxmlformats.org/drawingml/2006/main" wrap="square" lIns="0" tIns="0" rIns="0" bIns="0" anchor="t">
+            <a:noAutofit/>
+          </a:bodyPr>
+          <a:lstStyle xmlns:a="http://schemas.openxmlformats.org/drawingml/2006/main"/>
+          <a:p xmlns:a="http://schemas.openxmlformats.org/drawingml/2006/main">
+            <a:pPr algn="l">
+              <a:lnSpc>
+                <a:spcPct val="112000"/>
+              </a:lnSpc>
+              <a:buNone/>
+              <a:defRPr sz="1650" b="0">
+                <a:solidFill>
+                  <a:srgbClr val="EDF6F7"/>
+                </a:solidFill>
+                <a:latin typeface="Aptos"/>
+                <a:ea typeface="Aptos"/>
+                <a:cs typeface="Aptos"/>
+              </a:defRPr>
+            </a:pPr>
+            <a:r>
+              <a:rPr sz="1650" b="0">
+                <a:solidFill>
+                  <a:srgbClr val="EDF6F7"/>
+                </a:solidFill>
+                <a:latin typeface="Aptos"/>
+                <a:ea typeface="Aptos"/>
+                <a:cs typeface="Aptos"/>
+              </a:rPr>
+              <a:t>Five external evaluations</a:t>
+            </a:r>
+          </a:p>
+        </p:txBody>
+      </p:sp>
+      <p:sp>
+        <p:nvSpPr>
+          <p:cNvPr id="15" name="decision-accent-1">
+            <a:extLst xmlns:a="http://schemas.openxmlformats.org/drawingml/2006/main">
+              <a:ext uri="{FF2B5EF4-FFF2-40B4-BE49-F238E27FC236}">
+                <a16:creationId xmlns:a16="http://schemas.microsoft.com/office/drawing/2014/main" id="{89881E43-B4B0-4510-A644-E7BA2B571821}"/>
+              </a:ext>
+            </a:extLst>
+          </p:cNvPr>
+          <p:cNvSpPr>
+            <a:spLocks xmlns:a="http://schemas.openxmlformats.org/drawingml/2006/main" noGrp="1"/>
+          </p:cNvSpPr>
+          <p:nvPr/>
+        </p:nvSpPr>
+        <p:spPr>
+          <a:xfrm xmlns:a="http://schemas.openxmlformats.org/drawingml/2006/main">
+            <a:off x="4305300" y="2343150"/>
+            <a:ext cx="3143250" cy="38100"/>
+          </a:xfrm>
+          <a:prstGeom xmlns:a="http://schemas.openxmlformats.org/drawingml/2006/main" prst="roundRect">
+            <a:avLst>
+              <a:gd name="adj" fmla="val 50000"/>
+            </a:avLst>
+          </a:prstGeom>
+          <a:solidFill xmlns:a="http://schemas.openxmlformats.org/drawingml/2006/main">
+            <a:srgbClr val="2DD4BF"/>
+          </a:solidFill>
+          <a:ln xmlns:a="http://schemas.openxmlformats.org/drawingml/2006/main" w="0">
+            <a:noFill/>
+            <a:prstDash val="solid"/>
+          </a:ln>
+        </p:spPr>
+      </p:sp>
+      <p:sp>
+        <p:nvSpPr>
+          <p:cNvPr id="16" name="decision-label-1">
+            <a:extLst xmlns:a="http://schemas.openxmlformats.org/drawingml/2006/main">
+              <a:ext uri="{FF2B5EF4-FFF2-40B4-BE49-F238E27FC236}">
+                <a16:creationId xmlns:a16="http://schemas.microsoft.com/office/drawing/2014/main" id="{3A5A2080-CC90-4299-9287-D1E133E6A2E1}"/>
+              </a:ext>
+            </a:extLst>
+          </p:cNvPr>
+          <p:cNvSpPr>
+            <a:spLocks xmlns:a="http://schemas.openxmlformats.org/drawingml/2006/main" noGrp="1"/>
+          </p:cNvSpPr>
+          <p:nvPr/>
+        </p:nvSpPr>
+        <p:spPr>
+          <a:xfrm xmlns:a="http://schemas.openxmlformats.org/drawingml/2006/main">
+            <a:off x="4305300" y="2647950"/>
+            <a:ext cx="2381250" cy="209550"/>
+          </a:xfrm>
+          <a:prstGeom xmlns:a="http://schemas.openxmlformats.org/drawingml/2006/main" prst="rect">
+            <a:avLst/>
+          </a:prstGeom>
+          <a:noFill xmlns:a="http://schemas.openxmlformats.org/drawingml/2006/main"/>
+          <a:ln xmlns:a="http://schemas.openxmlformats.org/drawingml/2006/main" w="0">
+            <a:noFill/>
+            <a:prstDash val="solid"/>
+          </a:ln>
+        </p:spPr>
+        <p:txBody>
+          <a:bodyPr xmlns:a="http://schemas.openxmlformats.org/drawingml/2006/main" wrap="square" lIns="0" tIns="0" rIns="0" bIns="0" anchor="t">
+            <a:noAutofit/>
+          </a:bodyPr>
+          <a:lstStyle xmlns:a="http://schemas.openxmlformats.org/drawingml/2006/main"/>
+          <a:p xmlns:a="http://schemas.openxmlformats.org/drawingml/2006/main">
+            <a:pPr algn="l">
+              <a:lnSpc>
+                <a:spcPct val="108000"/>
+              </a:lnSpc>
+              <a:buNone/>
+              <a:defRPr sz="1050" b="1">
+                <a:solidFill>
+                  <a:srgbClr val="2DD4BF"/>
+                </a:solidFill>
+                <a:latin typeface="Aptos"/>
+                <a:ea typeface="Aptos"/>
+                <a:cs typeface="Aptos"/>
+              </a:defRPr>
+            </a:pPr>
+            <a:r>
+              <a:rPr sz="1050" b="1">
+                <a:solidFill>
+                  <a:srgbClr val="2DD4BF"/>
+                </a:solidFill>
+                <a:latin typeface="Aptos"/>
+                <a:ea typeface="Aptos"/>
+                <a:cs typeface="Aptos"/>
+              </a:rPr>
+              <a:t>NEXT · v0.2</a:t>
+            </a:r>
+          </a:p>
+        </p:txBody>
+      </p:sp>
+      <p:sp>
+        <p:nvSpPr>
+          <p:cNvPr id="17" name="decision-title-1">
+            <a:extLst xmlns:a="http://schemas.openxmlformats.org/drawingml/2006/main">
+              <a:ext uri="{FF2B5EF4-FFF2-40B4-BE49-F238E27FC236}">
+                <a16:creationId xmlns:a16="http://schemas.microsoft.com/office/drawing/2014/main" id="{4F6698AE-D1ED-4326-9C20-44F1E26894BC}"/>
+              </a:ext>
+            </a:extLst>
+          </p:cNvPr>
+          <p:cNvSpPr>
+            <a:spLocks xmlns:a="http://schemas.openxmlformats.org/drawingml/2006/main" noGrp="1"/>
+          </p:cNvSpPr>
+          <p:nvPr/>
+        </p:nvSpPr>
+        <p:spPr>
+          <a:xfrm xmlns:a="http://schemas.openxmlformats.org/drawingml/2006/main">
+            <a:off x="4305300" y="3048000"/>
+            <a:ext cx="3143250" cy="400050"/>
+          </a:xfrm>
+          <a:prstGeom xmlns:a="http://schemas.openxmlformats.org/drawingml/2006/main" prst="rect">
+            <a:avLst/>
+          </a:prstGeom>
+          <a:noFill xmlns:a="http://schemas.openxmlformats.org/drawingml/2006/main"/>
+          <a:ln xmlns:a="http://schemas.openxmlformats.org/drawingml/2006/main" w="0">
+            <a:noFill/>
+            <a:prstDash val="solid"/>
+          </a:ln>
+        </p:spPr>
+        <p:txBody>
+          <a:bodyPr xmlns:a="http://schemas.openxmlformats.org/drawingml/2006/main" wrap="square" lIns="0" tIns="0" rIns="0" bIns="0" anchor="t">
+            <a:noAutofit/>
+          </a:bodyPr>
+          <a:lstStyle xmlns:a="http://schemas.openxmlformats.org/drawingml/2006/main"/>
+          <a:p xmlns:a="http://schemas.openxmlformats.org/drawingml/2006/main">
+            <a:pPr algn="l">
+              <a:lnSpc>
+                <a:spcPct val="108000"/>
+              </a:lnSpc>
+              <a:buNone/>
+              <a:defRPr sz="2250" b="1">
+                <a:solidFill>
+                  <a:srgbClr val="EDF6F7"/>
+                </a:solidFill>
+                <a:latin typeface="Aptos"/>
+                <a:ea typeface="Aptos"/>
+                <a:cs typeface="Aptos"/>
+              </a:defRPr>
+            </a:pPr>
+            <a:r>
+              <a:rPr sz="2250" b="1">
+                <a:solidFill>
+                  <a:srgbClr val="EDF6F7"/>
+                </a:solidFill>
+                <a:latin typeface="Aptos"/>
+                <a:ea typeface="Aptos"/>
+                <a:cs typeface="Aptos"/>
+              </a:rPr>
+              <a:t>Prove one target</a:t>
+            </a:r>
+          </a:p>
+        </p:txBody>
+      </p:sp>
+      <p:sp>
+        <p:nvSpPr>
+          <p:cNvPr id="18" name="decision-1-0-dot">
+            <a:extLst xmlns:a="http://schemas.openxmlformats.org/drawingml/2006/main">
+              <a:ext uri="{FF2B5EF4-FFF2-40B4-BE49-F238E27FC236}">
+                <a16:creationId xmlns:a16="http://schemas.microsoft.com/office/drawing/2014/main" id="{7BACB87A-716A-4EB2-8B3F-7BEF104C360A}"/>
+              </a:ext>
+            </a:extLst>
+          </p:cNvPr>
+          <p:cNvSpPr>
+            <a:spLocks xmlns:a="http://schemas.openxmlformats.org/drawingml/2006/main" noGrp="1"/>
+          </p:cNvSpPr>
+          <p:nvPr/>
+        </p:nvSpPr>
+        <p:spPr>
+          <a:xfrm xmlns:a="http://schemas.openxmlformats.org/drawingml/2006/main">
+            <a:off x="4305300" y="3819525"/>
+            <a:ext cx="66675" cy="66675"/>
+          </a:xfrm>
+          <a:prstGeom xmlns:a="http://schemas.openxmlformats.org/drawingml/2006/main" prst="ellipse">
+            <a:avLst/>
+          </a:prstGeom>
+          <a:solidFill xmlns:a="http://schemas.openxmlformats.org/drawingml/2006/main">
+            <a:srgbClr val="2DD4BF"/>
+          </a:solidFill>
+          <a:ln xmlns:a="http://schemas.openxmlformats.org/drawingml/2006/main" w="0">
+            <a:noFill/>
+            <a:prstDash val="solid"/>
+          </a:ln>
+        </p:spPr>
+      </p:sp>
+      <p:sp>
+        <p:nvSpPr>
+          <p:cNvPr id="19" name="decision-1-0">
+            <a:extLst xmlns:a="http://schemas.openxmlformats.org/drawingml/2006/main">
+              <a:ext uri="{FF2B5EF4-FFF2-40B4-BE49-F238E27FC236}">
+                <a16:creationId xmlns:a16="http://schemas.microsoft.com/office/drawing/2014/main" id="{0D72FEBF-AA96-4C37-A3E1-BF155AC6DA21}"/>
+              </a:ext>
+            </a:extLst>
+          </p:cNvPr>
+          <p:cNvSpPr>
+            <a:spLocks xmlns:a="http://schemas.openxmlformats.org/drawingml/2006/main" noGrp="1"/>
+          </p:cNvSpPr>
+          <p:nvPr/>
+        </p:nvSpPr>
+        <p:spPr>
+          <a:xfrm xmlns:a="http://schemas.openxmlformats.org/drawingml/2006/main">
+            <a:off x="4495800" y="3733800"/>
+            <a:ext cx="2952750" cy="533400"/>
+          </a:xfrm>
+          <a:prstGeom xmlns:a="http://schemas.openxmlformats.org/drawingml/2006/main" prst="rect">
+            <a:avLst/>
+          </a:prstGeom>
+          <a:noFill xmlns:a="http://schemas.openxmlformats.org/drawingml/2006/main"/>
+          <a:ln xmlns:a="http://schemas.openxmlformats.org/drawingml/2006/main" w="0">
+            <a:noFill/>
+            <a:prstDash val="solid"/>
+          </a:ln>
+        </p:spPr>
+        <p:txBody>
+          <a:bodyPr xmlns:a="http://schemas.openxmlformats.org/drawingml/2006/main" wrap="square" lIns="0" tIns="0" rIns="0" bIns="0" anchor="t">
+            <a:noAutofit/>
+          </a:bodyPr>
+          <a:lstStyle xmlns:a="http://schemas.openxmlformats.org/drawingml/2006/main"/>
+          <a:p xmlns:a="http://schemas.openxmlformats.org/drawingml/2006/main">
+            <a:pPr algn="l">
+              <a:lnSpc>
+                <a:spcPct val="112000"/>
+              </a:lnSpc>
+              <a:buNone/>
+              <a:defRPr sz="1650" b="0">
+                <a:solidFill>
+                  <a:srgbClr val="EDF6F7"/>
+                </a:solidFill>
+                <a:latin typeface="Aptos"/>
+                <a:ea typeface="Aptos"/>
+                <a:cs typeface="Aptos"/>
+              </a:defRPr>
+            </a:pPr>
+            <a:r>
+              <a:rPr sz="1650" b="0">
+                <a:solidFill>
+                  <a:srgbClr val="EDF6F7"/>
+                </a:solidFill>
+                <a:latin typeface="Aptos"/>
+                <a:ea typeface="Aptos"/>
+                <a:cs typeface="Aptos"/>
+              </a:rPr>
+              <a:t>PostgreSQL RLS adapter</a:t>
+            </a:r>
+          </a:p>
+        </p:txBody>
+      </p:sp>
+      <p:sp>
+        <p:nvSpPr>
+          <p:cNvPr id="20" name="decision-1-1-dot">
+            <a:extLst xmlns:a="http://schemas.openxmlformats.org/drawingml/2006/main">
+              <a:ext uri="{FF2B5EF4-FFF2-40B4-BE49-F238E27FC236}">
+                <a16:creationId xmlns:a16="http://schemas.microsoft.com/office/drawing/2014/main" id="{387C4691-D86A-469D-A586-30E86613DA39}"/>
+              </a:ext>
+            </a:extLst>
+          </p:cNvPr>
+          <p:cNvSpPr>
+            <a:spLocks xmlns:a="http://schemas.openxmlformats.org/drawingml/2006/main" noGrp="1"/>
+          </p:cNvSpPr>
+          <p:nvPr/>
+        </p:nvSpPr>
+        <p:spPr>
+          <a:xfrm xmlns:a="http://schemas.openxmlformats.org/drawingml/2006/main">
+            <a:off x="4305300" y="4391025"/>
+            <a:ext cx="66675" cy="66675"/>
+          </a:xfrm>
+          <a:prstGeom xmlns:a="http://schemas.openxmlformats.org/drawingml/2006/main" prst="ellipse">
+            <a:avLst/>
+          </a:prstGeom>
+          <a:solidFill xmlns:a="http://schemas.openxmlformats.org/drawingml/2006/main">
+            <a:srgbClr val="2DD4BF"/>
+          </a:solidFill>
+          <a:ln xmlns:a="http://schemas.openxmlformats.org/drawingml/2006/main" w="0">
+            <a:noFill/>
+            <a:prstDash val="solid"/>
+          </a:ln>
+        </p:spPr>
+      </p:sp>
+      <p:sp>
+        <p:nvSpPr>
+          <p:cNvPr id="21" name="decision-1-1">
+            <a:extLst xmlns:a="http://schemas.openxmlformats.org/drawingml/2006/main">
+              <a:ext uri="{FF2B5EF4-FFF2-40B4-BE49-F238E27FC236}">
+                <a16:creationId xmlns:a16="http://schemas.microsoft.com/office/drawing/2014/main" id="{5DB8D9D3-931C-45AE-AF86-CC3191F7466B}"/>
+              </a:ext>
+            </a:extLst>
+          </p:cNvPr>
+          <p:cNvSpPr>
+            <a:spLocks xmlns:a="http://schemas.openxmlformats.org/drawingml/2006/main" noGrp="1"/>
+          </p:cNvSpPr>
+          <p:nvPr/>
+        </p:nvSpPr>
+        <p:spPr>
+          <a:xfrm xmlns:a="http://schemas.openxmlformats.org/drawingml/2006/main">
+            <a:off x="4495800" y="4305300"/>
+            <a:ext cx="2952750" cy="533400"/>
+          </a:xfrm>
+          <a:prstGeom xmlns:a="http://schemas.openxmlformats.org/drawingml/2006/main" prst="rect">
+            <a:avLst/>
+          </a:prstGeom>
+          <a:noFill xmlns:a="http://schemas.openxmlformats.org/drawingml/2006/main"/>
+          <a:ln xmlns:a="http://schemas.openxmlformats.org/drawingml/2006/main" w="0">
+            <a:noFill/>
+            <a:prstDash val="solid"/>
+          </a:ln>
+        </p:spPr>
+        <p:txBody>
+          <a:bodyPr xmlns:a="http://schemas.openxmlformats.org/drawingml/2006/main" wrap="square" lIns="0" tIns="0" rIns="0" bIns="0" anchor="t">
+            <a:noAutofit/>
+          </a:bodyPr>
+          <a:lstStyle xmlns:a="http://schemas.openxmlformats.org/drawingml/2006/main"/>
+          <a:p xmlns:a="http://schemas.openxmlformats.org/drawingml/2006/main">
+            <a:pPr algn="l">
+              <a:lnSpc>
+                <a:spcPct val="112000"/>
+              </a:lnSpc>
+              <a:buNone/>
+              <a:defRPr sz="1650" b="0">
+                <a:solidFill>
+                  <a:srgbClr val="EDF6F7"/>
+                </a:solidFill>
+                <a:latin typeface="Aptos"/>
+                <a:ea typeface="Aptos"/>
+                <a:cs typeface="Aptos"/>
+              </a:defRPr>
+            </a:pPr>
+            <a:r>
+              <a:rPr sz="1650" b="0">
+                <a:solidFill>
+                  <a:srgbClr val="EDF6F7"/>
+                </a:solidFill>
+                <a:latin typeface="Aptos"/>
+                <a:ea typeface="Aptos"/>
+                <a:cs typeface="Aptos"/>
+              </a:rPr>
+              <a:t>Apply, read back, drift</a:t>
+            </a:r>
+          </a:p>
+        </p:txBody>
+      </p:sp>
+      <p:sp>
+        <p:nvSpPr>
+          <p:cNvPr id="22" name="decision-1-2-dot">
+            <a:extLst xmlns:a="http://schemas.openxmlformats.org/drawingml/2006/main">
+              <a:ext uri="{FF2B5EF4-FFF2-40B4-BE49-F238E27FC236}">
+                <a16:creationId xmlns:a16="http://schemas.microsoft.com/office/drawing/2014/main" id="{93945EFA-2D3C-4E89-BB20-0D45B33C106B}"/>
+              </a:ext>
+            </a:extLst>
+          </p:cNvPr>
+          <p:cNvSpPr>
+            <a:spLocks xmlns:a="http://schemas.openxmlformats.org/drawingml/2006/main" noGrp="1"/>
+          </p:cNvSpPr>
+          <p:nvPr/>
+        </p:nvSpPr>
+        <p:spPr>
+          <a:xfrm xmlns:a="http://schemas.openxmlformats.org/drawingml/2006/main">
+            <a:off x="4305300" y="4962525"/>
+            <a:ext cx="66675" cy="66675"/>
+          </a:xfrm>
+          <a:prstGeom xmlns:a="http://schemas.openxmlformats.org/drawingml/2006/main" prst="ellipse">
+            <a:avLst/>
+          </a:prstGeom>
+          <a:solidFill xmlns:a="http://schemas.openxmlformats.org/drawingml/2006/main">
+            <a:srgbClr val="2DD4BF"/>
+          </a:solidFill>
+          <a:ln xmlns:a="http://schemas.openxmlformats.org/drawingml/2006/main" w="0">
+            <a:noFill/>
+            <a:prstDash val="solid"/>
+          </a:ln>
+        </p:spPr>
+      </p:sp>
+      <p:sp>
+        <p:nvSpPr>
+          <p:cNvPr id="23" name="decision-1-2">
+            <a:extLst xmlns:a="http://schemas.openxmlformats.org/drawingml/2006/main">
+              <a:ext uri="{FF2B5EF4-FFF2-40B4-BE49-F238E27FC236}">
+                <a16:creationId xmlns:a16="http://schemas.microsoft.com/office/drawing/2014/main" id="{CB3794E4-3EDA-4862-AF02-4BE216C15F6C}"/>
+              </a:ext>
+            </a:extLst>
+          </p:cNvPr>
+          <p:cNvSpPr>
+            <a:spLocks xmlns:a="http://schemas.openxmlformats.org/drawingml/2006/main" noGrp="1"/>
+          </p:cNvSpPr>
+          <p:nvPr/>
+        </p:nvSpPr>
+        <p:spPr>
+          <a:xfrm xmlns:a="http://schemas.openxmlformats.org/drawingml/2006/main">
+            <a:off x="4495800" y="4876800"/>
+            <a:ext cx="2952750" cy="533400"/>
+          </a:xfrm>
+          <a:prstGeom xmlns:a="http://schemas.openxmlformats.org/drawingml/2006/main" prst="rect">
+            <a:avLst/>
+          </a:prstGeom>
+          <a:noFill xmlns:a="http://schemas.openxmlformats.org/drawingml/2006/main"/>
+          <a:ln xmlns:a="http://schemas.openxmlformats.org/drawingml/2006/main" w="0">
+            <a:noFill/>
+            <a:prstDash val="solid"/>
+          </a:ln>
+        </p:spPr>
+        <p:txBody>
+          <a:bodyPr xmlns:a="http://schemas.openxmlformats.org/drawingml/2006/main" wrap="square" lIns="0" tIns="0" rIns="0" bIns="0" anchor="t">
+            <a:noAutofit/>
+          </a:bodyPr>
+          <a:lstStyle xmlns:a="http://schemas.openxmlformats.org/drawingml/2006/main"/>
+          <a:p xmlns:a="http://schemas.openxmlformats.org/drawingml/2006/main">
+            <a:pPr algn="l">
+              <a:lnSpc>
+                <a:spcPct val="112000"/>
+              </a:lnSpc>
+              <a:buNone/>
+              <a:defRPr sz="1650" b="0">
+                <a:solidFill>
+                  <a:srgbClr val="EDF6F7"/>
+                </a:solidFill>
+                <a:latin typeface="Aptos"/>
+                <a:ea typeface="Aptos"/>
+                <a:cs typeface="Aptos"/>
+              </a:defRPr>
+            </a:pPr>
+            <a:r>
+              <a:rPr sz="1650" b="0">
+                <a:solidFill>
+                  <a:srgbClr val="EDF6F7"/>
+                </a:solidFill>
+                <a:latin typeface="Aptos"/>
+                <a:ea typeface="Aptos"/>
+                <a:cs typeface="Aptos"/>
+              </a:rPr>
+              <a:t>AuthZEN 1.0 interop</a:t>
+            </a:r>
+          </a:p>
+        </p:txBody>
+      </p:sp>
+      <p:sp>
+        <p:nvSpPr>
+          <p:cNvPr id="24" name="decision-accent-2">
+            <a:extLst xmlns:a="http://schemas.openxmlformats.org/drawingml/2006/main">
+              <a:ext uri="{FF2B5EF4-FFF2-40B4-BE49-F238E27FC236}">
+                <a16:creationId xmlns:a16="http://schemas.microsoft.com/office/drawing/2014/main" id="{B911D945-5BF4-414A-A017-BA3677F34F62}"/>
+              </a:ext>
+            </a:extLst>
+          </p:cNvPr>
+          <p:cNvSpPr>
+            <a:spLocks xmlns:a="http://schemas.openxmlformats.org/drawingml/2006/main" noGrp="1"/>
+          </p:cNvSpPr>
+          <p:nvPr/>
+        </p:nvSpPr>
+        <p:spPr>
+          <a:xfrm xmlns:a="http://schemas.openxmlformats.org/drawingml/2006/main">
+            <a:off x="8001000" y="2343150"/>
+            <a:ext cx="3143250" cy="38100"/>
+          </a:xfrm>
+          <a:prstGeom xmlns:a="http://schemas.openxmlformats.org/drawingml/2006/main" prst="roundRect">
+            <a:avLst>
+              <a:gd name="adj" fmla="val 50000"/>
+            </a:avLst>
+          </a:prstGeom>
+          <a:solidFill xmlns:a="http://schemas.openxmlformats.org/drawingml/2006/main">
+            <a:srgbClr val="F4B942"/>
+          </a:solidFill>
+          <a:ln xmlns:a="http://schemas.openxmlformats.org/drawingml/2006/main" w="0">
+            <a:noFill/>
+            <a:prstDash val="solid"/>
+          </a:ln>
+        </p:spPr>
+      </p:sp>
+      <p:sp>
+        <p:nvSpPr>
+          <p:cNvPr id="25" name="decision-label-2">
+            <a:extLst xmlns:a="http://schemas.openxmlformats.org/drawingml/2006/main">
+              <a:ext uri="{FF2B5EF4-FFF2-40B4-BE49-F238E27FC236}">
+                <a16:creationId xmlns:a16="http://schemas.microsoft.com/office/drawing/2014/main" id="{7E87B72F-F401-4638-BD7F-FF681BEF1567}"/>
+              </a:ext>
+            </a:extLst>
+          </p:cNvPr>
+          <p:cNvSpPr>
+            <a:spLocks xmlns:a="http://schemas.openxmlformats.org/drawingml/2006/main" noGrp="1"/>
+          </p:cNvSpPr>
+          <p:nvPr/>
+        </p:nvSpPr>
+        <p:spPr>
+          <a:xfrm xmlns:a="http://schemas.openxmlformats.org/drawingml/2006/main">
+            <a:off x="8001000" y="2647950"/>
+            <a:ext cx="2381250" cy="209550"/>
+          </a:xfrm>
+          <a:prstGeom xmlns:a="http://schemas.openxmlformats.org/drawingml/2006/main" prst="rect">
+            <a:avLst/>
+          </a:prstGeom>
+          <a:noFill xmlns:a="http://schemas.openxmlformats.org/drawingml/2006/main"/>
+          <a:ln xmlns:a="http://schemas.openxmlformats.org/drawingml/2006/main" w="0">
+            <a:noFill/>
+            <a:prstDash val="solid"/>
+          </a:ln>
+        </p:spPr>
+        <p:txBody>
+          <a:bodyPr xmlns:a="http://schemas.openxmlformats.org/drawingml/2006/main" wrap="square" lIns="0" tIns="0" rIns="0" bIns="0" anchor="t">
+            <a:noAutofit/>
+          </a:bodyPr>
+          <a:lstStyle xmlns:a="http://schemas.openxmlformats.org/drawingml/2006/main"/>
+          <a:p xmlns:a="http://schemas.openxmlformats.org/drawingml/2006/main">
+            <a:pPr algn="l">
+              <a:lnSpc>
+                <a:spcPct val="108000"/>
+              </a:lnSpc>
+              <a:buNone/>
+              <a:defRPr sz="1050" b="1">
+                <a:solidFill>
+                  <a:srgbClr val="F4B942"/>
+                </a:solidFill>
+                <a:latin typeface="Aptos"/>
+                <a:ea typeface="Aptos"/>
+                <a:cs typeface="Aptos"/>
+              </a:defRPr>
+            </a:pPr>
+            <a:r>
+              <a:rPr sz="1050" b="1">
+                <a:solidFill>
+                  <a:srgbClr val="F4B942"/>
+                </a:solidFill>
+                <a:latin typeface="Aptos"/>
+                <a:ea typeface="Aptos"/>
+                <a:cs typeface="Aptos"/>
+              </a:rPr>
+              <a:t>LATER · v0.3</a:t>
+            </a:r>
+          </a:p>
+        </p:txBody>
+      </p:sp>
+      <p:sp>
+        <p:nvSpPr>
+          <p:cNvPr id="26" name="decision-title-2">
+            <a:extLst xmlns:a="http://schemas.openxmlformats.org/drawingml/2006/main">
+              <a:ext uri="{FF2B5EF4-FFF2-40B4-BE49-F238E27FC236}">
+                <a16:creationId xmlns:a16="http://schemas.microsoft.com/office/drawing/2014/main" id="{11D5AA0A-E2C4-45D7-9E1B-E948F0E4CF24}"/>
+              </a:ext>
+            </a:extLst>
+          </p:cNvPr>
+          <p:cNvSpPr>
+            <a:spLocks xmlns:a="http://schemas.openxmlformats.org/drawingml/2006/main" noGrp="1"/>
+          </p:cNvSpPr>
+          <p:nvPr/>
+        </p:nvSpPr>
+        <p:spPr>
+          <a:xfrm xmlns:a="http://schemas.openxmlformats.org/drawingml/2006/main">
+            <a:off x="8001000" y="3048000"/>
+            <a:ext cx="3143250" cy="400050"/>
+          </a:xfrm>
+          <a:prstGeom xmlns:a="http://schemas.openxmlformats.org/drawingml/2006/main" prst="rect">
+            <a:avLst/>
+          </a:prstGeom>
+          <a:noFill xmlns:a="http://schemas.openxmlformats.org/drawingml/2006/main"/>
+          <a:ln xmlns:a="http://schemas.openxmlformats.org/drawingml/2006/main" w="0">
+            <a:noFill/>
+            <a:prstDash val="solid"/>
+          </a:ln>
+        </p:spPr>
+        <p:txBody>
+          <a:bodyPr xmlns:a="http://schemas.openxmlformats.org/drawingml/2006/main" wrap="square" lIns="0" tIns="0" rIns="0" bIns="0" anchor="t">
+            <a:noAutofit/>
+          </a:bodyPr>
+          <a:lstStyle xmlns:a="http://schemas.openxmlformats.org/drawingml/2006/main"/>
+          <a:p xmlns:a="http://schemas.openxmlformats.org/drawingml/2006/main">
+            <a:pPr algn="l">
+              <a:lnSpc>
+                <a:spcPct val="108000"/>
+              </a:lnSpc>
+              <a:buNone/>
+              <a:defRPr sz="2250" b="1">
+                <a:solidFill>
+                  <a:srgbClr val="EDF6F7"/>
+                </a:solidFill>
+                <a:latin typeface="Aptos"/>
+                <a:ea typeface="Aptos"/>
+                <a:cs typeface="Aptos"/>
+              </a:defRPr>
+            </a:pPr>
+            <a:r>
+              <a:rPr sz="2250" b="1">
+                <a:solidFill>
+                  <a:srgbClr val="EDF6F7"/>
+                </a:solidFill>
+                <a:latin typeface="Aptos"/>
+                <a:ea typeface="Aptos"/>
+                <a:cs typeface="Aptos"/>
+              </a:rPr>
+              <a:t>Broaden evidence</a:t>
+            </a:r>
+          </a:p>
+        </p:txBody>
+      </p:sp>
+      <p:sp>
+        <p:nvSpPr>
+          <p:cNvPr id="27" name="decision-2-0-dot">
+            <a:extLst xmlns:a="http://schemas.openxmlformats.org/drawingml/2006/main">
+              <a:ext uri="{FF2B5EF4-FFF2-40B4-BE49-F238E27FC236}">
+                <a16:creationId xmlns:a16="http://schemas.microsoft.com/office/drawing/2014/main" id="{4220A6B7-3EFB-43A1-A593-B07B135080FF}"/>
+              </a:ext>
+            </a:extLst>
+          </p:cNvPr>
+          <p:cNvSpPr>
+            <a:spLocks xmlns:a="http://schemas.openxmlformats.org/drawingml/2006/main" noGrp="1"/>
+          </p:cNvSpPr>
+          <p:nvPr/>
+        </p:nvSpPr>
+        <p:spPr>
+          <a:xfrm xmlns:a="http://schemas.openxmlformats.org/drawingml/2006/main">
+            <a:off x="8001000" y="3819525"/>
+            <a:ext cx="66675" cy="66675"/>
+          </a:xfrm>
+          <a:prstGeom xmlns:a="http://schemas.openxmlformats.org/drawingml/2006/main" prst="ellipse">
+            <a:avLst/>
+          </a:prstGeom>
+          <a:solidFill xmlns:a="http://schemas.openxmlformats.org/drawingml/2006/main">
+            <a:srgbClr val="2DD4BF"/>
+          </a:solidFill>
+          <a:ln xmlns:a="http://schemas.openxmlformats.org/drawingml/2006/main" w="0">
+            <a:noFill/>
+            <a:prstDash val="solid"/>
+          </a:ln>
+        </p:spPr>
+      </p:sp>
+      <p:sp>
+        <p:nvSpPr>
+          <p:cNvPr id="28" name="decision-2-0">
+            <a:extLst xmlns:a="http://schemas.openxmlformats.org/drawingml/2006/main">
+              <a:ext uri="{FF2B5EF4-FFF2-40B4-BE49-F238E27FC236}">
+                <a16:creationId xmlns:a16="http://schemas.microsoft.com/office/drawing/2014/main" id="{E5C90706-88F8-4FD5-BF5F-F295AD26D14A}"/>
+              </a:ext>
+            </a:extLst>
+          </p:cNvPr>
+          <p:cNvSpPr>
+            <a:spLocks xmlns:a="http://schemas.openxmlformats.org/drawingml/2006/main" noGrp="1"/>
+          </p:cNvSpPr>
+          <p:nvPr/>
+        </p:nvSpPr>
+        <p:spPr>
+          <a:xfrm xmlns:a="http://schemas.openxmlformats.org/drawingml/2006/main">
+            <a:off x="8191500" y="3733800"/>
+            <a:ext cx="2952750" cy="533400"/>
+          </a:xfrm>
+          <a:prstGeom xmlns:a="http://schemas.openxmlformats.org/drawingml/2006/main" prst="rect">
+            <a:avLst/>
+          </a:prstGeom>
+          <a:noFill xmlns:a="http://schemas.openxmlformats.org/drawingml/2006/main"/>
+          <a:ln xmlns:a="http://schemas.openxmlformats.org/drawingml/2006/main" w="0">
+            <a:noFill/>
+            <a:prstDash val="solid"/>
+          </a:ln>
+        </p:spPr>
+        <p:txBody>
+          <a:bodyPr xmlns:a="http://schemas.openxmlformats.org/drawingml/2006/main" wrap="square" lIns="0" tIns="0" rIns="0" bIns="0" anchor="t">
+            <a:noAutofit/>
+          </a:bodyPr>
+          <a:lstStyle xmlns:a="http://schemas.openxmlformats.org/drawingml/2006/main"/>
+          <a:p xmlns:a="http://schemas.openxmlformats.org/drawingml/2006/main">
+            <a:pPr algn="l">
+              <a:lnSpc>
+                <a:spcPct val="112000"/>
+              </a:lnSpc>
+              <a:buNone/>
+              <a:defRPr sz="1650" b="0">
+                <a:solidFill>
+                  <a:srgbClr val="EDF6F7"/>
+                </a:solidFill>
+                <a:latin typeface="Aptos"/>
+                <a:ea typeface="Aptos"/>
+                <a:cs typeface="Aptos"/>
+              </a:defRPr>
+            </a:pPr>
+            <a:r>
+              <a:rPr sz="1650" b="0">
+                <a:solidFill>
+                  <a:srgbClr val="EDF6F7"/>
+                </a:solidFill>
+                <a:latin typeface="Aptos"/>
+                <a:ea typeface="Aptos"/>
+                <a:cs typeface="Aptos"/>
+              </a:rPr>
+              <a:t>Second certified adapter</a:t>
+            </a:r>
+          </a:p>
+        </p:txBody>
+      </p:sp>
+      <p:sp>
+        <p:nvSpPr>
+          <p:cNvPr id="29" name="decision-2-1-dot">
+            <a:extLst xmlns:a="http://schemas.openxmlformats.org/drawingml/2006/main">
+              <a:ext uri="{FF2B5EF4-FFF2-40B4-BE49-F238E27FC236}">
+                <a16:creationId xmlns:a16="http://schemas.microsoft.com/office/drawing/2014/main" id="{57D0565C-60F1-4E5B-B6F6-5979A902F611}"/>
+              </a:ext>
+            </a:extLst>
+          </p:cNvPr>
+          <p:cNvSpPr>
+            <a:spLocks xmlns:a="http://schemas.openxmlformats.org/drawingml/2006/main" noGrp="1"/>
+          </p:cNvSpPr>
+          <p:nvPr/>
+        </p:nvSpPr>
+        <p:spPr>
+          <a:xfrm xmlns:a="http://schemas.openxmlformats.org/drawingml/2006/main">
+            <a:off x="8001000" y="4391025"/>
+            <a:ext cx="66675" cy="66675"/>
+          </a:xfrm>
+          <a:prstGeom xmlns:a="http://schemas.openxmlformats.org/drawingml/2006/main" prst="ellipse">
+            <a:avLst/>
+          </a:prstGeom>
+          <a:solidFill xmlns:a="http://schemas.openxmlformats.org/drawingml/2006/main">
+            <a:srgbClr val="2DD4BF"/>
+          </a:solidFill>
+          <a:ln xmlns:a="http://schemas.openxmlformats.org/drawingml/2006/main" w="0">
+            <a:noFill/>
+            <a:prstDash val="solid"/>
+          </a:ln>
+        </p:spPr>
+      </p:sp>
+      <p:sp>
+        <p:nvSpPr>
+          <p:cNvPr id="30" name="decision-2-1">
+            <a:extLst xmlns:a="http://schemas.openxmlformats.org/drawingml/2006/main">
+              <a:ext uri="{FF2B5EF4-FFF2-40B4-BE49-F238E27FC236}">
+                <a16:creationId xmlns:a16="http://schemas.microsoft.com/office/drawing/2014/main" id="{93AC8937-A825-4CD3-8805-D56B0BD21948}"/>
+              </a:ext>
+            </a:extLst>
+          </p:cNvPr>
+          <p:cNvSpPr>
+            <a:spLocks xmlns:a="http://schemas.openxmlformats.org/drawingml/2006/main" noGrp="1"/>
+          </p:cNvSpPr>
+          <p:nvPr/>
+        </p:nvSpPr>
+        <p:spPr>
+          <a:xfrm xmlns:a="http://schemas.openxmlformats.org/drawingml/2006/main">
+            <a:off x="8191500" y="4305300"/>
+            <a:ext cx="2952750" cy="533400"/>
+          </a:xfrm>
+          <a:prstGeom xmlns:a="http://schemas.openxmlformats.org/drawingml/2006/main" prst="rect">
+            <a:avLst/>
+          </a:prstGeom>
+          <a:noFill xmlns:a="http://schemas.openxmlformats.org/drawingml/2006/main"/>
+          <a:ln xmlns:a="http://schemas.openxmlformats.org/drawingml/2006/main" w="0">
+            <a:noFill/>
+            <a:prstDash val="solid"/>
+          </a:ln>
+        </p:spPr>
+        <p:txBody>
+          <a:bodyPr xmlns:a="http://schemas.openxmlformats.org/drawingml/2006/main" wrap="square" lIns="0" tIns="0" rIns="0" bIns="0" anchor="t">
+            <a:noAutofit/>
+          </a:bodyPr>
+          <a:lstStyle xmlns:a="http://schemas.openxmlformats.org/drawingml/2006/main"/>
+          <a:p xmlns:a="http://schemas.openxmlformats.org/drawingml/2006/main">
+            <a:pPr algn="l">
+              <a:lnSpc>
+                <a:spcPct val="112000"/>
+              </a:lnSpc>
+              <a:buNone/>
+              <a:defRPr sz="1650" b="0">
+                <a:solidFill>
+                  <a:srgbClr val="EDF6F7"/>
+                </a:solidFill>
+                <a:latin typeface="Aptos"/>
+                <a:ea typeface="Aptos"/>
+                <a:cs typeface="Aptos"/>
+              </a:defRPr>
+            </a:pPr>
+            <a:r>
+              <a:rPr sz="1650" b="0">
+                <a:solidFill>
+                  <a:srgbClr val="EDF6F7"/>
+                </a:solidFill>
+                <a:latin typeface="Aptos"/>
+                <a:ea typeface="Aptos"/>
+                <a:cs typeface="Aptos"/>
+              </a:rPr>
+              <a:t>Community conformance kit</a:t>
+            </a:r>
+          </a:p>
+        </p:txBody>
+      </p:sp>
+      <p:sp>
+        <p:nvSpPr>
+          <p:cNvPr id="31" name="decision-2-2-dot">
+            <a:extLst xmlns:a="http://schemas.openxmlformats.org/drawingml/2006/main">
+              <a:ext uri="{FF2B5EF4-FFF2-40B4-BE49-F238E27FC236}">
+                <a16:creationId xmlns:a16="http://schemas.microsoft.com/office/drawing/2014/main" id="{522DC31E-2C5C-490C-A78D-D70433E9732A}"/>
+              </a:ext>
+            </a:extLst>
+          </p:cNvPr>
+          <p:cNvSpPr>
+            <a:spLocks xmlns:a="http://schemas.openxmlformats.org/drawingml/2006/main" noGrp="1"/>
+          </p:cNvSpPr>
+          <p:nvPr/>
+        </p:nvSpPr>
+        <p:spPr>
+          <a:xfrm xmlns:a="http://schemas.openxmlformats.org/drawingml/2006/main">
+            <a:off x="8001000" y="4962525"/>
+            <a:ext cx="66675" cy="66675"/>
+          </a:xfrm>
+          <a:prstGeom xmlns:a="http://schemas.openxmlformats.org/drawingml/2006/main" prst="ellipse">
+            <a:avLst/>
+          </a:prstGeom>
+          <a:solidFill xmlns:a="http://schemas.openxmlformats.org/drawingml/2006/main">
+            <a:srgbClr val="2DD4BF"/>
+          </a:solidFill>
+          <a:ln xmlns:a="http://schemas.openxmlformats.org/drawingml/2006/main" w="0">
+            <a:noFill/>
+            <a:prstDash val="solid"/>
+          </a:ln>
+        </p:spPr>
+      </p:sp>
+      <p:sp>
+        <p:nvSpPr>
+          <p:cNvPr id="32" name="decision-2-2">
+            <a:extLst xmlns:a="http://schemas.openxmlformats.org/drawingml/2006/main">
+              <a:ext uri="{FF2B5EF4-FFF2-40B4-BE49-F238E27FC236}">
+                <a16:creationId xmlns:a16="http://schemas.microsoft.com/office/drawing/2014/main" id="{3D94860B-328D-4B3A-A713-FD2E3416F661}"/>
+              </a:ext>
+            </a:extLst>
+          </p:cNvPr>
+          <p:cNvSpPr>
+            <a:spLocks xmlns:a="http://schemas.openxmlformats.org/drawingml/2006/main" noGrp="1"/>
+          </p:cNvSpPr>
+          <p:nvPr/>
+        </p:nvSpPr>
+        <p:spPr>
+          <a:xfrm xmlns:a="http://schemas.openxmlformats.org/drawingml/2006/main">
+            <a:off x="8191500" y="4876800"/>
+            <a:ext cx="2952750" cy="533400"/>
+          </a:xfrm>
+          <a:prstGeom xmlns:a="http://schemas.openxmlformats.org/drawingml/2006/main" prst="rect">
+            <a:avLst/>
+          </a:prstGeom>
+          <a:noFill xmlns:a="http://schemas.openxmlformats.org/drawingml/2006/main"/>
+          <a:ln xmlns:a="http://schemas.openxmlformats.org/drawingml/2006/main" w="0">
+            <a:noFill/>
+            <a:prstDash val="solid"/>
+          </a:ln>
+        </p:spPr>
+        <p:txBody>
+          <a:bodyPr xmlns:a="http://schemas.openxmlformats.org/drawingml/2006/main" wrap="square" lIns="0" tIns="0" rIns="0" bIns="0" anchor="t">
+            <a:noAutofit/>
+          </a:bodyPr>
+          <a:lstStyle xmlns:a="http://schemas.openxmlformats.org/drawingml/2006/main"/>
+          <a:p xmlns:a="http://schemas.openxmlformats.org/drawingml/2006/main">
+            <a:pPr algn="l">
+              <a:lnSpc>
+                <a:spcPct val="112000"/>
+              </a:lnSpc>
+              <a:buNone/>
+              <a:defRPr sz="1650" b="0">
+                <a:solidFill>
+                  <a:srgbClr val="EDF6F7"/>
+                </a:solidFill>
+                <a:latin typeface="Aptos"/>
+                <a:ea typeface="Aptos"/>
+                <a:cs typeface="Aptos"/>
+              </a:defRPr>
+            </a:pPr>
+            <a:r>
+              <a:rPr sz="1650" b="0">
+                <a:solidFill>
+                  <a:srgbClr val="EDF6F7"/>
+                </a:solidFill>
+                <a:latin typeface="Aptos"/>
+                <a:ea typeface="Aptos"/>
+                <a:cs typeface="Aptos"/>
+              </a:rPr>
+              <a:t>Pilot case study + SBOM</a:t>
+            </a:r>
+          </a:p>
+        </p:txBody>
+      </p:sp>
+      <p:sp>
+        <p:nvSpPr>
+          <p:cNvPr id="33" name="decision-callout">
+            <a:extLst xmlns:a="http://schemas.openxmlformats.org/drawingml/2006/main">
+              <a:ext uri="{FF2B5EF4-FFF2-40B4-BE49-F238E27FC236}">
+                <a16:creationId xmlns:a16="http://schemas.microsoft.com/office/drawing/2014/main" id="{974E09E0-C6BE-4454-9334-85B251BC9C2D}"/>
+              </a:ext>
+            </a:extLst>
+          </p:cNvPr>
+          <p:cNvSpPr>
+            <a:spLocks xmlns:a="http://schemas.openxmlformats.org/drawingml/2006/main" noGrp="1"/>
+          </p:cNvSpPr>
+          <p:nvPr/>
+        </p:nvSpPr>
+        <p:spPr>
+          <a:xfrm xmlns:a="http://schemas.openxmlformats.org/drawingml/2006/main">
+            <a:off x="609600" y="5676900"/>
+            <a:ext cx="10972800" cy="685800"/>
+          </a:xfrm>
+          <a:prstGeom xmlns:a="http://schemas.openxmlformats.org/drawingml/2006/main" prst="roundRect">
+            <a:avLst>
+              <a:gd name="adj" fmla="val 16667"/>
+            </a:avLst>
+          </a:prstGeom>
+          <a:solidFill xmlns:a="http://schemas.openxmlformats.org/drawingml/2006/main">
+            <a:srgbClr val="103B3B"/>
+          </a:solidFill>
+          <a:ln xmlns:a="http://schemas.openxmlformats.org/drawingml/2006/main" w="9525">
+            <a:solidFill>
+              <a:srgbClr val="1D615D"/>
+            </a:solidFill>
+            <a:prstDash val="solid"/>
+          </a:ln>
+        </p:spPr>
+      </p:sp>
+      <p:sp>
+        <p:nvSpPr>
+          <p:cNvPr id="34" name="decision-callout-text">
+            <a:extLst xmlns:a="http://schemas.openxmlformats.org/drawingml/2006/main">
+              <a:ext uri="{FF2B5EF4-FFF2-40B4-BE49-F238E27FC236}">
+                <a16:creationId xmlns:a16="http://schemas.microsoft.com/office/drawing/2014/main" id="{600489BF-E3C0-41B7-800E-BC16AAA15391}"/>
+              </a:ext>
+            </a:extLst>
+          </p:cNvPr>
+          <p:cNvSpPr>
+            <a:spLocks xmlns:a="http://schemas.openxmlformats.org/drawingml/2006/main" noGrp="1"/>
+          </p:cNvSpPr>
+          <p:nvPr/>
+        </p:nvSpPr>
+        <p:spPr>
+          <a:xfrm xmlns:a="http://schemas.openxmlformats.org/drawingml/2006/main">
+            <a:off x="876300" y="5876925"/>
+            <a:ext cx="10287000" cy="285750"/>
+          </a:xfrm>
+          <a:prstGeom xmlns:a="http://schemas.openxmlformats.org/drawingml/2006/main" prst="rect">
+            <a:avLst/>
+          </a:prstGeom>
+          <a:noFill xmlns:a="http://schemas.openxmlformats.org/drawingml/2006/main"/>
+          <a:ln xmlns:a="http://schemas.openxmlformats.org/drawingml/2006/main" w="0">
+            <a:noFill/>
+            <a:prstDash val="solid"/>
+          </a:ln>
+        </p:spPr>
+        <p:txBody>
+          <a:bodyPr xmlns:a="http://schemas.openxmlformats.org/drawingml/2006/main" wrap="square" lIns="0" tIns="0" rIns="0" bIns="0" anchor="t">
+            <a:noAutofit/>
+          </a:bodyPr>
+          <a:lstStyle xmlns:a="http://schemas.openxmlformats.org/drawingml/2006/main"/>
+          <a:p xmlns:a="http://schemas.openxmlformats.org/drawingml/2006/main">
+            <a:pPr algn="ctr">
+              <a:lnSpc>
+                <a:spcPct val="108000"/>
+              </a:lnSpc>
+              <a:buNone/>
+              <a:defRPr sz="1800" b="1">
+                <a:solidFill>
+                  <a:srgbClr val="EDF6F7"/>
+                </a:solidFill>
+                <a:latin typeface="Aptos"/>
+                <a:ea typeface="Aptos"/>
+                <a:cs typeface="Aptos"/>
+              </a:defRPr>
+            </a:pPr>
+            <a:r>
+              <a:rPr sz="1800" b="1">
+                <a:solidFill>
+                  <a:srgbClr val="EDF6F7"/>
+                </a:solidFill>
+                <a:latin typeface="Aptos"/>
+                <a:ea typeface="Aptos"/>
+                <a:cs typeface="Aptos"/>
+              </a:rPr>
+              <a:t>Scale after independent install, isolation, drift, and revocation evidence.</a:t>
             </a:r>
           </a:p>
         </p:txBody>
@@ -19561,7 +21419,7 @@
           <p:nvPr/>
         </p:nvPicPr>
         <p:blipFill>
-          <a:blip xmlns:r="http://schemas.openxmlformats.org/officeDocument/2006/relationships" xmlns:a="http://schemas.openxmlformats.org/drawingml/2006/main" r:embed="R39e3e3b2ea8547bb"/>
+          <a:blip xmlns:r="http://schemas.openxmlformats.org/officeDocument/2006/relationships" xmlns:a="http://schemas.openxmlformats.org/drawingml/2006/main" r:embed="R8f0dfc06162848f1"/>
           <a:srcRect xmlns:a="http://schemas.openxmlformats.org/drawingml/2006/main" l="0" t="0" r="0" b="0"/>
           <a:stretch xmlns:a="http://schemas.openxmlformats.org/drawingml/2006/main">
             <a:fillRect l="0" t="0" r="0" b="0"/>
@@ -19627,7 +21485,7 @@
           <p:nvPr/>
         </p:nvPicPr>
         <p:blipFill>
-          <a:blip xmlns:r="http://schemas.openxmlformats.org/officeDocument/2006/relationships" xmlns:a="http://schemas.openxmlformats.org/drawingml/2006/main" r:embed="R4d39c450e25d4870"/>
+          <a:blip xmlns:r="http://schemas.openxmlformats.org/officeDocument/2006/relationships" xmlns:a="http://schemas.openxmlformats.org/drawingml/2006/main" r:embed="Rf6e536fda6cb453d"/>
           <a:srcRect xmlns:a="http://schemas.openxmlformats.org/drawingml/2006/main" l="0" t="11766" r="0" b="11766"/>
           <a:stretch xmlns:a="http://schemas.openxmlformats.org/drawingml/2006/main">
             <a:fillRect l="0" t="0" r="0" b="0"/>

</xml_diff>

<commit_message>
Launch PurposeMesh v0.1 technical preview (#15)
Publish the evidence-gated technical preview, hardened Docker demo, release and supply-chain workflows, roadmap, updated brief, and executive architecture deck.
</commit_message>
<xml_diff>
--- a/docs/PurposeMesh-Executive-Architecture-Briefing.pptx
+++ b/docs/PurposeMesh-Executive-Architecture-Briefing.pptx
@@ -2,26 +2,27 @@
 <file path=ppt/presentation.xml><?xml version="1.0" encoding="utf-8"?>
 <p:presentation xmlns:p="http://schemas.openxmlformats.org/presentationml/2006/main">
   <p:sldMasterIdLst>
-    <p:sldMasterId xmlns:r="http://schemas.openxmlformats.org/officeDocument/2006/relationships" id="2147483648" r:id="R8bfa5b3defd04f9f"/>
+    <p:sldMasterId xmlns:r="http://schemas.openxmlformats.org/officeDocument/2006/relationships" id="2147483648" r:id="Rd812c8a17f874f7e"/>
   </p:sldMasterIdLst>
   <p:notesMasterIdLst>
-    <p:notesMasterId xmlns:r="http://schemas.openxmlformats.org/officeDocument/2006/relationships" r:id="Rd2e0ae57f2ae4a40"/>
+    <p:notesMasterId xmlns:r="http://schemas.openxmlformats.org/officeDocument/2006/relationships" r:id="Ra8efcc42d47d4d66"/>
   </p:notesMasterIdLst>
   <p:sldIdLst>
-    <p:sldId xmlns:r="http://schemas.openxmlformats.org/officeDocument/2006/relationships" id="256" r:id="Rc04614bb3e7648b3"/>
-    <p:sldId xmlns:r="http://schemas.openxmlformats.org/officeDocument/2006/relationships" id="257" r:id="R7247a06aa22d4364"/>
-    <p:sldId xmlns:r="http://schemas.openxmlformats.org/officeDocument/2006/relationships" id="258" r:id="R4514b02258f04ec7"/>
-    <p:sldId xmlns:r="http://schemas.openxmlformats.org/officeDocument/2006/relationships" id="259" r:id="R76ffd7c16b3f4c6b"/>
-    <p:sldId xmlns:r="http://schemas.openxmlformats.org/officeDocument/2006/relationships" id="260" r:id="Ra31b30669880468b"/>
-    <p:sldId xmlns:r="http://schemas.openxmlformats.org/officeDocument/2006/relationships" id="261" r:id="Re329eb6f4c0b42d3"/>
-    <p:sldId xmlns:r="http://schemas.openxmlformats.org/officeDocument/2006/relationships" id="262" r:id="R426c01a2281a40be"/>
-    <p:sldId xmlns:r="http://schemas.openxmlformats.org/officeDocument/2006/relationships" id="263" r:id="R7be70ffc3ff9499d"/>
-    <p:sldId xmlns:r="http://schemas.openxmlformats.org/officeDocument/2006/relationships" id="264" r:id="R1e27cb89b1a345b1"/>
-    <p:sldId xmlns:r="http://schemas.openxmlformats.org/officeDocument/2006/relationships" id="265" r:id="R49b8067c803e49df"/>
-    <p:sldId xmlns:r="http://schemas.openxmlformats.org/officeDocument/2006/relationships" id="266" r:id="R5075fb8a9a2642b3"/>
-    <p:sldId xmlns:r="http://schemas.openxmlformats.org/officeDocument/2006/relationships" id="267" r:id="Rb20494efcc18403c"/>
-    <p:sldId xmlns:r="http://schemas.openxmlformats.org/officeDocument/2006/relationships" id="268" r:id="R2c34c830812b4532"/>
-    <p:sldId xmlns:r="http://schemas.openxmlformats.org/officeDocument/2006/relationships" id="269" r:id="R53e039efa75c4069"/>
+    <p:sldId xmlns:r="http://schemas.openxmlformats.org/officeDocument/2006/relationships" id="256" r:id="R59f99f9b9d74458c"/>
+    <p:sldId xmlns:r="http://schemas.openxmlformats.org/officeDocument/2006/relationships" id="257" r:id="R85b198de23c44b9d"/>
+    <p:sldId xmlns:r="http://schemas.openxmlformats.org/officeDocument/2006/relationships" id="258" r:id="Rc1ff14263ac246ba"/>
+    <p:sldId xmlns:r="http://schemas.openxmlformats.org/officeDocument/2006/relationships" id="259" r:id="R6c2fd270de104a56"/>
+    <p:sldId xmlns:r="http://schemas.openxmlformats.org/officeDocument/2006/relationships" id="260" r:id="R4c326b048f784915"/>
+    <p:sldId xmlns:r="http://schemas.openxmlformats.org/officeDocument/2006/relationships" id="261" r:id="Ra26eca051f324db7"/>
+    <p:sldId xmlns:r="http://schemas.openxmlformats.org/officeDocument/2006/relationships" id="262" r:id="Rdf18d1ae66ed4eb7"/>
+    <p:sldId xmlns:r="http://schemas.openxmlformats.org/officeDocument/2006/relationships" id="263" r:id="Rcb4b1b9e2e224f3d"/>
+    <p:sldId xmlns:r="http://schemas.openxmlformats.org/officeDocument/2006/relationships" id="264" r:id="Ra692555593f241e8"/>
+    <p:sldId xmlns:r="http://schemas.openxmlformats.org/officeDocument/2006/relationships" id="265" r:id="R659d0fb7cd564ec5"/>
+    <p:sldId xmlns:r="http://schemas.openxmlformats.org/officeDocument/2006/relationships" id="266" r:id="R3529bd9c7b1f4fd8"/>
+    <p:sldId xmlns:r="http://schemas.openxmlformats.org/officeDocument/2006/relationships" id="267" r:id="R4058226cd6c54b76"/>
+    <p:sldId xmlns:r="http://schemas.openxmlformats.org/officeDocument/2006/relationships" id="268" r:id="R01718c7d87bc4368"/>
+    <p:sldId xmlns:r="http://schemas.openxmlformats.org/officeDocument/2006/relationships" id="269" r:id="R2dd46d7186cb4ab9"/>
+    <p:sldId xmlns:r="http://schemas.openxmlformats.org/officeDocument/2006/relationships" id="270" r:id="R5eb1822fd8a0425a"/>
   </p:sldIdLst>
   <p:sldSz cx="12192000" cy="6858000"/>
   <p:notesSz cx="6858000" cy="9144000"/>
@@ -1030,6 +1031,86 @@
 </p:notes>
 </file>
 
+<file path=ppt/notesSlides/notesSlide15.xml><?xml version="1.0" encoding="utf-8"?>
+<p:notes xmlns:p="http://schemas.openxmlformats.org/presentationml/2006/main">
+  <p:cSld>
+    <p:spTree>
+      <p:nvGrpSpPr>
+        <p:cNvPr id="1" name=""/>
+        <p:cNvGrpSpPr/>
+        <p:nvPr/>
+      </p:nvGrpSpPr>
+      <p:grpSpPr>
+        <a:xfrm xmlns:a="http://schemas.openxmlformats.org/drawingml/2006/main"/>
+      </p:grpSpPr>
+      <p:sp>
+        <p:nvSpPr>
+          <p:cNvPr id="2" name="Slide Image Placeholder 1"/>
+          <p:cNvSpPr>
+            <a:spLocks xmlns:a="http://schemas.openxmlformats.org/drawingml/2006/main" noGrp="1"/>
+          </p:cNvSpPr>
+          <p:nvPr>
+            <p:ph type="sldImg" idx="0"/>
+          </p:nvPr>
+        </p:nvSpPr>
+        <p:spPr/>
+      </p:sp>
+      <p:sp>
+        <p:nvSpPr>
+          <p:cNvPr id="3" name="Notes Placeholder 2"/>
+          <p:cNvSpPr>
+            <a:spLocks xmlns:a="http://schemas.openxmlformats.org/drawingml/2006/main" noGrp="1"/>
+          </p:cNvSpPr>
+          <p:nvPr>
+            <p:ph type="body" idx="1"/>
+          </p:nvPr>
+        </p:nvSpPr>
+        <p:spPr/>
+        <p:txBody>
+          <a:bodyPr xmlns:a="http://schemas.openxmlformats.org/drawingml/2006/main"/>
+          <a:lstStyle xmlns:a="http://schemas.openxmlformats.org/drawingml/2006/main"/>
+          <a:p xmlns:a="http://schemas.openxmlformats.org/drawingml/2006/main">
+            <a:r>
+              <a:t>[Sources]</a:t>
+            </a:r>
+          </a:p>
+          <a:p xmlns:a="http://schemas.openxmlformats.org/drawingml/2006/main">
+            <a:r>
+              <a:t>- https://openid.net/specs/authorization-api-1_0-final.html — AuthZEN Authorization API 1.0 final specification (accessed 16 August 2026).</a:t>
+            </a:r>
+          </a:p>
+          <a:p xmlns:a="http://schemas.openxmlformats.org/drawingml/2006/main">
+            <a:r>
+              <a:t>[/Sources]</a:t>
+            </a:r>
+          </a:p>
+        </p:txBody>
+      </p:sp>
+      <p:sp>
+        <p:nvSpPr>
+          <p:cNvPr id="4" name="Slide Number Placeholder 3"/>
+          <p:cNvSpPr>
+            <a:spLocks xmlns:a="http://schemas.openxmlformats.org/drawingml/2006/main" noGrp="1"/>
+          </p:cNvSpPr>
+          <p:nvPr>
+            <p:ph type="sldNum" idx="5"/>
+          </p:nvPr>
+        </p:nvSpPr>
+        <p:spPr/>
+        <p:txBody>
+          <a:bodyPr xmlns:a="http://schemas.openxmlformats.org/drawingml/2006/main"/>
+          <a:lstStyle xmlns:a="http://schemas.openxmlformats.org/drawingml/2006/main"/>
+          <a:p xmlns:a="http://schemas.openxmlformats.org/drawingml/2006/main"/>
+        </p:txBody>
+      </p:sp>
+    </p:spTree>
+  </p:cSld>
+  <p:clrMapOvr>
+    <a:masterClrMapping xmlns:a="http://schemas.openxmlformats.org/drawingml/2006/main"/>
+  </p:clrMapOvr>
+</p:notes>
+</file>
+
 <file path=ppt/notesSlides/notesSlide2.xml><?xml version="1.0" encoding="utf-8"?>
 <p:notes xmlns:p="http://schemas.openxmlformats.org/presentationml/2006/main">
   <p:cSld>
@@ -1858,7 +1939,7 @@
   </p:cSld>
   <p:clrMap bg1="lt1" tx1="dk1" bg2="lt2" tx2="dk2" accent1="accent1" accent2="accent2" accent3="accent3" accent4="accent4" accent5="accent5" accent6="accent6" hlink="hlink" folHlink="folHlink"/>
   <p:sldLayoutIdLst>
-    <p:sldLayoutId xmlns:r="http://schemas.openxmlformats.org/officeDocument/2006/relationships" id="2147483649" r:id="R015d4eed44b445fc"/>
+    <p:sldLayoutId xmlns:r="http://schemas.openxmlformats.org/officeDocument/2006/relationships" id="2147483649" r:id="Rdaf115554f1f43e8"/>
   </p:sldLayoutIdLst>
   <p:txStyles>
     <p:titleStyle>
@@ -10088,7 +10169,1784 @@
                 <a:ea typeface="Aptos"/>
                 <a:cs typeface="Aptos"/>
               </a:rPr>
-              <a:t>One dataset + purpose, two personas, one connector. Scale only after allow/deny, read-back, drift, identity, and recovery pass.</a:t>
+              <a:t>Pilot one dataset and connector; scale after read-back, drift, and recovery pass.</a:t>
+            </a:r>
+          </a:p>
+        </p:txBody>
+      </p:sp>
+      <p:sp>
+        <p:nvSpPr>
+          <p:cNvPr id="35" name="brand-9">
+            <a:extLst xmlns:a="http://schemas.openxmlformats.org/drawingml/2006/main">
+              <a:ext uri="{FF2B5EF4-FFF2-40B4-BE49-F238E27FC236}">
+                <a16:creationId xmlns:a16="http://schemas.microsoft.com/office/drawing/2014/main" id="{B112E3BB-DFB7-4F02-91C9-347E1094D734}"/>
+              </a:ext>
+            </a:extLst>
+          </p:cNvPr>
+          <p:cNvSpPr>
+            <a:spLocks xmlns:a="http://schemas.openxmlformats.org/drawingml/2006/main" noGrp="1"/>
+          </p:cNvSpPr>
+          <p:nvPr/>
+        </p:nvSpPr>
+        <p:spPr>
+          <a:xfrm xmlns:a="http://schemas.openxmlformats.org/drawingml/2006/main">
+            <a:off x="609600" y="266700"/>
+            <a:ext cx="1257300" cy="247650"/>
+          </a:xfrm>
+          <a:prstGeom xmlns:a="http://schemas.openxmlformats.org/drawingml/2006/main" prst="rect">
+            <a:avLst/>
+          </a:prstGeom>
+          <a:noFill xmlns:a="http://schemas.openxmlformats.org/drawingml/2006/main"/>
+          <a:ln xmlns:a="http://schemas.openxmlformats.org/drawingml/2006/main" w="0">
+            <a:noFill/>
+            <a:prstDash val="solid"/>
+          </a:ln>
+        </p:spPr>
+        <p:txBody>
+          <a:bodyPr xmlns:a="http://schemas.openxmlformats.org/drawingml/2006/main" wrap="square" lIns="0" tIns="0" rIns="0" bIns="0" anchor="t">
+            <a:normAutofit fontScale="100000"/>
+          </a:bodyPr>
+          <a:lstStyle xmlns:a="http://schemas.openxmlformats.org/drawingml/2006/main"/>
+          <a:p xmlns:a="http://schemas.openxmlformats.org/drawingml/2006/main">
+            <a:pPr algn="l">
+              <a:lnSpc>
+                <a:spcPct val="108000"/>
+              </a:lnSpc>
+              <a:buNone/>
+              <a:defRPr sz="1350" b="1">
+                <a:solidFill>
+                  <a:srgbClr val="2DD4BF"/>
+                </a:solidFill>
+                <a:latin typeface="Aptos"/>
+                <a:ea typeface="Aptos"/>
+                <a:cs typeface="Aptos"/>
+              </a:defRPr>
+            </a:pPr>
+            <a:r>
+              <a:rPr sz="1050" b="1">
+                <a:solidFill>
+                  <a:srgbClr val="2DD4BF"/>
+                </a:solidFill>
+                <a:latin typeface="Aptos"/>
+                <a:ea typeface="Aptos"/>
+                <a:cs typeface="Aptos"/>
+              </a:rPr>
+              <a:t>PurposeMesh</a:t>
+            </a:r>
+          </a:p>
+        </p:txBody>
+      </p:sp>
+    </p:spTree>
+    <p:extLst>
+      <p:ext uri="{BB962C8B-B14F-4D97-AF65-F5344CB8AC3E}">
+        <p14:creationId xmlns:p14="http://schemas.microsoft.com/office/powerpoint/2010/main" val="1391688617"/>
+      </p:ext>
+    </p:extLst>
+  </p:cSld>
+</p:sld>
+</file>
+
+<file path=ppt/slides/slide15.xml><?xml version="1.0" encoding="utf-8"?>
+<p:sld xmlns:p="http://schemas.openxmlformats.org/presentationml/2006/main">
+  <p:cSld>
+    <p:bg>
+      <p:bgPr>
+        <a:solidFill xmlns:a="http://schemas.openxmlformats.org/drawingml/2006/main">
+          <a:srgbClr val="071014"/>
+        </a:solidFill>
+      </p:bgPr>
+    </p:bg>
+    <p:spTree>
+      <p:nvGrpSpPr>
+        <p:cNvPr id="1" name=""/>
+        <p:cNvGrpSpPr/>
+        <p:nvPr/>
+      </p:nvGrpSpPr>
+      <p:grpSpPr>
+        <a:xfrm xmlns:a="http://schemas.openxmlformats.org/drawingml/2006/main"/>
+      </p:grpSpPr>
+      <p:sp>
+        <p:nvSpPr>
+          <p:cNvPr id="36" name="title-9">
+            <a:extLst xmlns:a="http://schemas.openxmlformats.org/drawingml/2006/main">
+              <a:ext uri="{FF2B5EF4-FFF2-40B4-BE49-F238E27FC236}">
+                <a16:creationId xmlns:a16="http://schemas.microsoft.com/office/drawing/2014/main" id="{4C73BD00-A2DE-49B5-BAFA-99C4ADF5BE23}"/>
+              </a:ext>
+            </a:extLst>
+          </p:cNvPr>
+          <p:cNvSpPr>
+            <a:spLocks xmlns:a="http://schemas.openxmlformats.org/drawingml/2006/main" noGrp="1"/>
+          </p:cNvSpPr>
+          <p:nvPr/>
+        </p:nvSpPr>
+        <p:spPr>
+          <a:xfrm xmlns:a="http://schemas.openxmlformats.org/drawingml/2006/main">
+            <a:off x="609600" y="723900"/>
+            <a:ext cx="10972800" cy="647700"/>
+          </a:xfrm>
+          <a:prstGeom xmlns:a="http://schemas.openxmlformats.org/drawingml/2006/main" prst="rect">
+            <a:avLst/>
+          </a:prstGeom>
+          <a:noFill xmlns:a="http://schemas.openxmlformats.org/drawingml/2006/main"/>
+          <a:ln xmlns:a="http://schemas.openxmlformats.org/drawingml/2006/main" w="0">
+            <a:noFill/>
+            <a:prstDash val="solid"/>
+          </a:ln>
+        </p:spPr>
+        <p:txBody>
+          <a:bodyPr xmlns:a="http://schemas.openxmlformats.org/drawingml/2006/main" wrap="square" lIns="0" tIns="0" rIns="0" bIns="0" anchor="t">
+            <a:noAutofit/>
+          </a:bodyPr>
+          <a:lstStyle xmlns:a="http://schemas.openxmlformats.org/drawingml/2006/main"/>
+          <a:p xmlns:a="http://schemas.openxmlformats.org/drawingml/2006/main">
+            <a:pPr algn="l">
+              <a:lnSpc>
+                <a:spcPct val="96000"/>
+              </a:lnSpc>
+              <a:buNone/>
+              <a:defRPr sz="3750" b="1">
+                <a:solidFill>
+                  <a:srgbClr val="EDF6F7"/>
+                </a:solidFill>
+                <a:latin typeface="Aptos"/>
+                <a:ea typeface="Aptos"/>
+                <a:cs typeface="Aptos"/>
+              </a:defRPr>
+            </a:pPr>
+            <a:r>
+              <a:rPr sz="3750" b="1">
+                <a:solidFill>
+                  <a:srgbClr val="EDF6F7"/>
+                </a:solidFill>
+                <a:latin typeface="Aptos"/>
+                <a:ea typeface="Aptos"/>
+                <a:cs typeface="Aptos"/>
+              </a:rPr>
+              <a:t>Roadmap: prove enforcement, then expand</a:t>
+            </a:r>
+          </a:p>
+        </p:txBody>
+      </p:sp>
+      <p:sp>
+        <p:nvSpPr>
+          <p:cNvPr id="2" name="subtitle-9">
+            <a:extLst xmlns:a="http://schemas.openxmlformats.org/drawingml/2006/main">
+              <a:ext uri="{FF2B5EF4-FFF2-40B4-BE49-F238E27FC236}">
+                <a16:creationId xmlns:a16="http://schemas.microsoft.com/office/drawing/2014/main" id="{416668E3-A93D-4622-A2D8-11C1608AF9D2}"/>
+              </a:ext>
+            </a:extLst>
+          </p:cNvPr>
+          <p:cNvSpPr>
+            <a:spLocks xmlns:a="http://schemas.openxmlformats.org/drawingml/2006/main" noGrp="1"/>
+          </p:cNvSpPr>
+          <p:nvPr/>
+        </p:nvSpPr>
+        <p:spPr>
+          <a:xfrm xmlns:a="http://schemas.openxmlformats.org/drawingml/2006/main">
+            <a:off x="609600" y="1466850"/>
+            <a:ext cx="10001250" cy="552450"/>
+          </a:xfrm>
+          <a:prstGeom xmlns:a="http://schemas.openxmlformats.org/drawingml/2006/main" prst="rect">
+            <a:avLst/>
+          </a:prstGeom>
+          <a:noFill xmlns:a="http://schemas.openxmlformats.org/drawingml/2006/main"/>
+          <a:ln xmlns:a="http://schemas.openxmlformats.org/drawingml/2006/main" w="0">
+            <a:noFill/>
+            <a:prstDash val="solid"/>
+          </a:ln>
+        </p:spPr>
+        <p:txBody>
+          <a:bodyPr xmlns:a="http://schemas.openxmlformats.org/drawingml/2006/main" wrap="square" lIns="0" tIns="0" rIns="0" bIns="0" anchor="t">
+            <a:noAutofit/>
+          </a:bodyPr>
+          <a:lstStyle xmlns:a="http://schemas.openxmlformats.org/drawingml/2006/main"/>
+          <a:p xmlns:a="http://schemas.openxmlformats.org/drawingml/2006/main">
+            <a:pPr algn="l">
+              <a:lnSpc>
+                <a:spcPct val="115000"/>
+              </a:lnSpc>
+              <a:buNone/>
+              <a:defRPr sz="1650" b="0">
+                <a:solidFill>
+                  <a:srgbClr val="9CB0B5"/>
+                </a:solidFill>
+                <a:latin typeface="Aptos"/>
+                <a:ea typeface="Aptos"/>
+                <a:cs typeface="Aptos"/>
+              </a:defRPr>
+            </a:pPr>
+            <a:r>
+              <a:rPr sz="1650" b="0">
+                <a:solidFill>
+                  <a:srgbClr val="9CB0B5"/>
+                </a:solidFill>
+                <a:latin typeface="Aptos"/>
+                <a:ea typeface="Aptos"/>
+                <a:cs typeface="Aptos"/>
+              </a:rPr>
+              <a:t>Trust grows in stages: reproducible local proof, one certified target, then scale.</a:t>
+            </a:r>
+          </a:p>
+        </p:txBody>
+      </p:sp>
+      <p:sp>
+        <p:nvSpPr>
+          <p:cNvPr id="3" name="top-accent-9">
+            <a:extLst xmlns:a="http://schemas.openxmlformats.org/drawingml/2006/main">
+              <a:ext uri="{FF2B5EF4-FFF2-40B4-BE49-F238E27FC236}">
+                <a16:creationId xmlns:a16="http://schemas.microsoft.com/office/drawing/2014/main" id="{FB18E914-8A72-4C23-83DC-83667C1A3D05}"/>
+              </a:ext>
+            </a:extLst>
+          </p:cNvPr>
+          <p:cNvSpPr>
+            <a:spLocks xmlns:a="http://schemas.openxmlformats.org/drawingml/2006/main" noGrp="1"/>
+          </p:cNvSpPr>
+          <p:nvPr/>
+        </p:nvSpPr>
+        <p:spPr>
+          <a:xfrm xmlns:a="http://schemas.openxmlformats.org/drawingml/2006/main">
+            <a:off x="0" y="0"/>
+            <a:ext cx="12192000" cy="38100"/>
+          </a:xfrm>
+          <a:prstGeom xmlns:a="http://schemas.openxmlformats.org/drawingml/2006/main" prst="roundRect">
+            <a:avLst>
+              <a:gd name="adj" fmla="val 50000"/>
+            </a:avLst>
+          </a:prstGeom>
+          <a:solidFill xmlns:a="http://schemas.openxmlformats.org/drawingml/2006/main">
+            <a:srgbClr val="2DD4BF"/>
+          </a:solidFill>
+          <a:ln xmlns:a="http://schemas.openxmlformats.org/drawingml/2006/main" w="0">
+            <a:noFill/>
+            <a:prstDash val="solid"/>
+          </a:ln>
+        </p:spPr>
+      </p:sp>
+      <p:sp>
+        <p:nvSpPr>
+          <p:cNvPr id="4" name="section-9">
+            <a:extLst xmlns:a="http://schemas.openxmlformats.org/drawingml/2006/main">
+              <a:ext uri="{FF2B5EF4-FFF2-40B4-BE49-F238E27FC236}">
+                <a16:creationId xmlns:a16="http://schemas.microsoft.com/office/drawing/2014/main" id="{F4C91E87-BD8A-44C4-9A25-AC3C3AC68431}"/>
+              </a:ext>
+            </a:extLst>
+          </p:cNvPr>
+          <p:cNvSpPr>
+            <a:spLocks xmlns:a="http://schemas.openxmlformats.org/drawingml/2006/main" noGrp="1"/>
+          </p:cNvSpPr>
+          <p:nvPr/>
+        </p:nvSpPr>
+        <p:spPr>
+          <a:xfrm xmlns:a="http://schemas.openxmlformats.org/drawingml/2006/main">
+            <a:off x="1619250" y="285750"/>
+            <a:ext cx="6858000" cy="209550"/>
+          </a:xfrm>
+          <a:prstGeom xmlns:a="http://schemas.openxmlformats.org/drawingml/2006/main" prst="rect">
+            <a:avLst/>
+          </a:prstGeom>
+          <a:noFill xmlns:a="http://schemas.openxmlformats.org/drawingml/2006/main"/>
+          <a:ln xmlns:a="http://schemas.openxmlformats.org/drawingml/2006/main" w="0">
+            <a:noFill/>
+            <a:prstDash val="solid"/>
+          </a:ln>
+        </p:spPr>
+        <p:txBody>
+          <a:bodyPr xmlns:a="http://schemas.openxmlformats.org/drawingml/2006/main" wrap="square" lIns="0" tIns="0" rIns="0" bIns="0" anchor="t">
+            <a:noAutofit/>
+          </a:bodyPr>
+          <a:lstStyle xmlns:a="http://schemas.openxmlformats.org/drawingml/2006/main"/>
+          <a:p xmlns:a="http://schemas.openxmlformats.org/drawingml/2006/main">
+            <a:pPr algn="l">
+              <a:lnSpc>
+                <a:spcPct val="108000"/>
+              </a:lnSpc>
+              <a:buNone/>
+              <a:defRPr sz="1050" b="1">
+                <a:solidFill>
+                  <a:srgbClr val="6F858B"/>
+                </a:solidFill>
+                <a:latin typeface="Aptos"/>
+                <a:ea typeface="Aptos"/>
+                <a:cs typeface="Aptos"/>
+              </a:defRPr>
+            </a:pPr>
+            <a:r>
+              <a:rPr sz="1050" b="1">
+                <a:solidFill>
+                  <a:srgbClr val="6F858B"/>
+                </a:solidFill>
+                <a:latin typeface="Aptos"/>
+                <a:ea typeface="Aptos"/>
+                <a:cs typeface="Aptos"/>
+              </a:rPr>
+              <a:t>PUBLIC ROADMAP</a:t>
+            </a:r>
+          </a:p>
+        </p:txBody>
+      </p:sp>
+      <p:sp>
+        <p:nvSpPr>
+          <p:cNvPr id="5" name="page-9">
+            <a:extLst xmlns:a="http://schemas.openxmlformats.org/drawingml/2006/main">
+              <a:ext uri="{FF2B5EF4-FFF2-40B4-BE49-F238E27FC236}">
+                <a16:creationId xmlns:a16="http://schemas.microsoft.com/office/drawing/2014/main" id="{BF242CCA-07DF-4B74-9D95-10AD31EA3FA7}"/>
+              </a:ext>
+            </a:extLst>
+          </p:cNvPr>
+          <p:cNvSpPr>
+            <a:spLocks xmlns:a="http://schemas.openxmlformats.org/drawingml/2006/main" noGrp="1"/>
+          </p:cNvSpPr>
+          <p:nvPr/>
+        </p:nvSpPr>
+        <p:spPr>
+          <a:xfrm xmlns:a="http://schemas.openxmlformats.org/drawingml/2006/main">
+            <a:off x="11049000" y="285750"/>
+            <a:ext cx="533400" cy="209550"/>
+          </a:xfrm>
+          <a:prstGeom xmlns:a="http://schemas.openxmlformats.org/drawingml/2006/main" prst="rect">
+            <a:avLst/>
+          </a:prstGeom>
+          <a:noFill xmlns:a="http://schemas.openxmlformats.org/drawingml/2006/main"/>
+          <a:ln xmlns:a="http://schemas.openxmlformats.org/drawingml/2006/main" w="0">
+            <a:noFill/>
+            <a:prstDash val="solid"/>
+          </a:ln>
+        </p:spPr>
+        <p:txBody>
+          <a:bodyPr xmlns:a="http://schemas.openxmlformats.org/drawingml/2006/main" wrap="square" lIns="0" tIns="0" rIns="0" bIns="0" anchor="t">
+            <a:noAutofit/>
+          </a:bodyPr>
+          <a:lstStyle xmlns:a="http://schemas.openxmlformats.org/drawingml/2006/main"/>
+          <a:p xmlns:a="http://schemas.openxmlformats.org/drawingml/2006/main">
+            <a:pPr algn="r">
+              <a:lnSpc>
+                <a:spcPct val="108000"/>
+              </a:lnSpc>
+              <a:buNone/>
+              <a:defRPr sz="1050" b="1">
+                <a:solidFill>
+                  <a:srgbClr val="6F858B"/>
+                </a:solidFill>
+                <a:latin typeface="Aptos"/>
+                <a:ea typeface="Aptos"/>
+                <a:cs typeface="Aptos"/>
+              </a:defRPr>
+            </a:pPr>
+            <a:r>
+              <a:rPr sz="1050" b="1">
+                <a:solidFill>
+                  <a:srgbClr val="6F858B"/>
+                </a:solidFill>
+                <a:latin typeface="Aptos"/>
+                <a:ea typeface="Aptos"/>
+                <a:cs typeface="Aptos"/>
+              </a:rPr>
+              <a:t>15</a:t>
+            </a:r>
+          </a:p>
+        </p:txBody>
+      </p:sp>
+      <p:sp>
+        <p:nvSpPr>
+          <p:cNvPr id="6" name="decision-accent-0">
+            <a:extLst xmlns:a="http://schemas.openxmlformats.org/drawingml/2006/main">
+              <a:ext uri="{FF2B5EF4-FFF2-40B4-BE49-F238E27FC236}">
+                <a16:creationId xmlns:a16="http://schemas.microsoft.com/office/drawing/2014/main" id="{57800E63-16B5-445A-A654-FD9DFBC7E3FA}"/>
+              </a:ext>
+            </a:extLst>
+          </p:cNvPr>
+          <p:cNvSpPr>
+            <a:spLocks xmlns:a="http://schemas.openxmlformats.org/drawingml/2006/main" noGrp="1"/>
+          </p:cNvSpPr>
+          <p:nvPr/>
+        </p:nvSpPr>
+        <p:spPr>
+          <a:xfrm xmlns:a="http://schemas.openxmlformats.org/drawingml/2006/main">
+            <a:off x="609600" y="2343150"/>
+            <a:ext cx="3143250" cy="38100"/>
+          </a:xfrm>
+          <a:prstGeom xmlns:a="http://schemas.openxmlformats.org/drawingml/2006/main" prst="roundRect">
+            <a:avLst>
+              <a:gd name="adj" fmla="val 50000"/>
+            </a:avLst>
+          </a:prstGeom>
+          <a:solidFill xmlns:a="http://schemas.openxmlformats.org/drawingml/2006/main">
+            <a:srgbClr val="38BDF8"/>
+          </a:solidFill>
+          <a:ln xmlns:a="http://schemas.openxmlformats.org/drawingml/2006/main" w="0">
+            <a:noFill/>
+            <a:prstDash val="solid"/>
+          </a:ln>
+        </p:spPr>
+      </p:sp>
+      <p:sp>
+        <p:nvSpPr>
+          <p:cNvPr id="7" name="decision-label-0">
+            <a:extLst xmlns:a="http://schemas.openxmlformats.org/drawingml/2006/main">
+              <a:ext uri="{FF2B5EF4-FFF2-40B4-BE49-F238E27FC236}">
+                <a16:creationId xmlns:a16="http://schemas.microsoft.com/office/drawing/2014/main" id="{22491B48-158F-4650-ADB1-D9724C10B79F}"/>
+              </a:ext>
+            </a:extLst>
+          </p:cNvPr>
+          <p:cNvSpPr>
+            <a:spLocks xmlns:a="http://schemas.openxmlformats.org/drawingml/2006/main" noGrp="1"/>
+          </p:cNvSpPr>
+          <p:nvPr/>
+        </p:nvSpPr>
+        <p:spPr>
+          <a:xfrm xmlns:a="http://schemas.openxmlformats.org/drawingml/2006/main">
+            <a:off x="609600" y="2647950"/>
+            <a:ext cx="2381250" cy="209550"/>
+          </a:xfrm>
+          <a:prstGeom xmlns:a="http://schemas.openxmlformats.org/drawingml/2006/main" prst="rect">
+            <a:avLst/>
+          </a:prstGeom>
+          <a:noFill xmlns:a="http://schemas.openxmlformats.org/drawingml/2006/main"/>
+          <a:ln xmlns:a="http://schemas.openxmlformats.org/drawingml/2006/main" w="0">
+            <a:noFill/>
+            <a:prstDash val="solid"/>
+          </a:ln>
+        </p:spPr>
+        <p:txBody>
+          <a:bodyPr xmlns:a="http://schemas.openxmlformats.org/drawingml/2006/main" wrap="square" lIns="0" tIns="0" rIns="0" bIns="0" anchor="t">
+            <a:noAutofit/>
+          </a:bodyPr>
+          <a:lstStyle xmlns:a="http://schemas.openxmlformats.org/drawingml/2006/main"/>
+          <a:p xmlns:a="http://schemas.openxmlformats.org/drawingml/2006/main">
+            <a:pPr algn="l">
+              <a:lnSpc>
+                <a:spcPct val="108000"/>
+              </a:lnSpc>
+              <a:buNone/>
+              <a:defRPr sz="1050" b="1">
+                <a:solidFill>
+                  <a:srgbClr val="38BDF8"/>
+                </a:solidFill>
+                <a:latin typeface="Aptos"/>
+                <a:ea typeface="Aptos"/>
+                <a:cs typeface="Aptos"/>
+              </a:defRPr>
+            </a:pPr>
+            <a:r>
+              <a:rPr sz="1050" b="1">
+                <a:solidFill>
+                  <a:srgbClr val="38BDF8"/>
+                </a:solidFill>
+                <a:latin typeface="Aptos"/>
+                <a:ea typeface="Aptos"/>
+                <a:cs typeface="Aptos"/>
+              </a:rPr>
+              <a:t>NOW · v0.1</a:t>
+            </a:r>
+          </a:p>
+        </p:txBody>
+      </p:sp>
+      <p:sp>
+        <p:nvSpPr>
+          <p:cNvPr id="8" name="decision-title-0">
+            <a:extLst xmlns:a="http://schemas.openxmlformats.org/drawingml/2006/main">
+              <a:ext uri="{FF2B5EF4-FFF2-40B4-BE49-F238E27FC236}">
+                <a16:creationId xmlns:a16="http://schemas.microsoft.com/office/drawing/2014/main" id="{D13498F6-3376-4090-A387-60CA829307DF}"/>
+              </a:ext>
+            </a:extLst>
+          </p:cNvPr>
+          <p:cNvSpPr>
+            <a:spLocks xmlns:a="http://schemas.openxmlformats.org/drawingml/2006/main" noGrp="1"/>
+          </p:cNvSpPr>
+          <p:nvPr/>
+        </p:nvSpPr>
+        <p:spPr>
+          <a:xfrm xmlns:a="http://schemas.openxmlformats.org/drawingml/2006/main">
+            <a:off x="609600" y="3048000"/>
+            <a:ext cx="3143250" cy="400050"/>
+          </a:xfrm>
+          <a:prstGeom xmlns:a="http://schemas.openxmlformats.org/drawingml/2006/main" prst="rect">
+            <a:avLst/>
+          </a:prstGeom>
+          <a:noFill xmlns:a="http://schemas.openxmlformats.org/drawingml/2006/main"/>
+          <a:ln xmlns:a="http://schemas.openxmlformats.org/drawingml/2006/main" w="0">
+            <a:noFill/>
+            <a:prstDash val="solid"/>
+          </a:ln>
+        </p:spPr>
+        <p:txBody>
+          <a:bodyPr xmlns:a="http://schemas.openxmlformats.org/drawingml/2006/main" wrap="square" lIns="0" tIns="0" rIns="0" bIns="0" anchor="t">
+            <a:noAutofit/>
+          </a:bodyPr>
+          <a:lstStyle xmlns:a="http://schemas.openxmlformats.org/drawingml/2006/main"/>
+          <a:p xmlns:a="http://schemas.openxmlformats.org/drawingml/2006/main">
+            <a:pPr algn="l">
+              <a:lnSpc>
+                <a:spcPct val="108000"/>
+              </a:lnSpc>
+              <a:buNone/>
+              <a:defRPr sz="2250" b="1">
+                <a:solidFill>
+                  <a:srgbClr val="EDF6F7"/>
+                </a:solidFill>
+                <a:latin typeface="Aptos"/>
+                <a:ea typeface="Aptos"/>
+                <a:cs typeface="Aptos"/>
+              </a:defRPr>
+            </a:pPr>
+            <a:r>
+              <a:rPr sz="2250" b="1">
+                <a:solidFill>
+                  <a:srgbClr val="EDF6F7"/>
+                </a:solidFill>
+                <a:latin typeface="Aptos"/>
+                <a:ea typeface="Aptos"/>
+                <a:cs typeface="Aptos"/>
+              </a:rPr>
+              <a:t>Technical Preview</a:t>
+            </a:r>
+          </a:p>
+        </p:txBody>
+      </p:sp>
+      <p:sp>
+        <p:nvSpPr>
+          <p:cNvPr id="9" name="decision-0-0-dot">
+            <a:extLst xmlns:a="http://schemas.openxmlformats.org/drawingml/2006/main">
+              <a:ext uri="{FF2B5EF4-FFF2-40B4-BE49-F238E27FC236}">
+                <a16:creationId xmlns:a16="http://schemas.microsoft.com/office/drawing/2014/main" id="{2972C95D-7FF7-4F84-B204-BD9595FBE40A}"/>
+              </a:ext>
+            </a:extLst>
+          </p:cNvPr>
+          <p:cNvSpPr>
+            <a:spLocks xmlns:a="http://schemas.openxmlformats.org/drawingml/2006/main" noGrp="1"/>
+          </p:cNvSpPr>
+          <p:nvPr/>
+        </p:nvSpPr>
+        <p:spPr>
+          <a:xfrm xmlns:a="http://schemas.openxmlformats.org/drawingml/2006/main">
+            <a:off x="609600" y="3819525"/>
+            <a:ext cx="66675" cy="66675"/>
+          </a:xfrm>
+          <a:prstGeom xmlns:a="http://schemas.openxmlformats.org/drawingml/2006/main" prst="ellipse">
+            <a:avLst/>
+          </a:prstGeom>
+          <a:solidFill xmlns:a="http://schemas.openxmlformats.org/drawingml/2006/main">
+            <a:srgbClr val="2DD4BF"/>
+          </a:solidFill>
+          <a:ln xmlns:a="http://schemas.openxmlformats.org/drawingml/2006/main" w="0">
+            <a:noFill/>
+            <a:prstDash val="solid"/>
+          </a:ln>
+        </p:spPr>
+      </p:sp>
+      <p:sp>
+        <p:nvSpPr>
+          <p:cNvPr id="10" name="decision-0-0">
+            <a:extLst xmlns:a="http://schemas.openxmlformats.org/drawingml/2006/main">
+              <a:ext uri="{FF2B5EF4-FFF2-40B4-BE49-F238E27FC236}">
+                <a16:creationId xmlns:a16="http://schemas.microsoft.com/office/drawing/2014/main" id="{1FC5A3BC-472D-492A-A790-109CFC75582E}"/>
+              </a:ext>
+            </a:extLst>
+          </p:cNvPr>
+          <p:cNvSpPr>
+            <a:spLocks xmlns:a="http://schemas.openxmlformats.org/drawingml/2006/main" noGrp="1"/>
+          </p:cNvSpPr>
+          <p:nvPr/>
+        </p:nvSpPr>
+        <p:spPr>
+          <a:xfrm xmlns:a="http://schemas.openxmlformats.org/drawingml/2006/main">
+            <a:off x="800100" y="3733800"/>
+            <a:ext cx="2952750" cy="533400"/>
+          </a:xfrm>
+          <a:prstGeom xmlns:a="http://schemas.openxmlformats.org/drawingml/2006/main" prst="rect">
+            <a:avLst/>
+          </a:prstGeom>
+          <a:noFill xmlns:a="http://schemas.openxmlformats.org/drawingml/2006/main"/>
+          <a:ln xmlns:a="http://schemas.openxmlformats.org/drawingml/2006/main" w="0">
+            <a:noFill/>
+            <a:prstDash val="solid"/>
+          </a:ln>
+        </p:spPr>
+        <p:txBody>
+          <a:bodyPr xmlns:a="http://schemas.openxmlformats.org/drawingml/2006/main" wrap="square" lIns="0" tIns="0" rIns="0" bIns="0" anchor="t">
+            <a:noAutofit/>
+          </a:bodyPr>
+          <a:lstStyle xmlns:a="http://schemas.openxmlformats.org/drawingml/2006/main"/>
+          <a:p xmlns:a="http://schemas.openxmlformats.org/drawingml/2006/main">
+            <a:pPr algn="l">
+              <a:lnSpc>
+                <a:spcPct val="112000"/>
+              </a:lnSpc>
+              <a:buNone/>
+              <a:defRPr sz="1650" b="0">
+                <a:solidFill>
+                  <a:srgbClr val="EDF6F7"/>
+                </a:solidFill>
+                <a:latin typeface="Aptos"/>
+                <a:ea typeface="Aptos"/>
+                <a:cs typeface="Aptos"/>
+              </a:defRPr>
+            </a:pPr>
+            <a:r>
+              <a:rPr sz="1650" b="0">
+                <a:solidFill>
+                  <a:srgbClr val="EDF6F7"/>
+                </a:solidFill>
+                <a:latin typeface="Aptos"/>
+                <a:ea typeface="Aptos"/>
+                <a:cs typeface="Aptos"/>
+              </a:rPr>
+              <a:t>One-command local demo</a:t>
+            </a:r>
+          </a:p>
+        </p:txBody>
+      </p:sp>
+      <p:sp>
+        <p:nvSpPr>
+          <p:cNvPr id="11" name="decision-0-1-dot">
+            <a:extLst xmlns:a="http://schemas.openxmlformats.org/drawingml/2006/main">
+              <a:ext uri="{FF2B5EF4-FFF2-40B4-BE49-F238E27FC236}">
+                <a16:creationId xmlns:a16="http://schemas.microsoft.com/office/drawing/2014/main" id="{208BED63-CEA2-4C36-956F-EBD2A1EE79C5}"/>
+              </a:ext>
+            </a:extLst>
+          </p:cNvPr>
+          <p:cNvSpPr>
+            <a:spLocks xmlns:a="http://schemas.openxmlformats.org/drawingml/2006/main" noGrp="1"/>
+          </p:cNvSpPr>
+          <p:nvPr/>
+        </p:nvSpPr>
+        <p:spPr>
+          <a:xfrm xmlns:a="http://schemas.openxmlformats.org/drawingml/2006/main">
+            <a:off x="609600" y="4391025"/>
+            <a:ext cx="66675" cy="66675"/>
+          </a:xfrm>
+          <a:prstGeom xmlns:a="http://schemas.openxmlformats.org/drawingml/2006/main" prst="ellipse">
+            <a:avLst/>
+          </a:prstGeom>
+          <a:solidFill xmlns:a="http://schemas.openxmlformats.org/drawingml/2006/main">
+            <a:srgbClr val="2DD4BF"/>
+          </a:solidFill>
+          <a:ln xmlns:a="http://schemas.openxmlformats.org/drawingml/2006/main" w="0">
+            <a:noFill/>
+            <a:prstDash val="solid"/>
+          </a:ln>
+        </p:spPr>
+      </p:sp>
+      <p:sp>
+        <p:nvSpPr>
+          <p:cNvPr id="12" name="decision-0-1">
+            <a:extLst xmlns:a="http://schemas.openxmlformats.org/drawingml/2006/main">
+              <a:ext uri="{FF2B5EF4-FFF2-40B4-BE49-F238E27FC236}">
+                <a16:creationId xmlns:a16="http://schemas.microsoft.com/office/drawing/2014/main" id="{A8C4C40F-14AE-432B-B8A6-B4A6D241496E}"/>
+              </a:ext>
+            </a:extLst>
+          </p:cNvPr>
+          <p:cNvSpPr>
+            <a:spLocks xmlns:a="http://schemas.openxmlformats.org/drawingml/2006/main" noGrp="1"/>
+          </p:cNvSpPr>
+          <p:nvPr/>
+        </p:nvSpPr>
+        <p:spPr>
+          <a:xfrm xmlns:a="http://schemas.openxmlformats.org/drawingml/2006/main">
+            <a:off x="800100" y="4305300"/>
+            <a:ext cx="2952750" cy="533400"/>
+          </a:xfrm>
+          <a:prstGeom xmlns:a="http://schemas.openxmlformats.org/drawingml/2006/main" prst="rect">
+            <a:avLst/>
+          </a:prstGeom>
+          <a:noFill xmlns:a="http://schemas.openxmlformats.org/drawingml/2006/main"/>
+          <a:ln xmlns:a="http://schemas.openxmlformats.org/drawingml/2006/main" w="0">
+            <a:noFill/>
+            <a:prstDash val="solid"/>
+          </a:ln>
+        </p:spPr>
+        <p:txBody>
+          <a:bodyPr xmlns:a="http://schemas.openxmlformats.org/drawingml/2006/main" wrap="square" lIns="0" tIns="0" rIns="0" bIns="0" anchor="t">
+            <a:noAutofit/>
+          </a:bodyPr>
+          <a:lstStyle xmlns:a="http://schemas.openxmlformats.org/drawingml/2006/main"/>
+          <a:p xmlns:a="http://schemas.openxmlformats.org/drawingml/2006/main">
+            <a:pPr algn="l">
+              <a:lnSpc>
+                <a:spcPct val="112000"/>
+              </a:lnSpc>
+              <a:buNone/>
+              <a:defRPr sz="1650" b="0">
+                <a:solidFill>
+                  <a:srgbClr val="EDF6F7"/>
+                </a:solidFill>
+                <a:latin typeface="Aptos"/>
+                <a:ea typeface="Aptos"/>
+                <a:cs typeface="Aptos"/>
+              </a:defRPr>
+            </a:pPr>
+            <a:r>
+              <a:rPr sz="1650" b="0">
+                <a:solidFill>
+                  <a:srgbClr val="EDF6F7"/>
+                </a:solidFill>
+                <a:latin typeface="Aptos"/>
+                <a:ea typeface="Aptos"/>
+                <a:cs typeface="Aptos"/>
+              </a:rPr>
+              <a:t>196 automated checks</a:t>
+            </a:r>
+          </a:p>
+        </p:txBody>
+      </p:sp>
+      <p:sp>
+        <p:nvSpPr>
+          <p:cNvPr id="13" name="decision-0-2-dot">
+            <a:extLst xmlns:a="http://schemas.openxmlformats.org/drawingml/2006/main">
+              <a:ext uri="{FF2B5EF4-FFF2-40B4-BE49-F238E27FC236}">
+                <a16:creationId xmlns:a16="http://schemas.microsoft.com/office/drawing/2014/main" id="{2E4395D6-9C5B-4AA6-A567-82E07E697A65}"/>
+              </a:ext>
+            </a:extLst>
+          </p:cNvPr>
+          <p:cNvSpPr>
+            <a:spLocks xmlns:a="http://schemas.openxmlformats.org/drawingml/2006/main" noGrp="1"/>
+          </p:cNvSpPr>
+          <p:nvPr/>
+        </p:nvSpPr>
+        <p:spPr>
+          <a:xfrm xmlns:a="http://schemas.openxmlformats.org/drawingml/2006/main">
+            <a:off x="609600" y="4962525"/>
+            <a:ext cx="66675" cy="66675"/>
+          </a:xfrm>
+          <a:prstGeom xmlns:a="http://schemas.openxmlformats.org/drawingml/2006/main" prst="ellipse">
+            <a:avLst/>
+          </a:prstGeom>
+          <a:solidFill xmlns:a="http://schemas.openxmlformats.org/drawingml/2006/main">
+            <a:srgbClr val="2DD4BF"/>
+          </a:solidFill>
+          <a:ln xmlns:a="http://schemas.openxmlformats.org/drawingml/2006/main" w="0">
+            <a:noFill/>
+            <a:prstDash val="solid"/>
+          </a:ln>
+        </p:spPr>
+      </p:sp>
+      <p:sp>
+        <p:nvSpPr>
+          <p:cNvPr id="14" name="decision-0-2">
+            <a:extLst xmlns:a="http://schemas.openxmlformats.org/drawingml/2006/main">
+              <a:ext uri="{FF2B5EF4-FFF2-40B4-BE49-F238E27FC236}">
+                <a16:creationId xmlns:a16="http://schemas.microsoft.com/office/drawing/2014/main" id="{499EE4D9-5FC5-4CC4-B842-316DD5F1D374}"/>
+              </a:ext>
+            </a:extLst>
+          </p:cNvPr>
+          <p:cNvSpPr>
+            <a:spLocks xmlns:a="http://schemas.openxmlformats.org/drawingml/2006/main" noGrp="1"/>
+          </p:cNvSpPr>
+          <p:nvPr/>
+        </p:nvSpPr>
+        <p:spPr>
+          <a:xfrm xmlns:a="http://schemas.openxmlformats.org/drawingml/2006/main">
+            <a:off x="800100" y="4876800"/>
+            <a:ext cx="2952750" cy="533400"/>
+          </a:xfrm>
+          <a:prstGeom xmlns:a="http://schemas.openxmlformats.org/drawingml/2006/main" prst="rect">
+            <a:avLst/>
+          </a:prstGeom>
+          <a:noFill xmlns:a="http://schemas.openxmlformats.org/drawingml/2006/main"/>
+          <a:ln xmlns:a="http://schemas.openxmlformats.org/drawingml/2006/main" w="0">
+            <a:noFill/>
+            <a:prstDash val="solid"/>
+          </a:ln>
+        </p:spPr>
+        <p:txBody>
+          <a:bodyPr xmlns:a="http://schemas.openxmlformats.org/drawingml/2006/main" wrap="square" lIns="0" tIns="0" rIns="0" bIns="0" anchor="t">
+            <a:noAutofit/>
+          </a:bodyPr>
+          <a:lstStyle xmlns:a="http://schemas.openxmlformats.org/drawingml/2006/main"/>
+          <a:p xmlns:a="http://schemas.openxmlformats.org/drawingml/2006/main">
+            <a:pPr algn="l">
+              <a:lnSpc>
+                <a:spcPct val="112000"/>
+              </a:lnSpc>
+              <a:buNone/>
+              <a:defRPr sz="1650" b="0">
+                <a:solidFill>
+                  <a:srgbClr val="EDF6F7"/>
+                </a:solidFill>
+                <a:latin typeface="Aptos"/>
+                <a:ea typeface="Aptos"/>
+                <a:cs typeface="Aptos"/>
+              </a:defRPr>
+            </a:pPr>
+            <a:r>
+              <a:rPr sz="1650" b="0">
+                <a:solidFill>
+                  <a:srgbClr val="EDF6F7"/>
+                </a:solidFill>
+                <a:latin typeface="Aptos"/>
+                <a:ea typeface="Aptos"/>
+                <a:cs typeface="Aptos"/>
+              </a:rPr>
+              <a:t>Five external evaluations</a:t>
+            </a:r>
+          </a:p>
+        </p:txBody>
+      </p:sp>
+      <p:sp>
+        <p:nvSpPr>
+          <p:cNvPr id="15" name="decision-accent-1">
+            <a:extLst xmlns:a="http://schemas.openxmlformats.org/drawingml/2006/main">
+              <a:ext uri="{FF2B5EF4-FFF2-40B4-BE49-F238E27FC236}">
+                <a16:creationId xmlns:a16="http://schemas.microsoft.com/office/drawing/2014/main" id="{89881E43-B4B0-4510-A644-E7BA2B571821}"/>
+              </a:ext>
+            </a:extLst>
+          </p:cNvPr>
+          <p:cNvSpPr>
+            <a:spLocks xmlns:a="http://schemas.openxmlformats.org/drawingml/2006/main" noGrp="1"/>
+          </p:cNvSpPr>
+          <p:nvPr/>
+        </p:nvSpPr>
+        <p:spPr>
+          <a:xfrm xmlns:a="http://schemas.openxmlformats.org/drawingml/2006/main">
+            <a:off x="4305300" y="2343150"/>
+            <a:ext cx="3143250" cy="38100"/>
+          </a:xfrm>
+          <a:prstGeom xmlns:a="http://schemas.openxmlformats.org/drawingml/2006/main" prst="roundRect">
+            <a:avLst>
+              <a:gd name="adj" fmla="val 50000"/>
+            </a:avLst>
+          </a:prstGeom>
+          <a:solidFill xmlns:a="http://schemas.openxmlformats.org/drawingml/2006/main">
+            <a:srgbClr val="2DD4BF"/>
+          </a:solidFill>
+          <a:ln xmlns:a="http://schemas.openxmlformats.org/drawingml/2006/main" w="0">
+            <a:noFill/>
+            <a:prstDash val="solid"/>
+          </a:ln>
+        </p:spPr>
+      </p:sp>
+      <p:sp>
+        <p:nvSpPr>
+          <p:cNvPr id="16" name="decision-label-1">
+            <a:extLst xmlns:a="http://schemas.openxmlformats.org/drawingml/2006/main">
+              <a:ext uri="{FF2B5EF4-FFF2-40B4-BE49-F238E27FC236}">
+                <a16:creationId xmlns:a16="http://schemas.microsoft.com/office/drawing/2014/main" id="{3A5A2080-CC90-4299-9287-D1E133E6A2E1}"/>
+              </a:ext>
+            </a:extLst>
+          </p:cNvPr>
+          <p:cNvSpPr>
+            <a:spLocks xmlns:a="http://schemas.openxmlformats.org/drawingml/2006/main" noGrp="1"/>
+          </p:cNvSpPr>
+          <p:nvPr/>
+        </p:nvSpPr>
+        <p:spPr>
+          <a:xfrm xmlns:a="http://schemas.openxmlformats.org/drawingml/2006/main">
+            <a:off x="4305300" y="2647950"/>
+            <a:ext cx="2381250" cy="209550"/>
+          </a:xfrm>
+          <a:prstGeom xmlns:a="http://schemas.openxmlformats.org/drawingml/2006/main" prst="rect">
+            <a:avLst/>
+          </a:prstGeom>
+          <a:noFill xmlns:a="http://schemas.openxmlformats.org/drawingml/2006/main"/>
+          <a:ln xmlns:a="http://schemas.openxmlformats.org/drawingml/2006/main" w="0">
+            <a:noFill/>
+            <a:prstDash val="solid"/>
+          </a:ln>
+        </p:spPr>
+        <p:txBody>
+          <a:bodyPr xmlns:a="http://schemas.openxmlformats.org/drawingml/2006/main" wrap="square" lIns="0" tIns="0" rIns="0" bIns="0" anchor="t">
+            <a:noAutofit/>
+          </a:bodyPr>
+          <a:lstStyle xmlns:a="http://schemas.openxmlformats.org/drawingml/2006/main"/>
+          <a:p xmlns:a="http://schemas.openxmlformats.org/drawingml/2006/main">
+            <a:pPr algn="l">
+              <a:lnSpc>
+                <a:spcPct val="108000"/>
+              </a:lnSpc>
+              <a:buNone/>
+              <a:defRPr sz="1050" b="1">
+                <a:solidFill>
+                  <a:srgbClr val="2DD4BF"/>
+                </a:solidFill>
+                <a:latin typeface="Aptos"/>
+                <a:ea typeface="Aptos"/>
+                <a:cs typeface="Aptos"/>
+              </a:defRPr>
+            </a:pPr>
+            <a:r>
+              <a:rPr sz="1050" b="1">
+                <a:solidFill>
+                  <a:srgbClr val="2DD4BF"/>
+                </a:solidFill>
+                <a:latin typeface="Aptos"/>
+                <a:ea typeface="Aptos"/>
+                <a:cs typeface="Aptos"/>
+              </a:rPr>
+              <a:t>NEXT · v0.2</a:t>
+            </a:r>
+          </a:p>
+        </p:txBody>
+      </p:sp>
+      <p:sp>
+        <p:nvSpPr>
+          <p:cNvPr id="17" name="decision-title-1">
+            <a:extLst xmlns:a="http://schemas.openxmlformats.org/drawingml/2006/main">
+              <a:ext uri="{FF2B5EF4-FFF2-40B4-BE49-F238E27FC236}">
+                <a16:creationId xmlns:a16="http://schemas.microsoft.com/office/drawing/2014/main" id="{4F6698AE-D1ED-4326-9C20-44F1E26894BC}"/>
+              </a:ext>
+            </a:extLst>
+          </p:cNvPr>
+          <p:cNvSpPr>
+            <a:spLocks xmlns:a="http://schemas.openxmlformats.org/drawingml/2006/main" noGrp="1"/>
+          </p:cNvSpPr>
+          <p:nvPr/>
+        </p:nvSpPr>
+        <p:spPr>
+          <a:xfrm xmlns:a="http://schemas.openxmlformats.org/drawingml/2006/main">
+            <a:off x="4305300" y="3048000"/>
+            <a:ext cx="3143250" cy="400050"/>
+          </a:xfrm>
+          <a:prstGeom xmlns:a="http://schemas.openxmlformats.org/drawingml/2006/main" prst="rect">
+            <a:avLst/>
+          </a:prstGeom>
+          <a:noFill xmlns:a="http://schemas.openxmlformats.org/drawingml/2006/main"/>
+          <a:ln xmlns:a="http://schemas.openxmlformats.org/drawingml/2006/main" w="0">
+            <a:noFill/>
+            <a:prstDash val="solid"/>
+          </a:ln>
+        </p:spPr>
+        <p:txBody>
+          <a:bodyPr xmlns:a="http://schemas.openxmlformats.org/drawingml/2006/main" wrap="square" lIns="0" tIns="0" rIns="0" bIns="0" anchor="t">
+            <a:noAutofit/>
+          </a:bodyPr>
+          <a:lstStyle xmlns:a="http://schemas.openxmlformats.org/drawingml/2006/main"/>
+          <a:p xmlns:a="http://schemas.openxmlformats.org/drawingml/2006/main">
+            <a:pPr algn="l">
+              <a:lnSpc>
+                <a:spcPct val="108000"/>
+              </a:lnSpc>
+              <a:buNone/>
+              <a:defRPr sz="2250" b="1">
+                <a:solidFill>
+                  <a:srgbClr val="EDF6F7"/>
+                </a:solidFill>
+                <a:latin typeface="Aptos"/>
+                <a:ea typeface="Aptos"/>
+                <a:cs typeface="Aptos"/>
+              </a:defRPr>
+            </a:pPr>
+            <a:r>
+              <a:rPr sz="2250" b="1">
+                <a:solidFill>
+                  <a:srgbClr val="EDF6F7"/>
+                </a:solidFill>
+                <a:latin typeface="Aptos"/>
+                <a:ea typeface="Aptos"/>
+                <a:cs typeface="Aptos"/>
+              </a:rPr>
+              <a:t>Prove one target</a:t>
+            </a:r>
+          </a:p>
+        </p:txBody>
+      </p:sp>
+      <p:sp>
+        <p:nvSpPr>
+          <p:cNvPr id="18" name="decision-1-0-dot">
+            <a:extLst xmlns:a="http://schemas.openxmlformats.org/drawingml/2006/main">
+              <a:ext uri="{FF2B5EF4-FFF2-40B4-BE49-F238E27FC236}">
+                <a16:creationId xmlns:a16="http://schemas.microsoft.com/office/drawing/2014/main" id="{7BACB87A-716A-4EB2-8B3F-7BEF104C360A}"/>
+              </a:ext>
+            </a:extLst>
+          </p:cNvPr>
+          <p:cNvSpPr>
+            <a:spLocks xmlns:a="http://schemas.openxmlformats.org/drawingml/2006/main" noGrp="1"/>
+          </p:cNvSpPr>
+          <p:nvPr/>
+        </p:nvSpPr>
+        <p:spPr>
+          <a:xfrm xmlns:a="http://schemas.openxmlformats.org/drawingml/2006/main">
+            <a:off x="4305300" y="3819525"/>
+            <a:ext cx="66675" cy="66675"/>
+          </a:xfrm>
+          <a:prstGeom xmlns:a="http://schemas.openxmlformats.org/drawingml/2006/main" prst="ellipse">
+            <a:avLst/>
+          </a:prstGeom>
+          <a:solidFill xmlns:a="http://schemas.openxmlformats.org/drawingml/2006/main">
+            <a:srgbClr val="2DD4BF"/>
+          </a:solidFill>
+          <a:ln xmlns:a="http://schemas.openxmlformats.org/drawingml/2006/main" w="0">
+            <a:noFill/>
+            <a:prstDash val="solid"/>
+          </a:ln>
+        </p:spPr>
+      </p:sp>
+      <p:sp>
+        <p:nvSpPr>
+          <p:cNvPr id="19" name="decision-1-0">
+            <a:extLst xmlns:a="http://schemas.openxmlformats.org/drawingml/2006/main">
+              <a:ext uri="{FF2B5EF4-FFF2-40B4-BE49-F238E27FC236}">
+                <a16:creationId xmlns:a16="http://schemas.microsoft.com/office/drawing/2014/main" id="{0D72FEBF-AA96-4C37-A3E1-BF155AC6DA21}"/>
+              </a:ext>
+            </a:extLst>
+          </p:cNvPr>
+          <p:cNvSpPr>
+            <a:spLocks xmlns:a="http://schemas.openxmlformats.org/drawingml/2006/main" noGrp="1"/>
+          </p:cNvSpPr>
+          <p:nvPr/>
+        </p:nvSpPr>
+        <p:spPr>
+          <a:xfrm xmlns:a="http://schemas.openxmlformats.org/drawingml/2006/main">
+            <a:off x="4495800" y="3733800"/>
+            <a:ext cx="2952750" cy="533400"/>
+          </a:xfrm>
+          <a:prstGeom xmlns:a="http://schemas.openxmlformats.org/drawingml/2006/main" prst="rect">
+            <a:avLst/>
+          </a:prstGeom>
+          <a:noFill xmlns:a="http://schemas.openxmlformats.org/drawingml/2006/main"/>
+          <a:ln xmlns:a="http://schemas.openxmlformats.org/drawingml/2006/main" w="0">
+            <a:noFill/>
+            <a:prstDash val="solid"/>
+          </a:ln>
+        </p:spPr>
+        <p:txBody>
+          <a:bodyPr xmlns:a="http://schemas.openxmlformats.org/drawingml/2006/main" wrap="square" lIns="0" tIns="0" rIns="0" bIns="0" anchor="t">
+            <a:noAutofit/>
+          </a:bodyPr>
+          <a:lstStyle xmlns:a="http://schemas.openxmlformats.org/drawingml/2006/main"/>
+          <a:p xmlns:a="http://schemas.openxmlformats.org/drawingml/2006/main">
+            <a:pPr algn="l">
+              <a:lnSpc>
+                <a:spcPct val="112000"/>
+              </a:lnSpc>
+              <a:buNone/>
+              <a:defRPr sz="1650" b="0">
+                <a:solidFill>
+                  <a:srgbClr val="EDF6F7"/>
+                </a:solidFill>
+                <a:latin typeface="Aptos"/>
+                <a:ea typeface="Aptos"/>
+                <a:cs typeface="Aptos"/>
+              </a:defRPr>
+            </a:pPr>
+            <a:r>
+              <a:rPr sz="1650" b="0">
+                <a:solidFill>
+                  <a:srgbClr val="EDF6F7"/>
+                </a:solidFill>
+                <a:latin typeface="Aptos"/>
+                <a:ea typeface="Aptos"/>
+                <a:cs typeface="Aptos"/>
+              </a:rPr>
+              <a:t>PostgreSQL RLS adapter</a:t>
+            </a:r>
+          </a:p>
+        </p:txBody>
+      </p:sp>
+      <p:sp>
+        <p:nvSpPr>
+          <p:cNvPr id="20" name="decision-1-1-dot">
+            <a:extLst xmlns:a="http://schemas.openxmlformats.org/drawingml/2006/main">
+              <a:ext uri="{FF2B5EF4-FFF2-40B4-BE49-F238E27FC236}">
+                <a16:creationId xmlns:a16="http://schemas.microsoft.com/office/drawing/2014/main" id="{387C4691-D86A-469D-A586-30E86613DA39}"/>
+              </a:ext>
+            </a:extLst>
+          </p:cNvPr>
+          <p:cNvSpPr>
+            <a:spLocks xmlns:a="http://schemas.openxmlformats.org/drawingml/2006/main" noGrp="1"/>
+          </p:cNvSpPr>
+          <p:nvPr/>
+        </p:nvSpPr>
+        <p:spPr>
+          <a:xfrm xmlns:a="http://schemas.openxmlformats.org/drawingml/2006/main">
+            <a:off x="4305300" y="4391025"/>
+            <a:ext cx="66675" cy="66675"/>
+          </a:xfrm>
+          <a:prstGeom xmlns:a="http://schemas.openxmlformats.org/drawingml/2006/main" prst="ellipse">
+            <a:avLst/>
+          </a:prstGeom>
+          <a:solidFill xmlns:a="http://schemas.openxmlformats.org/drawingml/2006/main">
+            <a:srgbClr val="2DD4BF"/>
+          </a:solidFill>
+          <a:ln xmlns:a="http://schemas.openxmlformats.org/drawingml/2006/main" w="0">
+            <a:noFill/>
+            <a:prstDash val="solid"/>
+          </a:ln>
+        </p:spPr>
+      </p:sp>
+      <p:sp>
+        <p:nvSpPr>
+          <p:cNvPr id="21" name="decision-1-1">
+            <a:extLst xmlns:a="http://schemas.openxmlformats.org/drawingml/2006/main">
+              <a:ext uri="{FF2B5EF4-FFF2-40B4-BE49-F238E27FC236}">
+                <a16:creationId xmlns:a16="http://schemas.microsoft.com/office/drawing/2014/main" id="{5DB8D9D3-931C-45AE-AF86-CC3191F7466B}"/>
+              </a:ext>
+            </a:extLst>
+          </p:cNvPr>
+          <p:cNvSpPr>
+            <a:spLocks xmlns:a="http://schemas.openxmlformats.org/drawingml/2006/main" noGrp="1"/>
+          </p:cNvSpPr>
+          <p:nvPr/>
+        </p:nvSpPr>
+        <p:spPr>
+          <a:xfrm xmlns:a="http://schemas.openxmlformats.org/drawingml/2006/main">
+            <a:off x="4495800" y="4305300"/>
+            <a:ext cx="2952750" cy="533400"/>
+          </a:xfrm>
+          <a:prstGeom xmlns:a="http://schemas.openxmlformats.org/drawingml/2006/main" prst="rect">
+            <a:avLst/>
+          </a:prstGeom>
+          <a:noFill xmlns:a="http://schemas.openxmlformats.org/drawingml/2006/main"/>
+          <a:ln xmlns:a="http://schemas.openxmlformats.org/drawingml/2006/main" w="0">
+            <a:noFill/>
+            <a:prstDash val="solid"/>
+          </a:ln>
+        </p:spPr>
+        <p:txBody>
+          <a:bodyPr xmlns:a="http://schemas.openxmlformats.org/drawingml/2006/main" wrap="square" lIns="0" tIns="0" rIns="0" bIns="0" anchor="t">
+            <a:noAutofit/>
+          </a:bodyPr>
+          <a:lstStyle xmlns:a="http://schemas.openxmlformats.org/drawingml/2006/main"/>
+          <a:p xmlns:a="http://schemas.openxmlformats.org/drawingml/2006/main">
+            <a:pPr algn="l">
+              <a:lnSpc>
+                <a:spcPct val="112000"/>
+              </a:lnSpc>
+              <a:buNone/>
+              <a:defRPr sz="1650" b="0">
+                <a:solidFill>
+                  <a:srgbClr val="EDF6F7"/>
+                </a:solidFill>
+                <a:latin typeface="Aptos"/>
+                <a:ea typeface="Aptos"/>
+                <a:cs typeface="Aptos"/>
+              </a:defRPr>
+            </a:pPr>
+            <a:r>
+              <a:rPr sz="1650" b="0">
+                <a:solidFill>
+                  <a:srgbClr val="EDF6F7"/>
+                </a:solidFill>
+                <a:latin typeface="Aptos"/>
+                <a:ea typeface="Aptos"/>
+                <a:cs typeface="Aptos"/>
+              </a:rPr>
+              <a:t>Apply, read back, drift</a:t>
+            </a:r>
+          </a:p>
+        </p:txBody>
+      </p:sp>
+      <p:sp>
+        <p:nvSpPr>
+          <p:cNvPr id="22" name="decision-1-2-dot">
+            <a:extLst xmlns:a="http://schemas.openxmlformats.org/drawingml/2006/main">
+              <a:ext uri="{FF2B5EF4-FFF2-40B4-BE49-F238E27FC236}">
+                <a16:creationId xmlns:a16="http://schemas.microsoft.com/office/drawing/2014/main" id="{93945EFA-2D3C-4E89-BB20-0D45B33C106B}"/>
+              </a:ext>
+            </a:extLst>
+          </p:cNvPr>
+          <p:cNvSpPr>
+            <a:spLocks xmlns:a="http://schemas.openxmlformats.org/drawingml/2006/main" noGrp="1"/>
+          </p:cNvSpPr>
+          <p:nvPr/>
+        </p:nvSpPr>
+        <p:spPr>
+          <a:xfrm xmlns:a="http://schemas.openxmlformats.org/drawingml/2006/main">
+            <a:off x="4305300" y="4962525"/>
+            <a:ext cx="66675" cy="66675"/>
+          </a:xfrm>
+          <a:prstGeom xmlns:a="http://schemas.openxmlformats.org/drawingml/2006/main" prst="ellipse">
+            <a:avLst/>
+          </a:prstGeom>
+          <a:solidFill xmlns:a="http://schemas.openxmlformats.org/drawingml/2006/main">
+            <a:srgbClr val="2DD4BF"/>
+          </a:solidFill>
+          <a:ln xmlns:a="http://schemas.openxmlformats.org/drawingml/2006/main" w="0">
+            <a:noFill/>
+            <a:prstDash val="solid"/>
+          </a:ln>
+        </p:spPr>
+      </p:sp>
+      <p:sp>
+        <p:nvSpPr>
+          <p:cNvPr id="23" name="decision-1-2">
+            <a:extLst xmlns:a="http://schemas.openxmlformats.org/drawingml/2006/main">
+              <a:ext uri="{FF2B5EF4-FFF2-40B4-BE49-F238E27FC236}">
+                <a16:creationId xmlns:a16="http://schemas.microsoft.com/office/drawing/2014/main" id="{CB3794E4-3EDA-4862-AF02-4BE216C15F6C}"/>
+              </a:ext>
+            </a:extLst>
+          </p:cNvPr>
+          <p:cNvSpPr>
+            <a:spLocks xmlns:a="http://schemas.openxmlformats.org/drawingml/2006/main" noGrp="1"/>
+          </p:cNvSpPr>
+          <p:nvPr/>
+        </p:nvSpPr>
+        <p:spPr>
+          <a:xfrm xmlns:a="http://schemas.openxmlformats.org/drawingml/2006/main">
+            <a:off x="4495800" y="4876800"/>
+            <a:ext cx="2952750" cy="533400"/>
+          </a:xfrm>
+          <a:prstGeom xmlns:a="http://schemas.openxmlformats.org/drawingml/2006/main" prst="rect">
+            <a:avLst/>
+          </a:prstGeom>
+          <a:noFill xmlns:a="http://schemas.openxmlformats.org/drawingml/2006/main"/>
+          <a:ln xmlns:a="http://schemas.openxmlformats.org/drawingml/2006/main" w="0">
+            <a:noFill/>
+            <a:prstDash val="solid"/>
+          </a:ln>
+        </p:spPr>
+        <p:txBody>
+          <a:bodyPr xmlns:a="http://schemas.openxmlformats.org/drawingml/2006/main" wrap="square" lIns="0" tIns="0" rIns="0" bIns="0" anchor="t">
+            <a:noAutofit/>
+          </a:bodyPr>
+          <a:lstStyle xmlns:a="http://schemas.openxmlformats.org/drawingml/2006/main"/>
+          <a:p xmlns:a="http://schemas.openxmlformats.org/drawingml/2006/main">
+            <a:pPr algn="l">
+              <a:lnSpc>
+                <a:spcPct val="112000"/>
+              </a:lnSpc>
+              <a:buNone/>
+              <a:defRPr sz="1650" b="0">
+                <a:solidFill>
+                  <a:srgbClr val="EDF6F7"/>
+                </a:solidFill>
+                <a:latin typeface="Aptos"/>
+                <a:ea typeface="Aptos"/>
+                <a:cs typeface="Aptos"/>
+              </a:defRPr>
+            </a:pPr>
+            <a:r>
+              <a:rPr sz="1650" b="0">
+                <a:solidFill>
+                  <a:srgbClr val="EDF6F7"/>
+                </a:solidFill>
+                <a:latin typeface="Aptos"/>
+                <a:ea typeface="Aptos"/>
+                <a:cs typeface="Aptos"/>
+              </a:rPr>
+              <a:t>AuthZEN 1.0 interop</a:t>
+            </a:r>
+          </a:p>
+        </p:txBody>
+      </p:sp>
+      <p:sp>
+        <p:nvSpPr>
+          <p:cNvPr id="24" name="decision-accent-2">
+            <a:extLst xmlns:a="http://schemas.openxmlformats.org/drawingml/2006/main">
+              <a:ext uri="{FF2B5EF4-FFF2-40B4-BE49-F238E27FC236}">
+                <a16:creationId xmlns:a16="http://schemas.microsoft.com/office/drawing/2014/main" id="{B911D945-5BF4-414A-A017-BA3677F34F62}"/>
+              </a:ext>
+            </a:extLst>
+          </p:cNvPr>
+          <p:cNvSpPr>
+            <a:spLocks xmlns:a="http://schemas.openxmlformats.org/drawingml/2006/main" noGrp="1"/>
+          </p:cNvSpPr>
+          <p:nvPr/>
+        </p:nvSpPr>
+        <p:spPr>
+          <a:xfrm xmlns:a="http://schemas.openxmlformats.org/drawingml/2006/main">
+            <a:off x="8001000" y="2343150"/>
+            <a:ext cx="3143250" cy="38100"/>
+          </a:xfrm>
+          <a:prstGeom xmlns:a="http://schemas.openxmlformats.org/drawingml/2006/main" prst="roundRect">
+            <a:avLst>
+              <a:gd name="adj" fmla="val 50000"/>
+            </a:avLst>
+          </a:prstGeom>
+          <a:solidFill xmlns:a="http://schemas.openxmlformats.org/drawingml/2006/main">
+            <a:srgbClr val="F4B942"/>
+          </a:solidFill>
+          <a:ln xmlns:a="http://schemas.openxmlformats.org/drawingml/2006/main" w="0">
+            <a:noFill/>
+            <a:prstDash val="solid"/>
+          </a:ln>
+        </p:spPr>
+      </p:sp>
+      <p:sp>
+        <p:nvSpPr>
+          <p:cNvPr id="25" name="decision-label-2">
+            <a:extLst xmlns:a="http://schemas.openxmlformats.org/drawingml/2006/main">
+              <a:ext uri="{FF2B5EF4-FFF2-40B4-BE49-F238E27FC236}">
+                <a16:creationId xmlns:a16="http://schemas.microsoft.com/office/drawing/2014/main" id="{7E87B72F-F401-4638-BD7F-FF681BEF1567}"/>
+              </a:ext>
+            </a:extLst>
+          </p:cNvPr>
+          <p:cNvSpPr>
+            <a:spLocks xmlns:a="http://schemas.openxmlformats.org/drawingml/2006/main" noGrp="1"/>
+          </p:cNvSpPr>
+          <p:nvPr/>
+        </p:nvSpPr>
+        <p:spPr>
+          <a:xfrm xmlns:a="http://schemas.openxmlformats.org/drawingml/2006/main">
+            <a:off x="8001000" y="2647950"/>
+            <a:ext cx="2381250" cy="209550"/>
+          </a:xfrm>
+          <a:prstGeom xmlns:a="http://schemas.openxmlformats.org/drawingml/2006/main" prst="rect">
+            <a:avLst/>
+          </a:prstGeom>
+          <a:noFill xmlns:a="http://schemas.openxmlformats.org/drawingml/2006/main"/>
+          <a:ln xmlns:a="http://schemas.openxmlformats.org/drawingml/2006/main" w="0">
+            <a:noFill/>
+            <a:prstDash val="solid"/>
+          </a:ln>
+        </p:spPr>
+        <p:txBody>
+          <a:bodyPr xmlns:a="http://schemas.openxmlformats.org/drawingml/2006/main" wrap="square" lIns="0" tIns="0" rIns="0" bIns="0" anchor="t">
+            <a:noAutofit/>
+          </a:bodyPr>
+          <a:lstStyle xmlns:a="http://schemas.openxmlformats.org/drawingml/2006/main"/>
+          <a:p xmlns:a="http://schemas.openxmlformats.org/drawingml/2006/main">
+            <a:pPr algn="l">
+              <a:lnSpc>
+                <a:spcPct val="108000"/>
+              </a:lnSpc>
+              <a:buNone/>
+              <a:defRPr sz="1050" b="1">
+                <a:solidFill>
+                  <a:srgbClr val="F4B942"/>
+                </a:solidFill>
+                <a:latin typeface="Aptos"/>
+                <a:ea typeface="Aptos"/>
+                <a:cs typeface="Aptos"/>
+              </a:defRPr>
+            </a:pPr>
+            <a:r>
+              <a:rPr sz="1050" b="1">
+                <a:solidFill>
+                  <a:srgbClr val="F4B942"/>
+                </a:solidFill>
+                <a:latin typeface="Aptos"/>
+                <a:ea typeface="Aptos"/>
+                <a:cs typeface="Aptos"/>
+              </a:rPr>
+              <a:t>LATER · v0.3</a:t>
+            </a:r>
+          </a:p>
+        </p:txBody>
+      </p:sp>
+      <p:sp>
+        <p:nvSpPr>
+          <p:cNvPr id="26" name="decision-title-2">
+            <a:extLst xmlns:a="http://schemas.openxmlformats.org/drawingml/2006/main">
+              <a:ext uri="{FF2B5EF4-FFF2-40B4-BE49-F238E27FC236}">
+                <a16:creationId xmlns:a16="http://schemas.microsoft.com/office/drawing/2014/main" id="{11D5AA0A-E2C4-45D7-9E1B-E948F0E4CF24}"/>
+              </a:ext>
+            </a:extLst>
+          </p:cNvPr>
+          <p:cNvSpPr>
+            <a:spLocks xmlns:a="http://schemas.openxmlformats.org/drawingml/2006/main" noGrp="1"/>
+          </p:cNvSpPr>
+          <p:nvPr/>
+        </p:nvSpPr>
+        <p:spPr>
+          <a:xfrm xmlns:a="http://schemas.openxmlformats.org/drawingml/2006/main">
+            <a:off x="8001000" y="3048000"/>
+            <a:ext cx="3143250" cy="400050"/>
+          </a:xfrm>
+          <a:prstGeom xmlns:a="http://schemas.openxmlformats.org/drawingml/2006/main" prst="rect">
+            <a:avLst/>
+          </a:prstGeom>
+          <a:noFill xmlns:a="http://schemas.openxmlformats.org/drawingml/2006/main"/>
+          <a:ln xmlns:a="http://schemas.openxmlformats.org/drawingml/2006/main" w="0">
+            <a:noFill/>
+            <a:prstDash val="solid"/>
+          </a:ln>
+        </p:spPr>
+        <p:txBody>
+          <a:bodyPr xmlns:a="http://schemas.openxmlformats.org/drawingml/2006/main" wrap="square" lIns="0" tIns="0" rIns="0" bIns="0" anchor="t">
+            <a:noAutofit/>
+          </a:bodyPr>
+          <a:lstStyle xmlns:a="http://schemas.openxmlformats.org/drawingml/2006/main"/>
+          <a:p xmlns:a="http://schemas.openxmlformats.org/drawingml/2006/main">
+            <a:pPr algn="l">
+              <a:lnSpc>
+                <a:spcPct val="108000"/>
+              </a:lnSpc>
+              <a:buNone/>
+              <a:defRPr sz="2250" b="1">
+                <a:solidFill>
+                  <a:srgbClr val="EDF6F7"/>
+                </a:solidFill>
+                <a:latin typeface="Aptos"/>
+                <a:ea typeface="Aptos"/>
+                <a:cs typeface="Aptos"/>
+              </a:defRPr>
+            </a:pPr>
+            <a:r>
+              <a:rPr sz="2250" b="1">
+                <a:solidFill>
+                  <a:srgbClr val="EDF6F7"/>
+                </a:solidFill>
+                <a:latin typeface="Aptos"/>
+                <a:ea typeface="Aptos"/>
+                <a:cs typeface="Aptos"/>
+              </a:rPr>
+              <a:t>Broaden evidence</a:t>
+            </a:r>
+          </a:p>
+        </p:txBody>
+      </p:sp>
+      <p:sp>
+        <p:nvSpPr>
+          <p:cNvPr id="27" name="decision-2-0-dot">
+            <a:extLst xmlns:a="http://schemas.openxmlformats.org/drawingml/2006/main">
+              <a:ext uri="{FF2B5EF4-FFF2-40B4-BE49-F238E27FC236}">
+                <a16:creationId xmlns:a16="http://schemas.microsoft.com/office/drawing/2014/main" id="{4220A6B7-3EFB-43A1-A593-B07B135080FF}"/>
+              </a:ext>
+            </a:extLst>
+          </p:cNvPr>
+          <p:cNvSpPr>
+            <a:spLocks xmlns:a="http://schemas.openxmlformats.org/drawingml/2006/main" noGrp="1"/>
+          </p:cNvSpPr>
+          <p:nvPr/>
+        </p:nvSpPr>
+        <p:spPr>
+          <a:xfrm xmlns:a="http://schemas.openxmlformats.org/drawingml/2006/main">
+            <a:off x="8001000" y="3819525"/>
+            <a:ext cx="66675" cy="66675"/>
+          </a:xfrm>
+          <a:prstGeom xmlns:a="http://schemas.openxmlformats.org/drawingml/2006/main" prst="ellipse">
+            <a:avLst/>
+          </a:prstGeom>
+          <a:solidFill xmlns:a="http://schemas.openxmlformats.org/drawingml/2006/main">
+            <a:srgbClr val="2DD4BF"/>
+          </a:solidFill>
+          <a:ln xmlns:a="http://schemas.openxmlformats.org/drawingml/2006/main" w="0">
+            <a:noFill/>
+            <a:prstDash val="solid"/>
+          </a:ln>
+        </p:spPr>
+      </p:sp>
+      <p:sp>
+        <p:nvSpPr>
+          <p:cNvPr id="28" name="decision-2-0">
+            <a:extLst xmlns:a="http://schemas.openxmlformats.org/drawingml/2006/main">
+              <a:ext uri="{FF2B5EF4-FFF2-40B4-BE49-F238E27FC236}">
+                <a16:creationId xmlns:a16="http://schemas.microsoft.com/office/drawing/2014/main" id="{E5C90706-88F8-4FD5-BF5F-F295AD26D14A}"/>
+              </a:ext>
+            </a:extLst>
+          </p:cNvPr>
+          <p:cNvSpPr>
+            <a:spLocks xmlns:a="http://schemas.openxmlformats.org/drawingml/2006/main" noGrp="1"/>
+          </p:cNvSpPr>
+          <p:nvPr/>
+        </p:nvSpPr>
+        <p:spPr>
+          <a:xfrm xmlns:a="http://schemas.openxmlformats.org/drawingml/2006/main">
+            <a:off x="8191500" y="3733800"/>
+            <a:ext cx="2952750" cy="533400"/>
+          </a:xfrm>
+          <a:prstGeom xmlns:a="http://schemas.openxmlformats.org/drawingml/2006/main" prst="rect">
+            <a:avLst/>
+          </a:prstGeom>
+          <a:noFill xmlns:a="http://schemas.openxmlformats.org/drawingml/2006/main"/>
+          <a:ln xmlns:a="http://schemas.openxmlformats.org/drawingml/2006/main" w="0">
+            <a:noFill/>
+            <a:prstDash val="solid"/>
+          </a:ln>
+        </p:spPr>
+        <p:txBody>
+          <a:bodyPr xmlns:a="http://schemas.openxmlformats.org/drawingml/2006/main" wrap="square" lIns="0" tIns="0" rIns="0" bIns="0" anchor="t">
+            <a:noAutofit/>
+          </a:bodyPr>
+          <a:lstStyle xmlns:a="http://schemas.openxmlformats.org/drawingml/2006/main"/>
+          <a:p xmlns:a="http://schemas.openxmlformats.org/drawingml/2006/main">
+            <a:pPr algn="l">
+              <a:lnSpc>
+                <a:spcPct val="112000"/>
+              </a:lnSpc>
+              <a:buNone/>
+              <a:defRPr sz="1650" b="0">
+                <a:solidFill>
+                  <a:srgbClr val="EDF6F7"/>
+                </a:solidFill>
+                <a:latin typeface="Aptos"/>
+                <a:ea typeface="Aptos"/>
+                <a:cs typeface="Aptos"/>
+              </a:defRPr>
+            </a:pPr>
+            <a:r>
+              <a:rPr sz="1650" b="0">
+                <a:solidFill>
+                  <a:srgbClr val="EDF6F7"/>
+                </a:solidFill>
+                <a:latin typeface="Aptos"/>
+                <a:ea typeface="Aptos"/>
+                <a:cs typeface="Aptos"/>
+              </a:rPr>
+              <a:t>Second certified adapter</a:t>
+            </a:r>
+          </a:p>
+        </p:txBody>
+      </p:sp>
+      <p:sp>
+        <p:nvSpPr>
+          <p:cNvPr id="29" name="decision-2-1-dot">
+            <a:extLst xmlns:a="http://schemas.openxmlformats.org/drawingml/2006/main">
+              <a:ext uri="{FF2B5EF4-FFF2-40B4-BE49-F238E27FC236}">
+                <a16:creationId xmlns:a16="http://schemas.microsoft.com/office/drawing/2014/main" id="{57D0565C-60F1-4E5B-B6F6-5979A902F611}"/>
+              </a:ext>
+            </a:extLst>
+          </p:cNvPr>
+          <p:cNvSpPr>
+            <a:spLocks xmlns:a="http://schemas.openxmlformats.org/drawingml/2006/main" noGrp="1"/>
+          </p:cNvSpPr>
+          <p:nvPr/>
+        </p:nvSpPr>
+        <p:spPr>
+          <a:xfrm xmlns:a="http://schemas.openxmlformats.org/drawingml/2006/main">
+            <a:off x="8001000" y="4391025"/>
+            <a:ext cx="66675" cy="66675"/>
+          </a:xfrm>
+          <a:prstGeom xmlns:a="http://schemas.openxmlformats.org/drawingml/2006/main" prst="ellipse">
+            <a:avLst/>
+          </a:prstGeom>
+          <a:solidFill xmlns:a="http://schemas.openxmlformats.org/drawingml/2006/main">
+            <a:srgbClr val="2DD4BF"/>
+          </a:solidFill>
+          <a:ln xmlns:a="http://schemas.openxmlformats.org/drawingml/2006/main" w="0">
+            <a:noFill/>
+            <a:prstDash val="solid"/>
+          </a:ln>
+        </p:spPr>
+      </p:sp>
+      <p:sp>
+        <p:nvSpPr>
+          <p:cNvPr id="30" name="decision-2-1">
+            <a:extLst xmlns:a="http://schemas.openxmlformats.org/drawingml/2006/main">
+              <a:ext uri="{FF2B5EF4-FFF2-40B4-BE49-F238E27FC236}">
+                <a16:creationId xmlns:a16="http://schemas.microsoft.com/office/drawing/2014/main" id="{93AC8937-A825-4CD3-8805-D56B0BD21948}"/>
+              </a:ext>
+            </a:extLst>
+          </p:cNvPr>
+          <p:cNvSpPr>
+            <a:spLocks xmlns:a="http://schemas.openxmlformats.org/drawingml/2006/main" noGrp="1"/>
+          </p:cNvSpPr>
+          <p:nvPr/>
+        </p:nvSpPr>
+        <p:spPr>
+          <a:xfrm xmlns:a="http://schemas.openxmlformats.org/drawingml/2006/main">
+            <a:off x="8191500" y="4305300"/>
+            <a:ext cx="2952750" cy="533400"/>
+          </a:xfrm>
+          <a:prstGeom xmlns:a="http://schemas.openxmlformats.org/drawingml/2006/main" prst="rect">
+            <a:avLst/>
+          </a:prstGeom>
+          <a:noFill xmlns:a="http://schemas.openxmlformats.org/drawingml/2006/main"/>
+          <a:ln xmlns:a="http://schemas.openxmlformats.org/drawingml/2006/main" w="0">
+            <a:noFill/>
+            <a:prstDash val="solid"/>
+          </a:ln>
+        </p:spPr>
+        <p:txBody>
+          <a:bodyPr xmlns:a="http://schemas.openxmlformats.org/drawingml/2006/main" wrap="square" lIns="0" tIns="0" rIns="0" bIns="0" anchor="t">
+            <a:noAutofit/>
+          </a:bodyPr>
+          <a:lstStyle xmlns:a="http://schemas.openxmlformats.org/drawingml/2006/main"/>
+          <a:p xmlns:a="http://schemas.openxmlformats.org/drawingml/2006/main">
+            <a:pPr algn="l">
+              <a:lnSpc>
+                <a:spcPct val="112000"/>
+              </a:lnSpc>
+              <a:buNone/>
+              <a:defRPr sz="1650" b="0">
+                <a:solidFill>
+                  <a:srgbClr val="EDF6F7"/>
+                </a:solidFill>
+                <a:latin typeface="Aptos"/>
+                <a:ea typeface="Aptos"/>
+                <a:cs typeface="Aptos"/>
+              </a:defRPr>
+            </a:pPr>
+            <a:r>
+              <a:rPr sz="1650" b="0">
+                <a:solidFill>
+                  <a:srgbClr val="EDF6F7"/>
+                </a:solidFill>
+                <a:latin typeface="Aptos"/>
+                <a:ea typeface="Aptos"/>
+                <a:cs typeface="Aptos"/>
+              </a:rPr>
+              <a:t>Community conformance kit</a:t>
+            </a:r>
+          </a:p>
+        </p:txBody>
+      </p:sp>
+      <p:sp>
+        <p:nvSpPr>
+          <p:cNvPr id="31" name="decision-2-2-dot">
+            <a:extLst xmlns:a="http://schemas.openxmlformats.org/drawingml/2006/main">
+              <a:ext uri="{FF2B5EF4-FFF2-40B4-BE49-F238E27FC236}">
+                <a16:creationId xmlns:a16="http://schemas.microsoft.com/office/drawing/2014/main" id="{522DC31E-2C5C-490C-A78D-D70433E9732A}"/>
+              </a:ext>
+            </a:extLst>
+          </p:cNvPr>
+          <p:cNvSpPr>
+            <a:spLocks xmlns:a="http://schemas.openxmlformats.org/drawingml/2006/main" noGrp="1"/>
+          </p:cNvSpPr>
+          <p:nvPr/>
+        </p:nvSpPr>
+        <p:spPr>
+          <a:xfrm xmlns:a="http://schemas.openxmlformats.org/drawingml/2006/main">
+            <a:off x="8001000" y="4962525"/>
+            <a:ext cx="66675" cy="66675"/>
+          </a:xfrm>
+          <a:prstGeom xmlns:a="http://schemas.openxmlformats.org/drawingml/2006/main" prst="ellipse">
+            <a:avLst/>
+          </a:prstGeom>
+          <a:solidFill xmlns:a="http://schemas.openxmlformats.org/drawingml/2006/main">
+            <a:srgbClr val="2DD4BF"/>
+          </a:solidFill>
+          <a:ln xmlns:a="http://schemas.openxmlformats.org/drawingml/2006/main" w="0">
+            <a:noFill/>
+            <a:prstDash val="solid"/>
+          </a:ln>
+        </p:spPr>
+      </p:sp>
+      <p:sp>
+        <p:nvSpPr>
+          <p:cNvPr id="32" name="decision-2-2">
+            <a:extLst xmlns:a="http://schemas.openxmlformats.org/drawingml/2006/main">
+              <a:ext uri="{FF2B5EF4-FFF2-40B4-BE49-F238E27FC236}">
+                <a16:creationId xmlns:a16="http://schemas.microsoft.com/office/drawing/2014/main" id="{3D94860B-328D-4B3A-A713-FD2E3416F661}"/>
+              </a:ext>
+            </a:extLst>
+          </p:cNvPr>
+          <p:cNvSpPr>
+            <a:spLocks xmlns:a="http://schemas.openxmlformats.org/drawingml/2006/main" noGrp="1"/>
+          </p:cNvSpPr>
+          <p:nvPr/>
+        </p:nvSpPr>
+        <p:spPr>
+          <a:xfrm xmlns:a="http://schemas.openxmlformats.org/drawingml/2006/main">
+            <a:off x="8191500" y="4876800"/>
+            <a:ext cx="2952750" cy="533400"/>
+          </a:xfrm>
+          <a:prstGeom xmlns:a="http://schemas.openxmlformats.org/drawingml/2006/main" prst="rect">
+            <a:avLst/>
+          </a:prstGeom>
+          <a:noFill xmlns:a="http://schemas.openxmlformats.org/drawingml/2006/main"/>
+          <a:ln xmlns:a="http://schemas.openxmlformats.org/drawingml/2006/main" w="0">
+            <a:noFill/>
+            <a:prstDash val="solid"/>
+          </a:ln>
+        </p:spPr>
+        <p:txBody>
+          <a:bodyPr xmlns:a="http://schemas.openxmlformats.org/drawingml/2006/main" wrap="square" lIns="0" tIns="0" rIns="0" bIns="0" anchor="t">
+            <a:noAutofit/>
+          </a:bodyPr>
+          <a:lstStyle xmlns:a="http://schemas.openxmlformats.org/drawingml/2006/main"/>
+          <a:p xmlns:a="http://schemas.openxmlformats.org/drawingml/2006/main">
+            <a:pPr algn="l">
+              <a:lnSpc>
+                <a:spcPct val="112000"/>
+              </a:lnSpc>
+              <a:buNone/>
+              <a:defRPr sz="1650" b="0">
+                <a:solidFill>
+                  <a:srgbClr val="EDF6F7"/>
+                </a:solidFill>
+                <a:latin typeface="Aptos"/>
+                <a:ea typeface="Aptos"/>
+                <a:cs typeface="Aptos"/>
+              </a:defRPr>
+            </a:pPr>
+            <a:r>
+              <a:rPr sz="1650" b="0">
+                <a:solidFill>
+                  <a:srgbClr val="EDF6F7"/>
+                </a:solidFill>
+                <a:latin typeface="Aptos"/>
+                <a:ea typeface="Aptos"/>
+                <a:cs typeface="Aptos"/>
+              </a:rPr>
+              <a:t>Pilot case study + SBOM</a:t>
+            </a:r>
+          </a:p>
+        </p:txBody>
+      </p:sp>
+      <p:sp>
+        <p:nvSpPr>
+          <p:cNvPr id="33" name="decision-callout">
+            <a:extLst xmlns:a="http://schemas.openxmlformats.org/drawingml/2006/main">
+              <a:ext uri="{FF2B5EF4-FFF2-40B4-BE49-F238E27FC236}">
+                <a16:creationId xmlns:a16="http://schemas.microsoft.com/office/drawing/2014/main" id="{974E09E0-C6BE-4454-9334-85B251BC9C2D}"/>
+              </a:ext>
+            </a:extLst>
+          </p:cNvPr>
+          <p:cNvSpPr>
+            <a:spLocks xmlns:a="http://schemas.openxmlformats.org/drawingml/2006/main" noGrp="1"/>
+          </p:cNvSpPr>
+          <p:nvPr/>
+        </p:nvSpPr>
+        <p:spPr>
+          <a:xfrm xmlns:a="http://schemas.openxmlformats.org/drawingml/2006/main">
+            <a:off x="609600" y="5676900"/>
+            <a:ext cx="10972800" cy="685800"/>
+          </a:xfrm>
+          <a:prstGeom xmlns:a="http://schemas.openxmlformats.org/drawingml/2006/main" prst="roundRect">
+            <a:avLst>
+              <a:gd name="adj" fmla="val 16667"/>
+            </a:avLst>
+          </a:prstGeom>
+          <a:solidFill xmlns:a="http://schemas.openxmlformats.org/drawingml/2006/main">
+            <a:srgbClr val="103B3B"/>
+          </a:solidFill>
+          <a:ln xmlns:a="http://schemas.openxmlformats.org/drawingml/2006/main" w="9525">
+            <a:solidFill>
+              <a:srgbClr val="1D615D"/>
+            </a:solidFill>
+            <a:prstDash val="solid"/>
+          </a:ln>
+        </p:spPr>
+      </p:sp>
+      <p:sp>
+        <p:nvSpPr>
+          <p:cNvPr id="34" name="decision-callout-text">
+            <a:extLst xmlns:a="http://schemas.openxmlformats.org/drawingml/2006/main">
+              <a:ext uri="{FF2B5EF4-FFF2-40B4-BE49-F238E27FC236}">
+                <a16:creationId xmlns:a16="http://schemas.microsoft.com/office/drawing/2014/main" id="{600489BF-E3C0-41B7-800E-BC16AAA15391}"/>
+              </a:ext>
+            </a:extLst>
+          </p:cNvPr>
+          <p:cNvSpPr>
+            <a:spLocks xmlns:a="http://schemas.openxmlformats.org/drawingml/2006/main" noGrp="1"/>
+          </p:cNvSpPr>
+          <p:nvPr/>
+        </p:nvSpPr>
+        <p:spPr>
+          <a:xfrm xmlns:a="http://schemas.openxmlformats.org/drawingml/2006/main">
+            <a:off x="876300" y="5876925"/>
+            <a:ext cx="10287000" cy="285750"/>
+          </a:xfrm>
+          <a:prstGeom xmlns:a="http://schemas.openxmlformats.org/drawingml/2006/main" prst="rect">
+            <a:avLst/>
+          </a:prstGeom>
+          <a:noFill xmlns:a="http://schemas.openxmlformats.org/drawingml/2006/main"/>
+          <a:ln xmlns:a="http://schemas.openxmlformats.org/drawingml/2006/main" w="0">
+            <a:noFill/>
+            <a:prstDash val="solid"/>
+          </a:ln>
+        </p:spPr>
+        <p:txBody>
+          <a:bodyPr xmlns:a="http://schemas.openxmlformats.org/drawingml/2006/main" wrap="square" lIns="0" tIns="0" rIns="0" bIns="0" anchor="t">
+            <a:noAutofit/>
+          </a:bodyPr>
+          <a:lstStyle xmlns:a="http://schemas.openxmlformats.org/drawingml/2006/main"/>
+          <a:p xmlns:a="http://schemas.openxmlformats.org/drawingml/2006/main">
+            <a:pPr algn="ctr">
+              <a:lnSpc>
+                <a:spcPct val="108000"/>
+              </a:lnSpc>
+              <a:buNone/>
+              <a:defRPr sz="1800" b="1">
+                <a:solidFill>
+                  <a:srgbClr val="EDF6F7"/>
+                </a:solidFill>
+                <a:latin typeface="Aptos"/>
+                <a:ea typeface="Aptos"/>
+                <a:cs typeface="Aptos"/>
+              </a:defRPr>
+            </a:pPr>
+            <a:r>
+              <a:rPr sz="1800" b="1">
+                <a:solidFill>
+                  <a:srgbClr val="EDF6F7"/>
+                </a:solidFill>
+                <a:latin typeface="Aptos"/>
+                <a:ea typeface="Aptos"/>
+                <a:cs typeface="Aptos"/>
+              </a:rPr>
+              <a:t>Scale after independent install, isolation, drift, and revocation evidence.</a:t>
             </a:r>
           </a:p>
         </p:txBody>
@@ -19561,7 +21419,7 @@
           <p:nvPr/>
         </p:nvPicPr>
         <p:blipFill>
-          <a:blip xmlns:r="http://schemas.openxmlformats.org/officeDocument/2006/relationships" xmlns:a="http://schemas.openxmlformats.org/drawingml/2006/main" r:embed="R39e3e3b2ea8547bb"/>
+          <a:blip xmlns:r="http://schemas.openxmlformats.org/officeDocument/2006/relationships" xmlns:a="http://schemas.openxmlformats.org/drawingml/2006/main" r:embed="R8f0dfc06162848f1"/>
           <a:srcRect xmlns:a="http://schemas.openxmlformats.org/drawingml/2006/main" l="0" t="0" r="0" b="0"/>
           <a:stretch xmlns:a="http://schemas.openxmlformats.org/drawingml/2006/main">
             <a:fillRect l="0" t="0" r="0" b="0"/>
@@ -19627,7 +21485,7 @@
           <p:nvPr/>
         </p:nvPicPr>
         <p:blipFill>
-          <a:blip xmlns:r="http://schemas.openxmlformats.org/officeDocument/2006/relationships" xmlns:a="http://schemas.openxmlformats.org/drawingml/2006/main" r:embed="R4d39c450e25d4870"/>
+          <a:blip xmlns:r="http://schemas.openxmlformats.org/officeDocument/2006/relationships" xmlns:a="http://schemas.openxmlformats.org/drawingml/2006/main" r:embed="Rf6e536fda6cb453d"/>
           <a:srcRect xmlns:a="http://schemas.openxmlformats.org/drawingml/2006/main" l="0" t="11766" r="0" b="11766"/>
           <a:stretch xmlns:a="http://schemas.openxmlformats.org/drawingml/2006/main">
             <a:fillRect l="0" t="0" r="0" b="0"/>

</xml_diff>